<commit_message>
docs: add document intelligence to conference story
</commit_message>
<xml_diff>
--- a/conference/HelpdeskAI-Kolkata-2026.pptx
+++ b/conference/HelpdeskAI-Kolkata-2026.pptx
@@ -1,5 +1,1568 @@
 
-<file path=ppt/presentation.xml><?xml version="1.0" encoding="utf-8"?>
+<file path=docProps\app.xml><?xml version="1.0" encoding="utf-8"?>
+<Properties xmlns="http://schemas.openxmlformats.org/officeDocument/2006/extended-properties" xmlns:vt="http://schemas.openxmlformats.org/officeDocument/2006/docPropsVTypes">
+  <TotalTime>32</TotalTime>
+  <Words>2224</Words>
+  <Application>Microsoft Office PowerPoint</Application>
+  <PresentationFormat>On-screen Show (16:9)</PresentationFormat>
+  <Paragraphs>265</Paragraphs>
+  <Slides>16</Slides>
+  <Notes>16</Notes>
+  <HiddenSlides>0</HiddenSlides>
+  <MMClips>0</MMClips>
+  <ScaleCrop>false</ScaleCrop>
+  <HeadingPairs>
+    <vt:vector size="6" baseType="variant">
+      <vt:variant>
+        <vt:lpstr>Fonts Used</vt:lpstr>
+      </vt:variant>
+      <vt:variant>
+        <vt:i4>3</vt:i4>
+      </vt:variant>
+      <vt:variant>
+        <vt:lpstr>Theme</vt:lpstr>
+      </vt:variant>
+      <vt:variant>
+        <vt:i4>1</vt:i4>
+      </vt:variant>
+      <vt:variant>
+        <vt:lpstr>Slide Titles</vt:lpstr>
+      </vt:variant>
+      <vt:variant>
+        <vt:i4>16</vt:i4>
+      </vt:variant>
+    </vt:vector>
+  </HeadingPairs>
+  <TitlesOfParts>
+    <vt:vector size="20" baseType="lpstr">
+      <vt:lpstr>Arial</vt:lpstr>
+      <vt:lpstr>Calibri</vt:lpstr>
+      <vt:lpstr>Consolas</vt:lpstr>
+      <vt:lpstr>Office Theme</vt:lpstr>
+      <vt:lpstr>PowerPoint Presentation</vt:lpstr>
+      <vt:lpstr>PowerPoint Presentation</vt:lpstr>
+      <vt:lpstr>PowerPoint Presentation</vt:lpstr>
+      <vt:lpstr>PowerPoint Presentation</vt:lpstr>
+      <vt:lpstr>PowerPoint Presentation</vt:lpstr>
+      <vt:lpstr>PowerPoint Presentation</vt:lpstr>
+      <vt:lpstr>PowerPoint Presentation</vt:lpstr>
+      <vt:lpstr>PowerPoint Presentation</vt:lpstr>
+      <vt:lpstr>PowerPoint Presentation</vt:lpstr>
+      <vt:lpstr>PowerPoint Presentation</vt:lpstr>
+      <vt:lpstr>PowerPoint Presentation</vt:lpstr>
+      <vt:lpstr>PowerPoint Presentation</vt:lpstr>
+      <vt:lpstr>PowerPoint Presentation</vt:lpstr>
+      <vt:lpstr>PowerPoint Presentation</vt:lpstr>
+      <vt:lpstr>PowerPoint Presentation</vt:lpstr>
+      <vt:lpstr>PowerPoint Presentation</vt:lpstr>
+    </vt:vector>
+  </TitlesOfParts>
+  <Company>PptxGenJS</Company>
+  <LinksUpToDate>false</LinksUpToDate>
+  <SharedDoc>false</SharedDoc>
+  <HyperlinksChanged>false</HyperlinksChanged>
+  <AppVersion>16.0000</AppVersion>
+</Properties>
+</file>
+
+<file path=docProps\core.xml><?xml version="1.0" encoding="utf-8"?>
+<cp:coreProperties xmlns:cp="http://schemas.openxmlformats.org/package/2006/metadata/core-properties" xmlns:dc="http://purl.org/dc/elements/1.1/" xmlns:dcterms="http://purl.org/dc/terms/" xmlns:dcmitype="http://purl.org/dc/dcmitype/" xmlns:xsi="http://www.w3.org/2001/XMLSchema-instance">
+  <dc:title>Building Production Multi-Agent Systems with MAF</dc:title>
+  <dc:subject>PptxGenJS Presentation</dc:subject>
+  <dc:creator>PptxGenJS</dc:creator>
+  <cp:lastModifiedBy>Choudhury, Sreyan</cp:lastModifiedBy>
+  <cp:revision>2</cp:revision>
+  <dcterms:created xsi:type="dcterms:W3CDTF">2026-04-03T14:22:34Z</dcterms:created>
+  <dcterms:modified xsi:type="dcterms:W3CDTF">2026-04-03T14:57:20Z</dcterms:modified>
+</cp:coreProperties>
+</file>
+
+<file path=ppt\notesMasters\notesMaster1.xml><?xml version="1.0" encoding="utf-8"?>
+<p:notesMaster xmlns:a="http://schemas.openxmlformats.org/drawingml/2006/main" xmlns:r="http://schemas.openxmlformats.org/officeDocument/2006/relationships" xmlns:p="http://schemas.openxmlformats.org/presentationml/2006/main">
+  <p:cSld>
+    <p:bg>
+      <p:bgRef idx="1001">
+        <a:schemeClr val="bg1"/>
+      </p:bgRef>
+    </p:bg>
+    <p:spTree>
+      <p:nvGrpSpPr>
+        <p:cNvPr id="1" name=""/>
+        <p:cNvGrpSpPr/>
+        <p:nvPr/>
+      </p:nvGrpSpPr>
+      <p:grpSpPr>
+        <a:xfrm>
+          <a:off x="0" y="0"/>
+          <a:ext cx="0" cy="0"/>
+          <a:chOff x="0" y="0"/>
+          <a:chExt cx="0" cy="0"/>
+        </a:xfrm>
+      </p:grpSpPr>
+    </p:spTree>
+    <p:extLst>
+      <p:ext uri="{BB962C8B-B14F-4D97-AF65-F5344CB8AC3E}">
+        <p14:creationId xmlns:p14="http://schemas.microsoft.com/office/powerpoint/2010/main" val="776189880"/>
+      </p:ext>
+    </p:extLst>
+  </p:cSld>
+  <p:clrMap bg1="lt1" tx1="dk1" bg2="lt2" tx2="dk2" accent1="accent1" accent2="accent2" accent3="accent3" accent4="accent4" accent5="accent5" accent6="accent6" hlink="hlink" folHlink="folHlink"/>
+  <p:notesStyle>
+    <a:lvl1pPr marL="0" algn="l" defTabSz="914400" rtl="0" eaLnBrk="1" latinLnBrk="0" hangingPunct="1">
+      <a:defRPr sz="1200" kern="1200">
+        <a:solidFill>
+          <a:schemeClr val="tx1"/>
+        </a:solidFill>
+        <a:latin typeface="+mn-lt"/>
+        <a:ea typeface="+mn-ea"/>
+        <a:cs typeface="+mn-cs"/>
+      </a:defRPr>
+    </a:lvl1pPr>
+    <a:lvl2pPr marL="457200" algn="l" defTabSz="914400" rtl="0" eaLnBrk="1" latinLnBrk="0" hangingPunct="1">
+      <a:defRPr sz="1200" kern="1200">
+        <a:solidFill>
+          <a:schemeClr val="tx1"/>
+        </a:solidFill>
+        <a:latin typeface="+mn-lt"/>
+        <a:ea typeface="+mn-ea"/>
+        <a:cs typeface="+mn-cs"/>
+      </a:defRPr>
+    </a:lvl2pPr>
+    <a:lvl3pPr marL="914400" algn="l" defTabSz="914400" rtl="0" eaLnBrk="1" latinLnBrk="0" hangingPunct="1">
+      <a:defRPr sz="1200" kern="1200">
+        <a:solidFill>
+          <a:schemeClr val="tx1"/>
+        </a:solidFill>
+        <a:latin typeface="+mn-lt"/>
+        <a:ea typeface="+mn-ea"/>
+        <a:cs typeface="+mn-cs"/>
+      </a:defRPr>
+    </a:lvl3pPr>
+    <a:lvl4pPr marL="1371600" algn="l" defTabSz="914400" rtl="0" eaLnBrk="1" latinLnBrk="0" hangingPunct="1">
+      <a:defRPr sz="1200" kern="1200">
+        <a:solidFill>
+          <a:schemeClr val="tx1"/>
+        </a:solidFill>
+        <a:latin typeface="+mn-lt"/>
+        <a:ea typeface="+mn-ea"/>
+        <a:cs typeface="+mn-cs"/>
+      </a:defRPr>
+    </a:lvl4pPr>
+    <a:lvl5pPr marL="1828800" algn="l" defTabSz="914400" rtl="0" eaLnBrk="1" latinLnBrk="0" hangingPunct="1">
+      <a:defRPr sz="1200" kern="1200">
+        <a:solidFill>
+          <a:schemeClr val="tx1"/>
+        </a:solidFill>
+        <a:latin typeface="+mn-lt"/>
+        <a:ea typeface="+mn-ea"/>
+        <a:cs typeface="+mn-cs"/>
+      </a:defRPr>
+    </a:lvl5pPr>
+    <a:lvl6pPr marL="2286000" algn="l" defTabSz="914400" rtl="0" eaLnBrk="1" latinLnBrk="0" hangingPunct="1">
+      <a:defRPr sz="1200" kern="1200">
+        <a:solidFill>
+          <a:schemeClr val="tx1"/>
+        </a:solidFill>
+        <a:latin typeface="+mn-lt"/>
+        <a:ea typeface="+mn-ea"/>
+        <a:cs typeface="+mn-cs"/>
+      </a:defRPr>
+    </a:lvl6pPr>
+    <a:lvl7pPr marL="2743200" algn="l" defTabSz="914400" rtl="0" eaLnBrk="1" latinLnBrk="0" hangingPunct="1">
+      <a:defRPr sz="1200" kern="1200">
+        <a:solidFill>
+          <a:schemeClr val="tx1"/>
+        </a:solidFill>
+        <a:latin typeface="+mn-lt"/>
+        <a:ea typeface="+mn-ea"/>
+        <a:cs typeface="+mn-cs"/>
+      </a:defRPr>
+    </a:lvl7pPr>
+    <a:lvl8pPr marL="3200400" algn="l" defTabSz="914400" rtl="0" eaLnBrk="1" latinLnBrk="0" hangingPunct="1">
+      <a:defRPr sz="1200" kern="1200">
+        <a:solidFill>
+          <a:schemeClr val="tx1"/>
+        </a:solidFill>
+        <a:latin typeface="+mn-lt"/>
+        <a:ea typeface="+mn-ea"/>
+        <a:cs typeface="+mn-cs"/>
+      </a:defRPr>
+    </a:lvl8pPr>
+    <a:lvl9pPr marL="3657600" algn="l" defTabSz="914400" rtl="0" eaLnBrk="1" latinLnBrk="0" hangingPunct="1">
+      <a:defRPr sz="1200" kern="1200">
+        <a:solidFill>
+          <a:schemeClr val="tx1"/>
+        </a:solidFill>
+        <a:latin typeface="+mn-lt"/>
+        <a:ea typeface="+mn-ea"/>
+        <a:cs typeface="+mn-cs"/>
+      </a:defRPr>
+    </a:lvl9pPr>
+  </p:notesStyle>
+</p:notesMaster>
+</file>
+
+<file path=ppt\notesSlides\notesSlide1.xml><?xml version="1.0" encoding="utf-8"?>
+<p:notes xmlns:a="http://schemas.openxmlformats.org/drawingml/2006/main" xmlns:r="http://schemas.openxmlformats.org/officeDocument/2006/relationships" xmlns:p="http://schemas.openxmlformats.org/presentationml/2006/main">
+  <p:cSld>
+    <p:spTree>
+      <p:nvGrpSpPr>
+        <p:cNvPr id="1" name=""/>
+        <p:cNvGrpSpPr/>
+        <p:nvPr/>
+      </p:nvGrpSpPr>
+      <p:grpSpPr>
+        <a:xfrm>
+          <a:off x="0" y="0"/>
+          <a:ext cx="0" cy="0"/>
+          <a:chOff x="0" y="0"/>
+          <a:chExt cx="0" cy="0"/>
+        </a:xfrm>
+      </p:grpSpPr>
+      <p:sp>
+        <p:nvSpPr>
+          <p:cNvPr id="2" name="Slide Image Placeholder 1"/>
+          <p:cNvSpPr>
+            <a:spLocks noGrp="1" noRot="1" noChangeAspect="1"/>
+          </p:cNvSpPr>
+          <p:nvPr>
+            <p:ph type="sldImg"/>
+          </p:nvPr>
+        </p:nvSpPr>
+        <p:spPr/>
+      </p:sp>
+      <p:sp>
+        <p:nvSpPr>
+          <p:cNvPr id="3" name="Notes Placeholder 2"/>
+          <p:cNvSpPr>
+            <a:spLocks noGrp="1"/>
+          </p:cNvSpPr>
+          <p:nvPr>
+            <p:ph type="body" idx="1"/>
+          </p:nvPr>
+        </p:nvSpPr>
+        <p:spPr/>
+        <p:txBody>
+          <a:bodyPr/>
+          <a:lstStyle/>
+          <a:p>
+            <a:endParaRPr lang="en-US" dirty="0"/>
+          </a:p>
+        </p:txBody>
+      </p:sp>
+      <p:sp>
+        <p:nvSpPr>
+          <p:cNvPr id="4" name="Slide Number Placeholder 3"/>
+          <p:cNvSpPr>
+            <a:spLocks noGrp="1"/>
+          </p:cNvSpPr>
+          <p:nvPr>
+            <p:ph type="sldNum" sz="quarter" idx="10"/>
+          </p:nvPr>
+        </p:nvSpPr>
+        <p:spPr/>
+        <p:txBody>
+          <a:bodyPr/>
+          <a:lstStyle/>
+          <a:p>
+            <a:fld id="{F7021451-1387-4CA6-816F-3879F97B5CBC}" type="slidenum">
+              <a:rPr lang="en-US"/>
+              <a:t>1</a:t>
+            </a:fld>
+            <a:endParaRPr lang="en-US"/>
+          </a:p>
+        </p:txBody>
+      </p:sp>
+    </p:spTree>
+    <p:extLst>
+      <p:ext uri="{BB962C8B-B14F-4D97-AF65-F5344CB8AC3E}">
+        <p14:creationId xmlns:p14="http://schemas.microsoft.com/office/powerpoint/2010/main" val="1024086991"/>
+      </p:ext>
+    </p:extLst>
+  </p:cSld>
+  <p:clrMapOvr>
+    <a:masterClrMapping/>
+  </p:clrMapOvr>
+</p:notes>
+</file>
+
+<file path=ppt\notesSlides\notesSlide10.xml><?xml version="1.0" encoding="utf-8"?>
+<p:notes xmlns:a="http://schemas.openxmlformats.org/drawingml/2006/main" xmlns:r="http://schemas.openxmlformats.org/officeDocument/2006/relationships" xmlns:p="http://schemas.openxmlformats.org/presentationml/2006/main">
+  <p:cSld>
+    <p:spTree>
+      <p:nvGrpSpPr>
+        <p:cNvPr id="1" name=""/>
+        <p:cNvGrpSpPr/>
+        <p:nvPr/>
+      </p:nvGrpSpPr>
+      <p:grpSpPr>
+        <a:xfrm>
+          <a:off x="0" y="0"/>
+          <a:ext cx="0" cy="0"/>
+          <a:chOff x="0" y="0"/>
+          <a:chExt cx="0" cy="0"/>
+        </a:xfrm>
+      </p:grpSpPr>
+      <p:sp>
+        <p:nvSpPr>
+          <p:cNvPr id="2" name="Slide Image Placeholder 1"/>
+          <p:cNvSpPr>
+            <a:spLocks noGrp="1" noRot="1" noChangeAspect="1"/>
+          </p:cNvSpPr>
+          <p:nvPr>
+            <p:ph type="sldImg"/>
+          </p:nvPr>
+        </p:nvSpPr>
+        <p:spPr/>
+      </p:sp>
+      <p:sp>
+        <p:nvSpPr>
+          <p:cNvPr id="3" name="Notes Placeholder 2"/>
+          <p:cNvSpPr>
+            <a:spLocks noGrp="1"/>
+          </p:cNvSpPr>
+          <p:nvPr>
+            <p:ph type="body" idx="1"/>
+          </p:nvPr>
+        </p:nvSpPr>
+        <p:spPr/>
+        <p:txBody>
+          <a:bodyPr/>
+          <a:lstStyle/>
+          <a:p>
+            <a:endParaRPr lang="en-US" dirty="0"/>
+          </a:p>
+        </p:txBody>
+      </p:sp>
+      <p:sp>
+        <p:nvSpPr>
+          <p:cNvPr id="4" name="Slide Number Placeholder 3"/>
+          <p:cNvSpPr>
+            <a:spLocks noGrp="1"/>
+          </p:cNvSpPr>
+          <p:nvPr>
+            <p:ph type="sldNum" sz="quarter" idx="10"/>
+          </p:nvPr>
+        </p:nvSpPr>
+        <p:spPr/>
+        <p:txBody>
+          <a:bodyPr/>
+          <a:lstStyle/>
+          <a:p>
+            <a:fld id="{F7021451-1387-4CA6-816F-3879F97B5CBC}" type="slidenum">
+              <a:rPr lang="en-US"/>
+              <a:t>10</a:t>
+            </a:fld>
+            <a:endParaRPr lang="en-US"/>
+          </a:p>
+        </p:txBody>
+      </p:sp>
+    </p:spTree>
+    <p:extLst>
+      <p:ext uri="{BB962C8B-B14F-4D97-AF65-F5344CB8AC3E}">
+        <p14:creationId xmlns:p14="http://schemas.microsoft.com/office/powerpoint/2010/main" val="1024086991"/>
+      </p:ext>
+    </p:extLst>
+  </p:cSld>
+  <p:clrMapOvr>
+    <a:masterClrMapping/>
+  </p:clrMapOvr>
+</p:notes>
+</file>
+
+<file path=ppt\notesSlides\notesSlide11.xml><?xml version="1.0" encoding="utf-8"?>
+<p:notes xmlns:a="http://schemas.openxmlformats.org/drawingml/2006/main" xmlns:r="http://schemas.openxmlformats.org/officeDocument/2006/relationships" xmlns:p="http://schemas.openxmlformats.org/presentationml/2006/main">
+  <p:cSld>
+    <p:spTree>
+      <p:nvGrpSpPr>
+        <p:cNvPr id="1" name=""/>
+        <p:cNvGrpSpPr/>
+        <p:nvPr/>
+      </p:nvGrpSpPr>
+      <p:grpSpPr>
+        <a:xfrm>
+          <a:off x="0" y="0"/>
+          <a:ext cx="0" cy="0"/>
+          <a:chOff x="0" y="0"/>
+          <a:chExt cx="0" cy="0"/>
+        </a:xfrm>
+      </p:grpSpPr>
+      <p:sp>
+        <p:nvSpPr>
+          <p:cNvPr id="2" name="Slide Image Placeholder 1"/>
+          <p:cNvSpPr>
+            <a:spLocks noGrp="1" noRot="1" noChangeAspect="1"/>
+          </p:cNvSpPr>
+          <p:nvPr>
+            <p:ph type="sldImg"/>
+          </p:nvPr>
+        </p:nvSpPr>
+        <p:spPr/>
+      </p:sp>
+      <p:sp>
+        <p:nvSpPr>
+          <p:cNvPr id="3" name="Notes Placeholder 2"/>
+          <p:cNvSpPr>
+            <a:spLocks noGrp="1"/>
+          </p:cNvSpPr>
+          <p:nvPr>
+            <p:ph type="body" idx="1"/>
+          </p:nvPr>
+        </p:nvSpPr>
+        <p:spPr/>
+        <p:txBody>
+          <a:bodyPr/>
+          <a:lstStyle/>
+          <a:p>
+            <a:endParaRPr lang="en-US" dirty="0"/>
+          </a:p>
+        </p:txBody>
+      </p:sp>
+      <p:sp>
+        <p:nvSpPr>
+          <p:cNvPr id="4" name="Slide Number Placeholder 3"/>
+          <p:cNvSpPr>
+            <a:spLocks noGrp="1"/>
+          </p:cNvSpPr>
+          <p:nvPr>
+            <p:ph type="sldNum" sz="quarter" idx="10"/>
+          </p:nvPr>
+        </p:nvSpPr>
+        <p:spPr/>
+        <p:txBody>
+          <a:bodyPr/>
+          <a:lstStyle/>
+          <a:p>
+            <a:fld id="{F7021451-1387-4CA6-816F-3879F97B5CBC}" type="slidenum">
+              <a:rPr lang="en-US"/>
+              <a:t>11</a:t>
+            </a:fld>
+            <a:endParaRPr lang="en-US"/>
+          </a:p>
+        </p:txBody>
+      </p:sp>
+    </p:spTree>
+    <p:extLst>
+      <p:ext uri="{BB962C8B-B14F-4D97-AF65-F5344CB8AC3E}">
+        <p14:creationId xmlns:p14="http://schemas.microsoft.com/office/powerpoint/2010/main" val="1024086991"/>
+      </p:ext>
+    </p:extLst>
+  </p:cSld>
+  <p:clrMapOvr>
+    <a:masterClrMapping/>
+  </p:clrMapOvr>
+</p:notes>
+</file>
+
+<file path=ppt\notesSlides\notesSlide12.xml><?xml version="1.0" encoding="utf-8"?>
+<p:notes xmlns:a="http://schemas.openxmlformats.org/drawingml/2006/main" xmlns:r="http://schemas.openxmlformats.org/officeDocument/2006/relationships" xmlns:p="http://schemas.openxmlformats.org/presentationml/2006/main">
+  <p:cSld>
+    <p:spTree>
+      <p:nvGrpSpPr>
+        <p:cNvPr id="1" name=""/>
+        <p:cNvGrpSpPr/>
+        <p:nvPr/>
+      </p:nvGrpSpPr>
+      <p:grpSpPr>
+        <a:xfrm>
+          <a:off x="0" y="0"/>
+          <a:ext cx="0" cy="0"/>
+          <a:chOff x="0" y="0"/>
+          <a:chExt cx="0" cy="0"/>
+        </a:xfrm>
+      </p:grpSpPr>
+      <p:sp>
+        <p:nvSpPr>
+          <p:cNvPr id="2" name="Slide Image Placeholder 1"/>
+          <p:cNvSpPr>
+            <a:spLocks noGrp="1" noRot="1" noChangeAspect="1"/>
+          </p:cNvSpPr>
+          <p:nvPr>
+            <p:ph type="sldImg"/>
+          </p:nvPr>
+        </p:nvSpPr>
+        <p:spPr/>
+      </p:sp>
+      <p:sp>
+        <p:nvSpPr>
+          <p:cNvPr id="3" name="Notes Placeholder 2"/>
+          <p:cNvSpPr>
+            <a:spLocks noGrp="1"/>
+          </p:cNvSpPr>
+          <p:nvPr>
+            <p:ph type="body" idx="1"/>
+          </p:nvPr>
+        </p:nvSpPr>
+        <p:spPr/>
+        <p:txBody>
+          <a:bodyPr/>
+          <a:lstStyle/>
+          <a:p>
+            <a:endParaRPr lang="en-US" dirty="0"/>
+          </a:p>
+        </p:txBody>
+      </p:sp>
+      <p:sp>
+        <p:nvSpPr>
+          <p:cNvPr id="4" name="Slide Number Placeholder 3"/>
+          <p:cNvSpPr>
+            <a:spLocks noGrp="1"/>
+          </p:cNvSpPr>
+          <p:nvPr>
+            <p:ph type="sldNum" sz="quarter" idx="10"/>
+          </p:nvPr>
+        </p:nvSpPr>
+        <p:spPr/>
+        <p:txBody>
+          <a:bodyPr/>
+          <a:lstStyle/>
+          <a:p>
+            <a:fld id="{F7021451-1387-4CA6-816F-3879F97B5CBC}" type="slidenum">
+              <a:rPr lang="en-US"/>
+              <a:t>12</a:t>
+            </a:fld>
+            <a:endParaRPr lang="en-US"/>
+          </a:p>
+        </p:txBody>
+      </p:sp>
+    </p:spTree>
+    <p:extLst>
+      <p:ext uri="{BB962C8B-B14F-4D97-AF65-F5344CB8AC3E}">
+        <p14:creationId xmlns:p14="http://schemas.microsoft.com/office/powerpoint/2010/main" val="1024086991"/>
+      </p:ext>
+    </p:extLst>
+  </p:cSld>
+  <p:clrMapOvr>
+    <a:masterClrMapping/>
+  </p:clrMapOvr>
+</p:notes>
+</file>
+
+<file path=ppt\notesSlides\notesSlide13.xml><?xml version="1.0" encoding="utf-8"?>
+<p:notes xmlns:a="http://schemas.openxmlformats.org/drawingml/2006/main" xmlns:r="http://schemas.openxmlformats.org/officeDocument/2006/relationships" xmlns:p="http://schemas.openxmlformats.org/presentationml/2006/main">
+  <p:cSld>
+    <p:spTree>
+      <p:nvGrpSpPr>
+        <p:cNvPr id="1" name=""/>
+        <p:cNvGrpSpPr/>
+        <p:nvPr/>
+      </p:nvGrpSpPr>
+      <p:grpSpPr>
+        <a:xfrm>
+          <a:off x="0" y="0"/>
+          <a:ext cx="0" cy="0"/>
+          <a:chOff x="0" y="0"/>
+          <a:chExt cx="0" cy="0"/>
+        </a:xfrm>
+      </p:grpSpPr>
+      <p:sp>
+        <p:nvSpPr>
+          <p:cNvPr id="2" name="Slide Image Placeholder 1"/>
+          <p:cNvSpPr>
+            <a:spLocks noGrp="1" noRot="1" noChangeAspect="1"/>
+          </p:cNvSpPr>
+          <p:nvPr>
+            <p:ph type="sldImg"/>
+          </p:nvPr>
+        </p:nvSpPr>
+        <p:spPr/>
+      </p:sp>
+      <p:sp>
+        <p:nvSpPr>
+          <p:cNvPr id="3" name="Notes Placeholder 2"/>
+          <p:cNvSpPr>
+            <a:spLocks noGrp="1"/>
+          </p:cNvSpPr>
+          <p:nvPr>
+            <p:ph type="body" idx="1"/>
+          </p:nvPr>
+        </p:nvSpPr>
+        <p:spPr/>
+        <p:txBody>
+          <a:bodyPr/>
+          <a:lstStyle/>
+          <a:p>
+            <a:endParaRPr lang="en-US" dirty="0"/>
+          </a:p>
+        </p:txBody>
+      </p:sp>
+      <p:sp>
+        <p:nvSpPr>
+          <p:cNvPr id="4" name="Slide Number Placeholder 3"/>
+          <p:cNvSpPr>
+            <a:spLocks noGrp="1"/>
+          </p:cNvSpPr>
+          <p:nvPr>
+            <p:ph type="sldNum" sz="quarter" idx="10"/>
+          </p:nvPr>
+        </p:nvSpPr>
+        <p:spPr/>
+        <p:txBody>
+          <a:bodyPr/>
+          <a:lstStyle/>
+          <a:p>
+            <a:fld id="{F7021451-1387-4CA6-816F-3879F97B5CBC}" type="slidenum">
+              <a:rPr lang="en-US"/>
+              <a:t>13</a:t>
+            </a:fld>
+            <a:endParaRPr lang="en-US"/>
+          </a:p>
+        </p:txBody>
+      </p:sp>
+    </p:spTree>
+    <p:extLst>
+      <p:ext uri="{BB962C8B-B14F-4D97-AF65-F5344CB8AC3E}">
+        <p14:creationId xmlns:p14="http://schemas.microsoft.com/office/powerpoint/2010/main" val="1024086991"/>
+      </p:ext>
+    </p:extLst>
+  </p:cSld>
+  <p:clrMapOvr>
+    <a:masterClrMapping/>
+  </p:clrMapOvr>
+</p:notes>
+</file>
+
+<file path=ppt\notesSlides\notesSlide14.xml><?xml version="1.0" encoding="utf-8"?>
+<p:notes xmlns:a="http://schemas.openxmlformats.org/drawingml/2006/main" xmlns:r="http://schemas.openxmlformats.org/officeDocument/2006/relationships" xmlns:p="http://schemas.openxmlformats.org/presentationml/2006/main">
+  <p:cSld>
+    <p:spTree>
+      <p:nvGrpSpPr>
+        <p:cNvPr id="1" name=""/>
+        <p:cNvGrpSpPr/>
+        <p:nvPr/>
+      </p:nvGrpSpPr>
+      <p:grpSpPr>
+        <a:xfrm>
+          <a:off x="0" y="0"/>
+          <a:ext cx="0" cy="0"/>
+          <a:chOff x="0" y="0"/>
+          <a:chExt cx="0" cy="0"/>
+        </a:xfrm>
+      </p:grpSpPr>
+      <p:sp>
+        <p:nvSpPr>
+          <p:cNvPr id="2" name="Slide Image Placeholder 1"/>
+          <p:cNvSpPr>
+            <a:spLocks noGrp="1" noRot="1" noChangeAspect="1"/>
+          </p:cNvSpPr>
+          <p:nvPr>
+            <p:ph type="sldImg"/>
+          </p:nvPr>
+        </p:nvSpPr>
+        <p:spPr/>
+      </p:sp>
+      <p:sp>
+        <p:nvSpPr>
+          <p:cNvPr id="3" name="Notes Placeholder 2"/>
+          <p:cNvSpPr>
+            <a:spLocks noGrp="1"/>
+          </p:cNvSpPr>
+          <p:nvPr>
+            <p:ph type="body" idx="1"/>
+          </p:nvPr>
+        </p:nvSpPr>
+        <p:spPr/>
+        <p:txBody>
+          <a:bodyPr/>
+          <a:lstStyle/>
+          <a:p>
+            <a:endParaRPr lang="en-US" dirty="0"/>
+          </a:p>
+        </p:txBody>
+      </p:sp>
+      <p:sp>
+        <p:nvSpPr>
+          <p:cNvPr id="4" name="Slide Number Placeholder 3"/>
+          <p:cNvSpPr>
+            <a:spLocks noGrp="1"/>
+          </p:cNvSpPr>
+          <p:nvPr>
+            <p:ph type="sldNum" sz="quarter" idx="10"/>
+          </p:nvPr>
+        </p:nvSpPr>
+        <p:spPr/>
+        <p:txBody>
+          <a:bodyPr/>
+          <a:lstStyle/>
+          <a:p>
+            <a:fld id="{F7021451-1387-4CA6-816F-3879F97B5CBC}" type="slidenum">
+              <a:rPr lang="en-US"/>
+              <a:t>14</a:t>
+            </a:fld>
+            <a:endParaRPr lang="en-US"/>
+          </a:p>
+        </p:txBody>
+      </p:sp>
+    </p:spTree>
+    <p:extLst>
+      <p:ext uri="{BB962C8B-B14F-4D97-AF65-F5344CB8AC3E}">
+        <p14:creationId xmlns:p14="http://schemas.microsoft.com/office/powerpoint/2010/main" val="1024086991"/>
+      </p:ext>
+    </p:extLst>
+  </p:cSld>
+  <p:clrMapOvr>
+    <a:masterClrMapping/>
+  </p:clrMapOvr>
+</p:notes>
+</file>
+
+<file path=ppt\notesSlides\notesSlide15.xml><?xml version="1.0" encoding="utf-8"?>
+<p:notes xmlns:a="http://schemas.openxmlformats.org/drawingml/2006/main" xmlns:r="http://schemas.openxmlformats.org/officeDocument/2006/relationships" xmlns:p="http://schemas.openxmlformats.org/presentationml/2006/main">
+  <p:cSld>
+    <p:spTree>
+      <p:nvGrpSpPr>
+        <p:cNvPr id="1" name=""/>
+        <p:cNvGrpSpPr/>
+        <p:nvPr/>
+      </p:nvGrpSpPr>
+      <p:grpSpPr>
+        <a:xfrm>
+          <a:off x="0" y="0"/>
+          <a:ext cx="0" cy="0"/>
+          <a:chOff x="0" y="0"/>
+          <a:chExt cx="0" cy="0"/>
+        </a:xfrm>
+      </p:grpSpPr>
+      <p:sp>
+        <p:nvSpPr>
+          <p:cNvPr id="2" name="Slide Image Placeholder 1"/>
+          <p:cNvSpPr>
+            <a:spLocks noGrp="1" noRot="1" noChangeAspect="1"/>
+          </p:cNvSpPr>
+          <p:nvPr>
+            <p:ph type="sldImg"/>
+          </p:nvPr>
+        </p:nvSpPr>
+        <p:spPr/>
+      </p:sp>
+      <p:sp>
+        <p:nvSpPr>
+          <p:cNvPr id="3" name="Notes Placeholder 2"/>
+          <p:cNvSpPr>
+            <a:spLocks noGrp="1"/>
+          </p:cNvSpPr>
+          <p:nvPr>
+            <p:ph type="body" idx="1"/>
+          </p:nvPr>
+        </p:nvSpPr>
+        <p:spPr/>
+        <p:txBody>
+          <a:bodyPr/>
+          <a:lstStyle/>
+          <a:p>
+            <a:endParaRPr lang="en-US" dirty="0"/>
+          </a:p>
+        </p:txBody>
+      </p:sp>
+      <p:sp>
+        <p:nvSpPr>
+          <p:cNvPr id="4" name="Slide Number Placeholder 3"/>
+          <p:cNvSpPr>
+            <a:spLocks noGrp="1"/>
+          </p:cNvSpPr>
+          <p:nvPr>
+            <p:ph type="sldNum" sz="quarter" idx="10"/>
+          </p:nvPr>
+        </p:nvSpPr>
+        <p:spPr/>
+        <p:txBody>
+          <a:bodyPr/>
+          <a:lstStyle/>
+          <a:p>
+            <a:fld id="{F7021451-1387-4CA6-816F-3879F97B5CBC}" type="slidenum">
+              <a:rPr lang="en-US"/>
+              <a:t>15</a:t>
+            </a:fld>
+            <a:endParaRPr lang="en-US"/>
+          </a:p>
+        </p:txBody>
+      </p:sp>
+    </p:spTree>
+    <p:extLst>
+      <p:ext uri="{BB962C8B-B14F-4D97-AF65-F5344CB8AC3E}">
+        <p14:creationId xmlns:p14="http://schemas.microsoft.com/office/powerpoint/2010/main" val="1024086991"/>
+      </p:ext>
+    </p:extLst>
+  </p:cSld>
+  <p:clrMapOvr>
+    <a:masterClrMapping/>
+  </p:clrMapOvr>
+</p:notes>
+</file>
+
+<file path=ppt\notesSlides\notesSlide16.xml><?xml version="1.0" encoding="utf-8"?>
+<p:notes xmlns:a="http://schemas.openxmlformats.org/drawingml/2006/main" xmlns:r="http://schemas.openxmlformats.org/officeDocument/2006/relationships" xmlns:p="http://schemas.openxmlformats.org/presentationml/2006/main">
+  <p:cSld>
+    <p:spTree>
+      <p:nvGrpSpPr>
+        <p:cNvPr id="1" name=""/>
+        <p:cNvGrpSpPr/>
+        <p:nvPr/>
+      </p:nvGrpSpPr>
+      <p:grpSpPr>
+        <a:xfrm>
+          <a:off x="0" y="0"/>
+          <a:ext cx="0" cy="0"/>
+          <a:chOff x="0" y="0"/>
+          <a:chExt cx="0" cy="0"/>
+        </a:xfrm>
+      </p:grpSpPr>
+      <p:sp>
+        <p:nvSpPr>
+          <p:cNvPr id="2" name="Slide Image Placeholder 1"/>
+          <p:cNvSpPr>
+            <a:spLocks noGrp="1" noRot="1" noChangeAspect="1"/>
+          </p:cNvSpPr>
+          <p:nvPr>
+            <p:ph type="sldImg"/>
+          </p:nvPr>
+        </p:nvSpPr>
+        <p:spPr/>
+      </p:sp>
+      <p:sp>
+        <p:nvSpPr>
+          <p:cNvPr id="3" name="Notes Placeholder 2"/>
+          <p:cNvSpPr>
+            <a:spLocks noGrp="1"/>
+          </p:cNvSpPr>
+          <p:nvPr>
+            <p:ph type="body" idx="1"/>
+          </p:nvPr>
+        </p:nvSpPr>
+        <p:spPr/>
+        <p:txBody>
+          <a:bodyPr/>
+          <a:lstStyle/>
+          <a:p>
+            <a:endParaRPr lang="en-US" dirty="0"/>
+          </a:p>
+        </p:txBody>
+      </p:sp>
+      <p:sp>
+        <p:nvSpPr>
+          <p:cNvPr id="4" name="Slide Number Placeholder 3"/>
+          <p:cNvSpPr>
+            <a:spLocks noGrp="1"/>
+          </p:cNvSpPr>
+          <p:nvPr>
+            <p:ph type="sldNum" sz="quarter" idx="10"/>
+          </p:nvPr>
+        </p:nvSpPr>
+        <p:spPr/>
+        <p:txBody>
+          <a:bodyPr/>
+          <a:lstStyle/>
+          <a:p>
+            <a:fld id="{F7021451-1387-4CA6-816F-3879F97B5CBC}" type="slidenum">
+              <a:rPr lang="en-US"/>
+              <a:t>16</a:t>
+            </a:fld>
+            <a:endParaRPr lang="en-US"/>
+          </a:p>
+        </p:txBody>
+      </p:sp>
+    </p:spTree>
+    <p:extLst>
+      <p:ext uri="{BB962C8B-B14F-4D97-AF65-F5344CB8AC3E}">
+        <p14:creationId xmlns:p14="http://schemas.microsoft.com/office/powerpoint/2010/main" val="1024086991"/>
+      </p:ext>
+    </p:extLst>
+  </p:cSld>
+  <p:clrMapOvr>
+    <a:masterClrMapping/>
+  </p:clrMapOvr>
+</p:notes>
+</file>
+
+<file path=ppt\notesSlides\notesSlide2.xml><?xml version="1.0" encoding="utf-8"?>
+<p:notes xmlns:a="http://schemas.openxmlformats.org/drawingml/2006/main" xmlns:r="http://schemas.openxmlformats.org/officeDocument/2006/relationships" xmlns:p="http://schemas.openxmlformats.org/presentationml/2006/main">
+  <p:cSld>
+    <p:spTree>
+      <p:nvGrpSpPr>
+        <p:cNvPr id="1" name=""/>
+        <p:cNvGrpSpPr/>
+        <p:nvPr/>
+      </p:nvGrpSpPr>
+      <p:grpSpPr>
+        <a:xfrm>
+          <a:off x="0" y="0"/>
+          <a:ext cx="0" cy="0"/>
+          <a:chOff x="0" y="0"/>
+          <a:chExt cx="0" cy="0"/>
+        </a:xfrm>
+      </p:grpSpPr>
+      <p:sp>
+        <p:nvSpPr>
+          <p:cNvPr id="2" name="Slide Image Placeholder 1"/>
+          <p:cNvSpPr>
+            <a:spLocks noGrp="1" noRot="1" noChangeAspect="1"/>
+          </p:cNvSpPr>
+          <p:nvPr>
+            <p:ph type="sldImg"/>
+          </p:nvPr>
+        </p:nvSpPr>
+        <p:spPr/>
+      </p:sp>
+      <p:sp>
+        <p:nvSpPr>
+          <p:cNvPr id="3" name="Notes Placeholder 2"/>
+          <p:cNvSpPr>
+            <a:spLocks noGrp="1"/>
+          </p:cNvSpPr>
+          <p:nvPr>
+            <p:ph type="body" idx="1"/>
+          </p:nvPr>
+        </p:nvSpPr>
+        <p:spPr/>
+        <p:txBody>
+          <a:bodyPr/>
+          <a:lstStyle/>
+          <a:p>
+            <a:endParaRPr lang="en-US" dirty="0"/>
+          </a:p>
+        </p:txBody>
+      </p:sp>
+      <p:sp>
+        <p:nvSpPr>
+          <p:cNvPr id="4" name="Slide Number Placeholder 3"/>
+          <p:cNvSpPr>
+            <a:spLocks noGrp="1"/>
+          </p:cNvSpPr>
+          <p:nvPr>
+            <p:ph type="sldNum" sz="quarter" idx="10"/>
+          </p:nvPr>
+        </p:nvSpPr>
+        <p:spPr/>
+        <p:txBody>
+          <a:bodyPr/>
+          <a:lstStyle/>
+          <a:p>
+            <a:fld id="{F7021451-1387-4CA6-816F-3879F97B5CBC}" type="slidenum">
+              <a:rPr lang="en-US"/>
+              <a:t>2</a:t>
+            </a:fld>
+            <a:endParaRPr lang="en-US"/>
+          </a:p>
+        </p:txBody>
+      </p:sp>
+    </p:spTree>
+    <p:extLst>
+      <p:ext uri="{BB962C8B-B14F-4D97-AF65-F5344CB8AC3E}">
+        <p14:creationId xmlns:p14="http://schemas.microsoft.com/office/powerpoint/2010/main" val="1024086991"/>
+      </p:ext>
+    </p:extLst>
+  </p:cSld>
+  <p:clrMapOvr>
+    <a:masterClrMapping/>
+  </p:clrMapOvr>
+</p:notes>
+</file>
+
+<file path=ppt\notesSlides\notesSlide3.xml><?xml version="1.0" encoding="utf-8"?>
+<p:notes xmlns:a="http://schemas.openxmlformats.org/drawingml/2006/main" xmlns:r="http://schemas.openxmlformats.org/officeDocument/2006/relationships" xmlns:p="http://schemas.openxmlformats.org/presentationml/2006/main">
+  <p:cSld>
+    <p:spTree>
+      <p:nvGrpSpPr>
+        <p:cNvPr id="1" name=""/>
+        <p:cNvGrpSpPr/>
+        <p:nvPr/>
+      </p:nvGrpSpPr>
+      <p:grpSpPr>
+        <a:xfrm>
+          <a:off x="0" y="0"/>
+          <a:ext cx="0" cy="0"/>
+          <a:chOff x="0" y="0"/>
+          <a:chExt cx="0" cy="0"/>
+        </a:xfrm>
+      </p:grpSpPr>
+      <p:sp>
+        <p:nvSpPr>
+          <p:cNvPr id="2" name="Slide Image Placeholder 1"/>
+          <p:cNvSpPr>
+            <a:spLocks noGrp="1" noRot="1" noChangeAspect="1"/>
+          </p:cNvSpPr>
+          <p:nvPr>
+            <p:ph type="sldImg"/>
+          </p:nvPr>
+        </p:nvSpPr>
+        <p:spPr/>
+      </p:sp>
+      <p:sp>
+        <p:nvSpPr>
+          <p:cNvPr id="3" name="Notes Placeholder 2"/>
+          <p:cNvSpPr>
+            <a:spLocks noGrp="1"/>
+          </p:cNvSpPr>
+          <p:nvPr>
+            <p:ph type="body" idx="1"/>
+          </p:nvPr>
+        </p:nvSpPr>
+        <p:spPr/>
+        <p:txBody>
+          <a:bodyPr/>
+          <a:lstStyle/>
+          <a:p>
+            <a:endParaRPr lang="en-US" dirty="0"/>
+          </a:p>
+        </p:txBody>
+      </p:sp>
+      <p:sp>
+        <p:nvSpPr>
+          <p:cNvPr id="4" name="Slide Number Placeholder 3"/>
+          <p:cNvSpPr>
+            <a:spLocks noGrp="1"/>
+          </p:cNvSpPr>
+          <p:nvPr>
+            <p:ph type="sldNum" sz="quarter" idx="10"/>
+          </p:nvPr>
+        </p:nvSpPr>
+        <p:spPr/>
+        <p:txBody>
+          <a:bodyPr/>
+          <a:lstStyle/>
+          <a:p>
+            <a:fld id="{F7021451-1387-4CA6-816F-3879F97B5CBC}" type="slidenum">
+              <a:rPr lang="en-US"/>
+              <a:t>3</a:t>
+            </a:fld>
+            <a:endParaRPr lang="en-US"/>
+          </a:p>
+        </p:txBody>
+      </p:sp>
+    </p:spTree>
+    <p:extLst>
+      <p:ext uri="{BB962C8B-B14F-4D97-AF65-F5344CB8AC3E}">
+        <p14:creationId xmlns:p14="http://schemas.microsoft.com/office/powerpoint/2010/main" val="1024086991"/>
+      </p:ext>
+    </p:extLst>
+  </p:cSld>
+  <p:clrMapOvr>
+    <a:masterClrMapping/>
+  </p:clrMapOvr>
+</p:notes>
+</file>
+
+<file path=ppt\notesSlides\notesSlide4.xml><?xml version="1.0" encoding="utf-8"?>
+<p:notes xmlns:a="http://schemas.openxmlformats.org/drawingml/2006/main" xmlns:r="http://schemas.openxmlformats.org/officeDocument/2006/relationships" xmlns:p="http://schemas.openxmlformats.org/presentationml/2006/main">
+  <p:cSld>
+    <p:spTree>
+      <p:nvGrpSpPr>
+        <p:cNvPr id="1" name=""/>
+        <p:cNvGrpSpPr/>
+        <p:nvPr/>
+      </p:nvGrpSpPr>
+      <p:grpSpPr>
+        <a:xfrm>
+          <a:off x="0" y="0"/>
+          <a:ext cx="0" cy="0"/>
+          <a:chOff x="0" y="0"/>
+          <a:chExt cx="0" cy="0"/>
+        </a:xfrm>
+      </p:grpSpPr>
+      <p:sp>
+        <p:nvSpPr>
+          <p:cNvPr id="2" name="Slide Image Placeholder 1"/>
+          <p:cNvSpPr>
+            <a:spLocks noGrp="1" noRot="1" noChangeAspect="1"/>
+          </p:cNvSpPr>
+          <p:nvPr>
+            <p:ph type="sldImg"/>
+          </p:nvPr>
+        </p:nvSpPr>
+        <p:spPr/>
+      </p:sp>
+      <p:sp>
+        <p:nvSpPr>
+          <p:cNvPr id="3" name="Notes Placeholder 2"/>
+          <p:cNvSpPr>
+            <a:spLocks noGrp="1"/>
+          </p:cNvSpPr>
+          <p:nvPr>
+            <p:ph type="body" idx="1"/>
+          </p:nvPr>
+        </p:nvSpPr>
+        <p:spPr/>
+        <p:txBody>
+          <a:bodyPr/>
+          <a:lstStyle/>
+          <a:p>
+            <a:endParaRPr lang="en-US" dirty="0"/>
+          </a:p>
+        </p:txBody>
+      </p:sp>
+      <p:sp>
+        <p:nvSpPr>
+          <p:cNvPr id="4" name="Slide Number Placeholder 3"/>
+          <p:cNvSpPr>
+            <a:spLocks noGrp="1"/>
+          </p:cNvSpPr>
+          <p:nvPr>
+            <p:ph type="sldNum" sz="quarter" idx="10"/>
+          </p:nvPr>
+        </p:nvSpPr>
+        <p:spPr/>
+        <p:txBody>
+          <a:bodyPr/>
+          <a:lstStyle/>
+          <a:p>
+            <a:fld id="{F7021451-1387-4CA6-816F-3879F97B5CBC}" type="slidenum">
+              <a:rPr lang="en-US"/>
+              <a:t>4</a:t>
+            </a:fld>
+            <a:endParaRPr lang="en-US"/>
+          </a:p>
+        </p:txBody>
+      </p:sp>
+    </p:spTree>
+    <p:extLst>
+      <p:ext uri="{BB962C8B-B14F-4D97-AF65-F5344CB8AC3E}">
+        <p14:creationId xmlns:p14="http://schemas.microsoft.com/office/powerpoint/2010/main" val="1024086991"/>
+      </p:ext>
+    </p:extLst>
+  </p:cSld>
+  <p:clrMapOvr>
+    <a:masterClrMapping/>
+  </p:clrMapOvr>
+</p:notes>
+</file>
+
+<file path=ppt\notesSlides\notesSlide5.xml><?xml version="1.0" encoding="utf-8"?>
+<p:notes xmlns:a="http://schemas.openxmlformats.org/drawingml/2006/main" xmlns:r="http://schemas.openxmlformats.org/officeDocument/2006/relationships" xmlns:p="http://schemas.openxmlformats.org/presentationml/2006/main">
+  <p:cSld>
+    <p:spTree>
+      <p:nvGrpSpPr>
+        <p:cNvPr id="1" name=""/>
+        <p:cNvGrpSpPr/>
+        <p:nvPr/>
+      </p:nvGrpSpPr>
+      <p:grpSpPr>
+        <a:xfrm>
+          <a:off x="0" y="0"/>
+          <a:ext cx="0" cy="0"/>
+          <a:chOff x="0" y="0"/>
+          <a:chExt cx="0" cy="0"/>
+        </a:xfrm>
+      </p:grpSpPr>
+      <p:sp>
+        <p:nvSpPr>
+          <p:cNvPr id="2" name="Slide Image Placeholder 1"/>
+          <p:cNvSpPr>
+            <a:spLocks noGrp="1" noRot="1" noChangeAspect="1"/>
+          </p:cNvSpPr>
+          <p:nvPr>
+            <p:ph type="sldImg"/>
+          </p:nvPr>
+        </p:nvSpPr>
+        <p:spPr/>
+      </p:sp>
+      <p:sp>
+        <p:nvSpPr>
+          <p:cNvPr id="3" name="Notes Placeholder 2"/>
+          <p:cNvSpPr>
+            <a:spLocks noGrp="1"/>
+          </p:cNvSpPr>
+          <p:nvPr>
+            <p:ph type="body" idx="1"/>
+          </p:nvPr>
+        </p:nvSpPr>
+        <p:spPr/>
+        <p:txBody>
+          <a:bodyPr/>
+          <a:lstStyle/>
+          <a:p>
+            <a:endParaRPr lang="en-US" dirty="0"/>
+          </a:p>
+        </p:txBody>
+      </p:sp>
+      <p:sp>
+        <p:nvSpPr>
+          <p:cNvPr id="4" name="Slide Number Placeholder 3"/>
+          <p:cNvSpPr>
+            <a:spLocks noGrp="1"/>
+          </p:cNvSpPr>
+          <p:nvPr>
+            <p:ph type="sldNum" sz="quarter" idx="10"/>
+          </p:nvPr>
+        </p:nvSpPr>
+        <p:spPr/>
+        <p:txBody>
+          <a:bodyPr/>
+          <a:lstStyle/>
+          <a:p>
+            <a:fld id="{F7021451-1387-4CA6-816F-3879F97B5CBC}" type="slidenum">
+              <a:rPr lang="en-US"/>
+              <a:t>5</a:t>
+            </a:fld>
+            <a:endParaRPr lang="en-US"/>
+          </a:p>
+        </p:txBody>
+      </p:sp>
+    </p:spTree>
+    <p:extLst>
+      <p:ext uri="{BB962C8B-B14F-4D97-AF65-F5344CB8AC3E}">
+        <p14:creationId xmlns:p14="http://schemas.microsoft.com/office/powerpoint/2010/main" val="1024086991"/>
+      </p:ext>
+    </p:extLst>
+  </p:cSld>
+  <p:clrMapOvr>
+    <a:masterClrMapping/>
+  </p:clrMapOvr>
+</p:notes>
+</file>
+
+<file path=ppt\notesSlides\notesSlide6.xml><?xml version="1.0" encoding="utf-8"?>
+<p:notes xmlns:a="http://schemas.openxmlformats.org/drawingml/2006/main" xmlns:r="http://schemas.openxmlformats.org/officeDocument/2006/relationships" xmlns:p="http://schemas.openxmlformats.org/presentationml/2006/main">
+  <p:cSld>
+    <p:spTree>
+      <p:nvGrpSpPr>
+        <p:cNvPr id="1" name=""/>
+        <p:cNvGrpSpPr/>
+        <p:nvPr/>
+      </p:nvGrpSpPr>
+      <p:grpSpPr>
+        <a:xfrm>
+          <a:off x="0" y="0"/>
+          <a:ext cx="0" cy="0"/>
+          <a:chOff x="0" y="0"/>
+          <a:chExt cx="0" cy="0"/>
+        </a:xfrm>
+      </p:grpSpPr>
+      <p:sp>
+        <p:nvSpPr>
+          <p:cNvPr id="2" name="Slide Image Placeholder 1"/>
+          <p:cNvSpPr>
+            <a:spLocks noGrp="1" noRot="1" noChangeAspect="1"/>
+          </p:cNvSpPr>
+          <p:nvPr>
+            <p:ph type="sldImg"/>
+          </p:nvPr>
+        </p:nvSpPr>
+        <p:spPr/>
+      </p:sp>
+      <p:sp>
+        <p:nvSpPr>
+          <p:cNvPr id="3" name="Notes Placeholder 2"/>
+          <p:cNvSpPr>
+            <a:spLocks noGrp="1"/>
+          </p:cNvSpPr>
+          <p:nvPr>
+            <p:ph type="body" idx="1"/>
+          </p:nvPr>
+        </p:nvSpPr>
+        <p:spPr/>
+        <p:txBody>
+          <a:bodyPr/>
+          <a:lstStyle/>
+          <a:p>
+            <a:endParaRPr lang="en-US" dirty="0"/>
+          </a:p>
+        </p:txBody>
+      </p:sp>
+      <p:sp>
+        <p:nvSpPr>
+          <p:cNvPr id="4" name="Slide Number Placeholder 3"/>
+          <p:cNvSpPr>
+            <a:spLocks noGrp="1"/>
+          </p:cNvSpPr>
+          <p:nvPr>
+            <p:ph type="sldNum" sz="quarter" idx="10"/>
+          </p:nvPr>
+        </p:nvSpPr>
+        <p:spPr/>
+        <p:txBody>
+          <a:bodyPr/>
+          <a:lstStyle/>
+          <a:p>
+            <a:fld id="{F7021451-1387-4CA6-816F-3879F97B5CBC}" type="slidenum">
+              <a:rPr lang="en-US"/>
+              <a:t>6</a:t>
+            </a:fld>
+            <a:endParaRPr lang="en-US"/>
+          </a:p>
+        </p:txBody>
+      </p:sp>
+    </p:spTree>
+    <p:extLst>
+      <p:ext uri="{BB962C8B-B14F-4D97-AF65-F5344CB8AC3E}">
+        <p14:creationId xmlns:p14="http://schemas.microsoft.com/office/powerpoint/2010/main" val="1024086991"/>
+      </p:ext>
+    </p:extLst>
+  </p:cSld>
+  <p:clrMapOvr>
+    <a:masterClrMapping/>
+  </p:clrMapOvr>
+</p:notes>
+</file>
+
+<file path=ppt\notesSlides\notesSlide7.xml><?xml version="1.0" encoding="utf-8"?>
+<p:notes xmlns:a="http://schemas.openxmlformats.org/drawingml/2006/main" xmlns:r="http://schemas.openxmlformats.org/officeDocument/2006/relationships" xmlns:p="http://schemas.openxmlformats.org/presentationml/2006/main">
+  <p:cSld>
+    <p:spTree>
+      <p:nvGrpSpPr>
+        <p:cNvPr id="1" name=""/>
+        <p:cNvGrpSpPr/>
+        <p:nvPr/>
+      </p:nvGrpSpPr>
+      <p:grpSpPr>
+        <a:xfrm>
+          <a:off x="0" y="0"/>
+          <a:ext cx="0" cy="0"/>
+          <a:chOff x="0" y="0"/>
+          <a:chExt cx="0" cy="0"/>
+        </a:xfrm>
+      </p:grpSpPr>
+      <p:sp>
+        <p:nvSpPr>
+          <p:cNvPr id="2" name="Slide Image Placeholder 1"/>
+          <p:cNvSpPr>
+            <a:spLocks noGrp="1" noRot="1" noChangeAspect="1"/>
+          </p:cNvSpPr>
+          <p:nvPr>
+            <p:ph type="sldImg"/>
+          </p:nvPr>
+        </p:nvSpPr>
+        <p:spPr/>
+      </p:sp>
+      <p:sp>
+        <p:nvSpPr>
+          <p:cNvPr id="3" name="Notes Placeholder 2"/>
+          <p:cNvSpPr>
+            <a:spLocks noGrp="1"/>
+          </p:cNvSpPr>
+          <p:nvPr>
+            <p:ph type="body" idx="1"/>
+          </p:nvPr>
+        </p:nvSpPr>
+        <p:spPr/>
+        <p:txBody>
+          <a:bodyPr/>
+          <a:lstStyle/>
+          <a:p>
+            <a:endParaRPr lang="en-US" dirty="0"/>
+          </a:p>
+        </p:txBody>
+      </p:sp>
+      <p:sp>
+        <p:nvSpPr>
+          <p:cNvPr id="4" name="Slide Number Placeholder 3"/>
+          <p:cNvSpPr>
+            <a:spLocks noGrp="1"/>
+          </p:cNvSpPr>
+          <p:nvPr>
+            <p:ph type="sldNum" sz="quarter" idx="10"/>
+          </p:nvPr>
+        </p:nvSpPr>
+        <p:spPr/>
+        <p:txBody>
+          <a:bodyPr/>
+          <a:lstStyle/>
+          <a:p>
+            <a:fld id="{F7021451-1387-4CA6-816F-3879F97B5CBC}" type="slidenum">
+              <a:rPr lang="en-US"/>
+              <a:t>7</a:t>
+            </a:fld>
+            <a:endParaRPr lang="en-US"/>
+          </a:p>
+        </p:txBody>
+      </p:sp>
+    </p:spTree>
+    <p:extLst>
+      <p:ext uri="{BB962C8B-B14F-4D97-AF65-F5344CB8AC3E}">
+        <p14:creationId xmlns:p14="http://schemas.microsoft.com/office/powerpoint/2010/main" val="1024086991"/>
+      </p:ext>
+    </p:extLst>
+  </p:cSld>
+  <p:clrMapOvr>
+    <a:masterClrMapping/>
+  </p:clrMapOvr>
+</p:notes>
+</file>
+
+<file path=ppt\notesSlides\notesSlide8.xml><?xml version="1.0" encoding="utf-8"?>
+<p:notes xmlns:a="http://schemas.openxmlformats.org/drawingml/2006/main" xmlns:r="http://schemas.openxmlformats.org/officeDocument/2006/relationships" xmlns:p="http://schemas.openxmlformats.org/presentationml/2006/main">
+  <p:cSld>
+    <p:spTree>
+      <p:nvGrpSpPr>
+        <p:cNvPr id="1" name=""/>
+        <p:cNvGrpSpPr/>
+        <p:nvPr/>
+      </p:nvGrpSpPr>
+      <p:grpSpPr>
+        <a:xfrm>
+          <a:off x="0" y="0"/>
+          <a:ext cx="0" cy="0"/>
+          <a:chOff x="0" y="0"/>
+          <a:chExt cx="0" cy="0"/>
+        </a:xfrm>
+      </p:grpSpPr>
+      <p:sp>
+        <p:nvSpPr>
+          <p:cNvPr id="2" name="Slide Image Placeholder 1"/>
+          <p:cNvSpPr>
+            <a:spLocks noGrp="1" noRot="1" noChangeAspect="1"/>
+          </p:cNvSpPr>
+          <p:nvPr>
+            <p:ph type="sldImg"/>
+          </p:nvPr>
+        </p:nvSpPr>
+        <p:spPr/>
+      </p:sp>
+      <p:sp>
+        <p:nvSpPr>
+          <p:cNvPr id="3" name="Notes Placeholder 2"/>
+          <p:cNvSpPr>
+            <a:spLocks noGrp="1"/>
+          </p:cNvSpPr>
+          <p:nvPr>
+            <p:ph type="body" idx="1"/>
+          </p:nvPr>
+        </p:nvSpPr>
+        <p:spPr/>
+        <p:txBody>
+          <a:bodyPr/>
+          <a:lstStyle/>
+          <a:p>
+            <a:endParaRPr lang="en-US" dirty="0"/>
+          </a:p>
+        </p:txBody>
+      </p:sp>
+      <p:sp>
+        <p:nvSpPr>
+          <p:cNvPr id="4" name="Slide Number Placeholder 3"/>
+          <p:cNvSpPr>
+            <a:spLocks noGrp="1"/>
+          </p:cNvSpPr>
+          <p:nvPr>
+            <p:ph type="sldNum" sz="quarter" idx="10"/>
+          </p:nvPr>
+        </p:nvSpPr>
+        <p:spPr/>
+        <p:txBody>
+          <a:bodyPr/>
+          <a:lstStyle/>
+          <a:p>
+            <a:fld id="{F7021451-1387-4CA6-816F-3879F97B5CBC}" type="slidenum">
+              <a:rPr lang="en-US"/>
+              <a:t>8</a:t>
+            </a:fld>
+            <a:endParaRPr lang="en-US"/>
+          </a:p>
+        </p:txBody>
+      </p:sp>
+    </p:spTree>
+    <p:extLst>
+      <p:ext uri="{BB962C8B-B14F-4D97-AF65-F5344CB8AC3E}">
+        <p14:creationId xmlns:p14="http://schemas.microsoft.com/office/powerpoint/2010/main" val="1024086991"/>
+      </p:ext>
+    </p:extLst>
+  </p:cSld>
+  <p:clrMapOvr>
+    <a:masterClrMapping/>
+  </p:clrMapOvr>
+</p:notes>
+</file>
+
+<file path=ppt\notesSlides\notesSlide9.xml><?xml version="1.0" encoding="utf-8"?>
+<p:notes xmlns:a="http://schemas.openxmlformats.org/drawingml/2006/main" xmlns:r="http://schemas.openxmlformats.org/officeDocument/2006/relationships" xmlns:p="http://schemas.openxmlformats.org/presentationml/2006/main">
+  <p:cSld>
+    <p:spTree>
+      <p:nvGrpSpPr>
+        <p:cNvPr id="1" name=""/>
+        <p:cNvGrpSpPr/>
+        <p:nvPr/>
+      </p:nvGrpSpPr>
+      <p:grpSpPr>
+        <a:xfrm>
+          <a:off x="0" y="0"/>
+          <a:ext cx="0" cy="0"/>
+          <a:chOff x="0" y="0"/>
+          <a:chExt cx="0" cy="0"/>
+        </a:xfrm>
+      </p:grpSpPr>
+      <p:sp>
+        <p:nvSpPr>
+          <p:cNvPr id="2" name="Slide Image Placeholder 1"/>
+          <p:cNvSpPr>
+            <a:spLocks noGrp="1" noRot="1" noChangeAspect="1"/>
+          </p:cNvSpPr>
+          <p:nvPr>
+            <p:ph type="sldImg"/>
+          </p:nvPr>
+        </p:nvSpPr>
+        <p:spPr/>
+      </p:sp>
+      <p:sp>
+        <p:nvSpPr>
+          <p:cNvPr id="3" name="Notes Placeholder 2"/>
+          <p:cNvSpPr>
+            <a:spLocks noGrp="1"/>
+          </p:cNvSpPr>
+          <p:nvPr>
+            <p:ph type="body" idx="1"/>
+          </p:nvPr>
+        </p:nvSpPr>
+        <p:spPr/>
+        <p:txBody>
+          <a:bodyPr/>
+          <a:lstStyle/>
+          <a:p>
+            <a:endParaRPr lang="en-US" dirty="0"/>
+          </a:p>
+        </p:txBody>
+      </p:sp>
+      <p:sp>
+        <p:nvSpPr>
+          <p:cNvPr id="4" name="Slide Number Placeholder 3"/>
+          <p:cNvSpPr>
+            <a:spLocks noGrp="1"/>
+          </p:cNvSpPr>
+          <p:nvPr>
+            <p:ph type="sldNum" sz="quarter" idx="10"/>
+          </p:nvPr>
+        </p:nvSpPr>
+        <p:spPr/>
+        <p:txBody>
+          <a:bodyPr/>
+          <a:lstStyle/>
+          <a:p>
+            <a:fld id="{F7021451-1387-4CA6-816F-3879F97B5CBC}" type="slidenum">
+              <a:rPr lang="en-US"/>
+              <a:t>9</a:t>
+            </a:fld>
+            <a:endParaRPr lang="en-US"/>
+          </a:p>
+        </p:txBody>
+      </p:sp>
+    </p:spTree>
+    <p:extLst>
+      <p:ext uri="{BB962C8B-B14F-4D97-AF65-F5344CB8AC3E}">
+        <p14:creationId xmlns:p14="http://schemas.microsoft.com/office/powerpoint/2010/main" val="1024086991"/>
+      </p:ext>
+    </p:extLst>
+  </p:cSld>
+  <p:clrMapOvr>
+    <a:masterClrMapping/>
+  </p:clrMapOvr>
+</p:notes>
+</file>
+
+<file path=ppt\presProps.xml><?xml version="1.0" encoding="utf-8"?>
+<p:presentationPr xmlns:a="http://schemas.openxmlformats.org/drawingml/2006/main" xmlns:r="http://schemas.openxmlformats.org/officeDocument/2006/relationships" xmlns:p="http://schemas.openxmlformats.org/presentationml/2006/main">
+  <p:extLst>
+    <p:ext uri="{E76CE94A-603C-4142-B9EB-6D1370010A27}">
+      <p14:discardImageEditData xmlns:p14="http://schemas.microsoft.com/office/powerpoint/2010/main" val="0"/>
+    </p:ext>
+    <p:ext uri="{D31A062A-798A-4329-ABDD-BBA856620510}">
+      <p14:defaultImageDpi xmlns:p14="http://schemas.microsoft.com/office/powerpoint/2010/main" val="220"/>
+    </p:ext>
+    <p:ext uri="{FD5EFAAD-0ECE-453E-9831-46B23BE46B34}">
+      <p15:chartTrackingRefBased xmlns:p15="http://schemas.microsoft.com/office/powerpoint/2012/main" val="0"/>
+    </p:ext>
+  </p:extLst>
+</p:presentationPr>
+</file>
+
+<file path=ppt\presentation.xml><?xml version="1.0" encoding="utf-8"?>
 <p:presentation xmlns:a="http://schemas.openxmlformats.org/drawingml/2006/main" xmlns:r="http://schemas.openxmlformats.org/officeDocument/2006/relationships" xmlns:p="http://schemas.openxmlformats.org/presentationml/2006/main" saveSubsetFonts="1" autoCompressPictures="0">
   <p:sldMasterIdLst>
     <p:sldMasterId id="2147483648" r:id="rId1"/>
@@ -127,1476 +1690,7 @@
 </p:presentation>
 </file>
 
-<file path=ppt/notesMasters/notesMaster1.xml><?xml version="1.0" encoding="utf-8"?>
-<p:notesMaster xmlns:a="http://schemas.openxmlformats.org/drawingml/2006/main" xmlns:r="http://schemas.openxmlformats.org/officeDocument/2006/relationships" xmlns:p="http://schemas.openxmlformats.org/presentationml/2006/main">
-  <p:cSld>
-    <p:bg>
-      <p:bgRef idx="1001">
-        <a:schemeClr val="bg1"/>
-      </p:bgRef>
-    </p:bg>
-    <p:spTree>
-      <p:nvGrpSpPr>
-        <p:cNvPr id="1" name=""/>
-        <p:cNvGrpSpPr/>
-        <p:nvPr/>
-      </p:nvGrpSpPr>
-      <p:grpSpPr>
-        <a:xfrm>
-          <a:off x="0" y="0"/>
-          <a:ext cx="0" cy="0"/>
-          <a:chOff x="0" y="0"/>
-          <a:chExt cx="0" cy="0"/>
-        </a:xfrm>
-      </p:grpSpPr>
-    </p:spTree>
-    <p:extLst>
-      <p:ext uri="{BB962C8B-B14F-4D97-AF65-F5344CB8AC3E}">
-        <p14:creationId xmlns:p14="http://schemas.microsoft.com/office/powerpoint/2010/main" val="776189880"/>
-      </p:ext>
-    </p:extLst>
-  </p:cSld>
-  <p:clrMap bg1="lt1" tx1="dk1" bg2="lt2" tx2="dk2" accent1="accent1" accent2="accent2" accent3="accent3" accent4="accent4" accent5="accent5" accent6="accent6" hlink="hlink" folHlink="folHlink"/>
-  <p:notesStyle>
-    <a:lvl1pPr marL="0" algn="l" defTabSz="914400" rtl="0" eaLnBrk="1" latinLnBrk="0" hangingPunct="1">
-      <a:defRPr sz="1200" kern="1200">
-        <a:solidFill>
-          <a:schemeClr val="tx1"/>
-        </a:solidFill>
-        <a:latin typeface="+mn-lt"/>
-        <a:ea typeface="+mn-ea"/>
-        <a:cs typeface="+mn-cs"/>
-      </a:defRPr>
-    </a:lvl1pPr>
-    <a:lvl2pPr marL="457200" algn="l" defTabSz="914400" rtl="0" eaLnBrk="1" latinLnBrk="0" hangingPunct="1">
-      <a:defRPr sz="1200" kern="1200">
-        <a:solidFill>
-          <a:schemeClr val="tx1"/>
-        </a:solidFill>
-        <a:latin typeface="+mn-lt"/>
-        <a:ea typeface="+mn-ea"/>
-        <a:cs typeface="+mn-cs"/>
-      </a:defRPr>
-    </a:lvl2pPr>
-    <a:lvl3pPr marL="914400" algn="l" defTabSz="914400" rtl="0" eaLnBrk="1" latinLnBrk="0" hangingPunct="1">
-      <a:defRPr sz="1200" kern="1200">
-        <a:solidFill>
-          <a:schemeClr val="tx1"/>
-        </a:solidFill>
-        <a:latin typeface="+mn-lt"/>
-        <a:ea typeface="+mn-ea"/>
-        <a:cs typeface="+mn-cs"/>
-      </a:defRPr>
-    </a:lvl3pPr>
-    <a:lvl4pPr marL="1371600" algn="l" defTabSz="914400" rtl="0" eaLnBrk="1" latinLnBrk="0" hangingPunct="1">
-      <a:defRPr sz="1200" kern="1200">
-        <a:solidFill>
-          <a:schemeClr val="tx1"/>
-        </a:solidFill>
-        <a:latin typeface="+mn-lt"/>
-        <a:ea typeface="+mn-ea"/>
-        <a:cs typeface="+mn-cs"/>
-      </a:defRPr>
-    </a:lvl4pPr>
-    <a:lvl5pPr marL="1828800" algn="l" defTabSz="914400" rtl="0" eaLnBrk="1" latinLnBrk="0" hangingPunct="1">
-      <a:defRPr sz="1200" kern="1200">
-        <a:solidFill>
-          <a:schemeClr val="tx1"/>
-        </a:solidFill>
-        <a:latin typeface="+mn-lt"/>
-        <a:ea typeface="+mn-ea"/>
-        <a:cs typeface="+mn-cs"/>
-      </a:defRPr>
-    </a:lvl5pPr>
-    <a:lvl6pPr marL="2286000" algn="l" defTabSz="914400" rtl="0" eaLnBrk="1" latinLnBrk="0" hangingPunct="1">
-      <a:defRPr sz="1200" kern="1200">
-        <a:solidFill>
-          <a:schemeClr val="tx1"/>
-        </a:solidFill>
-        <a:latin typeface="+mn-lt"/>
-        <a:ea typeface="+mn-ea"/>
-        <a:cs typeface="+mn-cs"/>
-      </a:defRPr>
-    </a:lvl6pPr>
-    <a:lvl7pPr marL="2743200" algn="l" defTabSz="914400" rtl="0" eaLnBrk="1" latinLnBrk="0" hangingPunct="1">
-      <a:defRPr sz="1200" kern="1200">
-        <a:solidFill>
-          <a:schemeClr val="tx1"/>
-        </a:solidFill>
-        <a:latin typeface="+mn-lt"/>
-        <a:ea typeface="+mn-ea"/>
-        <a:cs typeface="+mn-cs"/>
-      </a:defRPr>
-    </a:lvl7pPr>
-    <a:lvl8pPr marL="3200400" algn="l" defTabSz="914400" rtl="0" eaLnBrk="1" latinLnBrk="0" hangingPunct="1">
-      <a:defRPr sz="1200" kern="1200">
-        <a:solidFill>
-          <a:schemeClr val="tx1"/>
-        </a:solidFill>
-        <a:latin typeface="+mn-lt"/>
-        <a:ea typeface="+mn-ea"/>
-        <a:cs typeface="+mn-cs"/>
-      </a:defRPr>
-    </a:lvl8pPr>
-    <a:lvl9pPr marL="3657600" algn="l" defTabSz="914400" rtl="0" eaLnBrk="1" latinLnBrk="0" hangingPunct="1">
-      <a:defRPr sz="1200" kern="1200">
-        <a:solidFill>
-          <a:schemeClr val="tx1"/>
-        </a:solidFill>
-        <a:latin typeface="+mn-lt"/>
-        <a:ea typeface="+mn-ea"/>
-        <a:cs typeface="+mn-cs"/>
-      </a:defRPr>
-    </a:lvl9pPr>
-  </p:notesStyle>
-</p:notesMaster>
-</file>
-
-<file path=ppt/notesSlides/notesSlide1.xml><?xml version="1.0" encoding="utf-8"?>
-<p:notes xmlns:a="http://schemas.openxmlformats.org/drawingml/2006/main" xmlns:r="http://schemas.openxmlformats.org/officeDocument/2006/relationships" xmlns:p="http://schemas.openxmlformats.org/presentationml/2006/main">
-  <p:cSld>
-    <p:spTree>
-      <p:nvGrpSpPr>
-        <p:cNvPr id="1" name=""/>
-        <p:cNvGrpSpPr/>
-        <p:nvPr/>
-      </p:nvGrpSpPr>
-      <p:grpSpPr>
-        <a:xfrm>
-          <a:off x="0" y="0"/>
-          <a:ext cx="0" cy="0"/>
-          <a:chOff x="0" y="0"/>
-          <a:chExt cx="0" cy="0"/>
-        </a:xfrm>
-      </p:grpSpPr>
-      <p:sp>
-        <p:nvSpPr>
-          <p:cNvPr id="2" name="Slide Image Placeholder 1"/>
-          <p:cNvSpPr>
-            <a:spLocks noGrp="1" noRot="1" noChangeAspect="1"/>
-          </p:cNvSpPr>
-          <p:nvPr>
-            <p:ph type="sldImg"/>
-          </p:nvPr>
-        </p:nvSpPr>
-        <p:spPr/>
-      </p:sp>
-      <p:sp>
-        <p:nvSpPr>
-          <p:cNvPr id="3" name="Notes Placeholder 2"/>
-          <p:cNvSpPr>
-            <a:spLocks noGrp="1"/>
-          </p:cNvSpPr>
-          <p:nvPr>
-            <p:ph type="body" idx="1"/>
-          </p:nvPr>
-        </p:nvSpPr>
-        <p:spPr/>
-        <p:txBody>
-          <a:bodyPr/>
-          <a:lstStyle/>
-          <a:p>
-            <a:endParaRPr lang="en-US" dirty="0"/>
-          </a:p>
-        </p:txBody>
-      </p:sp>
-      <p:sp>
-        <p:nvSpPr>
-          <p:cNvPr id="4" name="Slide Number Placeholder 3"/>
-          <p:cNvSpPr>
-            <a:spLocks noGrp="1"/>
-          </p:cNvSpPr>
-          <p:nvPr>
-            <p:ph type="sldNum" sz="quarter" idx="10"/>
-          </p:nvPr>
-        </p:nvSpPr>
-        <p:spPr/>
-        <p:txBody>
-          <a:bodyPr/>
-          <a:lstStyle/>
-          <a:p>
-            <a:fld id="{F7021451-1387-4CA6-816F-3879F97B5CBC}" type="slidenum">
-              <a:rPr lang="en-US"/>
-              <a:t>1</a:t>
-            </a:fld>
-            <a:endParaRPr lang="en-US"/>
-          </a:p>
-        </p:txBody>
-      </p:sp>
-    </p:spTree>
-    <p:extLst>
-      <p:ext uri="{BB962C8B-B14F-4D97-AF65-F5344CB8AC3E}">
-        <p14:creationId xmlns:p14="http://schemas.microsoft.com/office/powerpoint/2010/main" val="1024086991"/>
-      </p:ext>
-    </p:extLst>
-  </p:cSld>
-  <p:clrMapOvr>
-    <a:masterClrMapping/>
-  </p:clrMapOvr>
-</p:notes>
-</file>
-
-<file path=ppt/notesSlides/notesSlide10.xml><?xml version="1.0" encoding="utf-8"?>
-<p:notes xmlns:a="http://schemas.openxmlformats.org/drawingml/2006/main" xmlns:r="http://schemas.openxmlformats.org/officeDocument/2006/relationships" xmlns:p="http://schemas.openxmlformats.org/presentationml/2006/main">
-  <p:cSld>
-    <p:spTree>
-      <p:nvGrpSpPr>
-        <p:cNvPr id="1" name=""/>
-        <p:cNvGrpSpPr/>
-        <p:nvPr/>
-      </p:nvGrpSpPr>
-      <p:grpSpPr>
-        <a:xfrm>
-          <a:off x="0" y="0"/>
-          <a:ext cx="0" cy="0"/>
-          <a:chOff x="0" y="0"/>
-          <a:chExt cx="0" cy="0"/>
-        </a:xfrm>
-      </p:grpSpPr>
-      <p:sp>
-        <p:nvSpPr>
-          <p:cNvPr id="2" name="Slide Image Placeholder 1"/>
-          <p:cNvSpPr>
-            <a:spLocks noGrp="1" noRot="1" noChangeAspect="1"/>
-          </p:cNvSpPr>
-          <p:nvPr>
-            <p:ph type="sldImg"/>
-          </p:nvPr>
-        </p:nvSpPr>
-        <p:spPr/>
-      </p:sp>
-      <p:sp>
-        <p:nvSpPr>
-          <p:cNvPr id="3" name="Notes Placeholder 2"/>
-          <p:cNvSpPr>
-            <a:spLocks noGrp="1"/>
-          </p:cNvSpPr>
-          <p:nvPr>
-            <p:ph type="body" idx="1"/>
-          </p:nvPr>
-        </p:nvSpPr>
-        <p:spPr/>
-        <p:txBody>
-          <a:bodyPr/>
-          <a:lstStyle/>
-          <a:p>
-            <a:endParaRPr lang="en-US" dirty="0"/>
-          </a:p>
-        </p:txBody>
-      </p:sp>
-      <p:sp>
-        <p:nvSpPr>
-          <p:cNvPr id="4" name="Slide Number Placeholder 3"/>
-          <p:cNvSpPr>
-            <a:spLocks noGrp="1"/>
-          </p:cNvSpPr>
-          <p:nvPr>
-            <p:ph type="sldNum" sz="quarter" idx="10"/>
-          </p:nvPr>
-        </p:nvSpPr>
-        <p:spPr/>
-        <p:txBody>
-          <a:bodyPr/>
-          <a:lstStyle/>
-          <a:p>
-            <a:fld id="{F7021451-1387-4CA6-816F-3879F97B5CBC}" type="slidenum">
-              <a:rPr lang="en-US"/>
-              <a:t>10</a:t>
-            </a:fld>
-            <a:endParaRPr lang="en-US"/>
-          </a:p>
-        </p:txBody>
-      </p:sp>
-    </p:spTree>
-    <p:extLst>
-      <p:ext uri="{BB962C8B-B14F-4D97-AF65-F5344CB8AC3E}">
-        <p14:creationId xmlns:p14="http://schemas.microsoft.com/office/powerpoint/2010/main" val="1024086991"/>
-      </p:ext>
-    </p:extLst>
-  </p:cSld>
-  <p:clrMapOvr>
-    <a:masterClrMapping/>
-  </p:clrMapOvr>
-</p:notes>
-</file>
-
-<file path=ppt/notesSlides/notesSlide11.xml><?xml version="1.0" encoding="utf-8"?>
-<p:notes xmlns:a="http://schemas.openxmlformats.org/drawingml/2006/main" xmlns:r="http://schemas.openxmlformats.org/officeDocument/2006/relationships" xmlns:p="http://schemas.openxmlformats.org/presentationml/2006/main">
-  <p:cSld>
-    <p:spTree>
-      <p:nvGrpSpPr>
-        <p:cNvPr id="1" name=""/>
-        <p:cNvGrpSpPr/>
-        <p:nvPr/>
-      </p:nvGrpSpPr>
-      <p:grpSpPr>
-        <a:xfrm>
-          <a:off x="0" y="0"/>
-          <a:ext cx="0" cy="0"/>
-          <a:chOff x="0" y="0"/>
-          <a:chExt cx="0" cy="0"/>
-        </a:xfrm>
-      </p:grpSpPr>
-      <p:sp>
-        <p:nvSpPr>
-          <p:cNvPr id="2" name="Slide Image Placeholder 1"/>
-          <p:cNvSpPr>
-            <a:spLocks noGrp="1" noRot="1" noChangeAspect="1"/>
-          </p:cNvSpPr>
-          <p:nvPr>
-            <p:ph type="sldImg"/>
-          </p:nvPr>
-        </p:nvSpPr>
-        <p:spPr/>
-      </p:sp>
-      <p:sp>
-        <p:nvSpPr>
-          <p:cNvPr id="3" name="Notes Placeholder 2"/>
-          <p:cNvSpPr>
-            <a:spLocks noGrp="1"/>
-          </p:cNvSpPr>
-          <p:nvPr>
-            <p:ph type="body" idx="1"/>
-          </p:nvPr>
-        </p:nvSpPr>
-        <p:spPr/>
-        <p:txBody>
-          <a:bodyPr/>
-          <a:lstStyle/>
-          <a:p>
-            <a:endParaRPr lang="en-US" dirty="0"/>
-          </a:p>
-        </p:txBody>
-      </p:sp>
-      <p:sp>
-        <p:nvSpPr>
-          <p:cNvPr id="4" name="Slide Number Placeholder 3"/>
-          <p:cNvSpPr>
-            <a:spLocks noGrp="1"/>
-          </p:cNvSpPr>
-          <p:nvPr>
-            <p:ph type="sldNum" sz="quarter" idx="10"/>
-          </p:nvPr>
-        </p:nvSpPr>
-        <p:spPr/>
-        <p:txBody>
-          <a:bodyPr/>
-          <a:lstStyle/>
-          <a:p>
-            <a:fld id="{F7021451-1387-4CA6-816F-3879F97B5CBC}" type="slidenum">
-              <a:rPr lang="en-US"/>
-              <a:t>11</a:t>
-            </a:fld>
-            <a:endParaRPr lang="en-US"/>
-          </a:p>
-        </p:txBody>
-      </p:sp>
-    </p:spTree>
-    <p:extLst>
-      <p:ext uri="{BB962C8B-B14F-4D97-AF65-F5344CB8AC3E}">
-        <p14:creationId xmlns:p14="http://schemas.microsoft.com/office/powerpoint/2010/main" val="1024086991"/>
-      </p:ext>
-    </p:extLst>
-  </p:cSld>
-  <p:clrMapOvr>
-    <a:masterClrMapping/>
-  </p:clrMapOvr>
-</p:notes>
-</file>
-
-<file path=ppt/notesSlides/notesSlide12.xml><?xml version="1.0" encoding="utf-8"?>
-<p:notes xmlns:a="http://schemas.openxmlformats.org/drawingml/2006/main" xmlns:r="http://schemas.openxmlformats.org/officeDocument/2006/relationships" xmlns:p="http://schemas.openxmlformats.org/presentationml/2006/main">
-  <p:cSld>
-    <p:spTree>
-      <p:nvGrpSpPr>
-        <p:cNvPr id="1" name=""/>
-        <p:cNvGrpSpPr/>
-        <p:nvPr/>
-      </p:nvGrpSpPr>
-      <p:grpSpPr>
-        <a:xfrm>
-          <a:off x="0" y="0"/>
-          <a:ext cx="0" cy="0"/>
-          <a:chOff x="0" y="0"/>
-          <a:chExt cx="0" cy="0"/>
-        </a:xfrm>
-      </p:grpSpPr>
-      <p:sp>
-        <p:nvSpPr>
-          <p:cNvPr id="2" name="Slide Image Placeholder 1"/>
-          <p:cNvSpPr>
-            <a:spLocks noGrp="1" noRot="1" noChangeAspect="1"/>
-          </p:cNvSpPr>
-          <p:nvPr>
-            <p:ph type="sldImg"/>
-          </p:nvPr>
-        </p:nvSpPr>
-        <p:spPr/>
-      </p:sp>
-      <p:sp>
-        <p:nvSpPr>
-          <p:cNvPr id="3" name="Notes Placeholder 2"/>
-          <p:cNvSpPr>
-            <a:spLocks noGrp="1"/>
-          </p:cNvSpPr>
-          <p:nvPr>
-            <p:ph type="body" idx="1"/>
-          </p:nvPr>
-        </p:nvSpPr>
-        <p:spPr/>
-        <p:txBody>
-          <a:bodyPr/>
-          <a:lstStyle/>
-          <a:p>
-            <a:endParaRPr lang="en-US" dirty="0"/>
-          </a:p>
-        </p:txBody>
-      </p:sp>
-      <p:sp>
-        <p:nvSpPr>
-          <p:cNvPr id="4" name="Slide Number Placeholder 3"/>
-          <p:cNvSpPr>
-            <a:spLocks noGrp="1"/>
-          </p:cNvSpPr>
-          <p:nvPr>
-            <p:ph type="sldNum" sz="quarter" idx="10"/>
-          </p:nvPr>
-        </p:nvSpPr>
-        <p:spPr/>
-        <p:txBody>
-          <a:bodyPr/>
-          <a:lstStyle/>
-          <a:p>
-            <a:fld id="{F7021451-1387-4CA6-816F-3879F97B5CBC}" type="slidenum">
-              <a:rPr lang="en-US"/>
-              <a:t>12</a:t>
-            </a:fld>
-            <a:endParaRPr lang="en-US"/>
-          </a:p>
-        </p:txBody>
-      </p:sp>
-    </p:spTree>
-    <p:extLst>
-      <p:ext uri="{BB962C8B-B14F-4D97-AF65-F5344CB8AC3E}">
-        <p14:creationId xmlns:p14="http://schemas.microsoft.com/office/powerpoint/2010/main" val="1024086991"/>
-      </p:ext>
-    </p:extLst>
-  </p:cSld>
-  <p:clrMapOvr>
-    <a:masterClrMapping/>
-  </p:clrMapOvr>
-</p:notes>
-</file>
-
-<file path=ppt/notesSlides/notesSlide13.xml><?xml version="1.0" encoding="utf-8"?>
-<p:notes xmlns:a="http://schemas.openxmlformats.org/drawingml/2006/main" xmlns:r="http://schemas.openxmlformats.org/officeDocument/2006/relationships" xmlns:p="http://schemas.openxmlformats.org/presentationml/2006/main">
-  <p:cSld>
-    <p:spTree>
-      <p:nvGrpSpPr>
-        <p:cNvPr id="1" name=""/>
-        <p:cNvGrpSpPr/>
-        <p:nvPr/>
-      </p:nvGrpSpPr>
-      <p:grpSpPr>
-        <a:xfrm>
-          <a:off x="0" y="0"/>
-          <a:ext cx="0" cy="0"/>
-          <a:chOff x="0" y="0"/>
-          <a:chExt cx="0" cy="0"/>
-        </a:xfrm>
-      </p:grpSpPr>
-      <p:sp>
-        <p:nvSpPr>
-          <p:cNvPr id="2" name="Slide Image Placeholder 1"/>
-          <p:cNvSpPr>
-            <a:spLocks noGrp="1" noRot="1" noChangeAspect="1"/>
-          </p:cNvSpPr>
-          <p:nvPr>
-            <p:ph type="sldImg"/>
-          </p:nvPr>
-        </p:nvSpPr>
-        <p:spPr/>
-      </p:sp>
-      <p:sp>
-        <p:nvSpPr>
-          <p:cNvPr id="3" name="Notes Placeholder 2"/>
-          <p:cNvSpPr>
-            <a:spLocks noGrp="1"/>
-          </p:cNvSpPr>
-          <p:nvPr>
-            <p:ph type="body" idx="1"/>
-          </p:nvPr>
-        </p:nvSpPr>
-        <p:spPr/>
-        <p:txBody>
-          <a:bodyPr/>
-          <a:lstStyle/>
-          <a:p>
-            <a:endParaRPr lang="en-US" dirty="0"/>
-          </a:p>
-        </p:txBody>
-      </p:sp>
-      <p:sp>
-        <p:nvSpPr>
-          <p:cNvPr id="4" name="Slide Number Placeholder 3"/>
-          <p:cNvSpPr>
-            <a:spLocks noGrp="1"/>
-          </p:cNvSpPr>
-          <p:nvPr>
-            <p:ph type="sldNum" sz="quarter" idx="10"/>
-          </p:nvPr>
-        </p:nvSpPr>
-        <p:spPr/>
-        <p:txBody>
-          <a:bodyPr/>
-          <a:lstStyle/>
-          <a:p>
-            <a:fld id="{F7021451-1387-4CA6-816F-3879F97B5CBC}" type="slidenum">
-              <a:rPr lang="en-US"/>
-              <a:t>13</a:t>
-            </a:fld>
-            <a:endParaRPr lang="en-US"/>
-          </a:p>
-        </p:txBody>
-      </p:sp>
-    </p:spTree>
-    <p:extLst>
-      <p:ext uri="{BB962C8B-B14F-4D97-AF65-F5344CB8AC3E}">
-        <p14:creationId xmlns:p14="http://schemas.microsoft.com/office/powerpoint/2010/main" val="1024086991"/>
-      </p:ext>
-    </p:extLst>
-  </p:cSld>
-  <p:clrMapOvr>
-    <a:masterClrMapping/>
-  </p:clrMapOvr>
-</p:notes>
-</file>
-
-<file path=ppt/notesSlides/notesSlide14.xml><?xml version="1.0" encoding="utf-8"?>
-<p:notes xmlns:a="http://schemas.openxmlformats.org/drawingml/2006/main" xmlns:r="http://schemas.openxmlformats.org/officeDocument/2006/relationships" xmlns:p="http://schemas.openxmlformats.org/presentationml/2006/main">
-  <p:cSld>
-    <p:spTree>
-      <p:nvGrpSpPr>
-        <p:cNvPr id="1" name=""/>
-        <p:cNvGrpSpPr/>
-        <p:nvPr/>
-      </p:nvGrpSpPr>
-      <p:grpSpPr>
-        <a:xfrm>
-          <a:off x="0" y="0"/>
-          <a:ext cx="0" cy="0"/>
-          <a:chOff x="0" y="0"/>
-          <a:chExt cx="0" cy="0"/>
-        </a:xfrm>
-      </p:grpSpPr>
-      <p:sp>
-        <p:nvSpPr>
-          <p:cNvPr id="2" name="Slide Image Placeholder 1"/>
-          <p:cNvSpPr>
-            <a:spLocks noGrp="1" noRot="1" noChangeAspect="1"/>
-          </p:cNvSpPr>
-          <p:nvPr>
-            <p:ph type="sldImg"/>
-          </p:nvPr>
-        </p:nvSpPr>
-        <p:spPr/>
-      </p:sp>
-      <p:sp>
-        <p:nvSpPr>
-          <p:cNvPr id="3" name="Notes Placeholder 2"/>
-          <p:cNvSpPr>
-            <a:spLocks noGrp="1"/>
-          </p:cNvSpPr>
-          <p:nvPr>
-            <p:ph type="body" idx="1"/>
-          </p:nvPr>
-        </p:nvSpPr>
-        <p:spPr/>
-        <p:txBody>
-          <a:bodyPr/>
-          <a:lstStyle/>
-          <a:p>
-            <a:endParaRPr lang="en-US" dirty="0"/>
-          </a:p>
-        </p:txBody>
-      </p:sp>
-      <p:sp>
-        <p:nvSpPr>
-          <p:cNvPr id="4" name="Slide Number Placeholder 3"/>
-          <p:cNvSpPr>
-            <a:spLocks noGrp="1"/>
-          </p:cNvSpPr>
-          <p:nvPr>
-            <p:ph type="sldNum" sz="quarter" idx="10"/>
-          </p:nvPr>
-        </p:nvSpPr>
-        <p:spPr/>
-        <p:txBody>
-          <a:bodyPr/>
-          <a:lstStyle/>
-          <a:p>
-            <a:fld id="{F7021451-1387-4CA6-816F-3879F97B5CBC}" type="slidenum">
-              <a:rPr lang="en-US"/>
-              <a:t>14</a:t>
-            </a:fld>
-            <a:endParaRPr lang="en-US"/>
-          </a:p>
-        </p:txBody>
-      </p:sp>
-    </p:spTree>
-    <p:extLst>
-      <p:ext uri="{BB962C8B-B14F-4D97-AF65-F5344CB8AC3E}">
-        <p14:creationId xmlns:p14="http://schemas.microsoft.com/office/powerpoint/2010/main" val="1024086991"/>
-      </p:ext>
-    </p:extLst>
-  </p:cSld>
-  <p:clrMapOvr>
-    <a:masterClrMapping/>
-  </p:clrMapOvr>
-</p:notes>
-</file>
-
-<file path=ppt/notesSlides/notesSlide15.xml><?xml version="1.0" encoding="utf-8"?>
-<p:notes xmlns:a="http://schemas.openxmlformats.org/drawingml/2006/main" xmlns:r="http://schemas.openxmlformats.org/officeDocument/2006/relationships" xmlns:p="http://schemas.openxmlformats.org/presentationml/2006/main">
-  <p:cSld>
-    <p:spTree>
-      <p:nvGrpSpPr>
-        <p:cNvPr id="1" name=""/>
-        <p:cNvGrpSpPr/>
-        <p:nvPr/>
-      </p:nvGrpSpPr>
-      <p:grpSpPr>
-        <a:xfrm>
-          <a:off x="0" y="0"/>
-          <a:ext cx="0" cy="0"/>
-          <a:chOff x="0" y="0"/>
-          <a:chExt cx="0" cy="0"/>
-        </a:xfrm>
-      </p:grpSpPr>
-      <p:sp>
-        <p:nvSpPr>
-          <p:cNvPr id="2" name="Slide Image Placeholder 1"/>
-          <p:cNvSpPr>
-            <a:spLocks noGrp="1" noRot="1" noChangeAspect="1"/>
-          </p:cNvSpPr>
-          <p:nvPr>
-            <p:ph type="sldImg"/>
-          </p:nvPr>
-        </p:nvSpPr>
-        <p:spPr/>
-      </p:sp>
-      <p:sp>
-        <p:nvSpPr>
-          <p:cNvPr id="3" name="Notes Placeholder 2"/>
-          <p:cNvSpPr>
-            <a:spLocks noGrp="1"/>
-          </p:cNvSpPr>
-          <p:nvPr>
-            <p:ph type="body" idx="1"/>
-          </p:nvPr>
-        </p:nvSpPr>
-        <p:spPr/>
-        <p:txBody>
-          <a:bodyPr/>
-          <a:lstStyle/>
-          <a:p>
-            <a:endParaRPr lang="en-US" dirty="0"/>
-          </a:p>
-        </p:txBody>
-      </p:sp>
-      <p:sp>
-        <p:nvSpPr>
-          <p:cNvPr id="4" name="Slide Number Placeholder 3"/>
-          <p:cNvSpPr>
-            <a:spLocks noGrp="1"/>
-          </p:cNvSpPr>
-          <p:nvPr>
-            <p:ph type="sldNum" sz="quarter" idx="10"/>
-          </p:nvPr>
-        </p:nvSpPr>
-        <p:spPr/>
-        <p:txBody>
-          <a:bodyPr/>
-          <a:lstStyle/>
-          <a:p>
-            <a:fld id="{F7021451-1387-4CA6-816F-3879F97B5CBC}" type="slidenum">
-              <a:rPr lang="en-US"/>
-              <a:t>15</a:t>
-            </a:fld>
-            <a:endParaRPr lang="en-US"/>
-          </a:p>
-        </p:txBody>
-      </p:sp>
-    </p:spTree>
-    <p:extLst>
-      <p:ext uri="{BB962C8B-B14F-4D97-AF65-F5344CB8AC3E}">
-        <p14:creationId xmlns:p14="http://schemas.microsoft.com/office/powerpoint/2010/main" val="1024086991"/>
-      </p:ext>
-    </p:extLst>
-  </p:cSld>
-  <p:clrMapOvr>
-    <a:masterClrMapping/>
-  </p:clrMapOvr>
-</p:notes>
-</file>
-
-<file path=ppt/notesSlides/notesSlide16.xml><?xml version="1.0" encoding="utf-8"?>
-<p:notes xmlns:a="http://schemas.openxmlformats.org/drawingml/2006/main" xmlns:r="http://schemas.openxmlformats.org/officeDocument/2006/relationships" xmlns:p="http://schemas.openxmlformats.org/presentationml/2006/main">
-  <p:cSld>
-    <p:spTree>
-      <p:nvGrpSpPr>
-        <p:cNvPr id="1" name=""/>
-        <p:cNvGrpSpPr/>
-        <p:nvPr/>
-      </p:nvGrpSpPr>
-      <p:grpSpPr>
-        <a:xfrm>
-          <a:off x="0" y="0"/>
-          <a:ext cx="0" cy="0"/>
-          <a:chOff x="0" y="0"/>
-          <a:chExt cx="0" cy="0"/>
-        </a:xfrm>
-      </p:grpSpPr>
-      <p:sp>
-        <p:nvSpPr>
-          <p:cNvPr id="2" name="Slide Image Placeholder 1"/>
-          <p:cNvSpPr>
-            <a:spLocks noGrp="1" noRot="1" noChangeAspect="1"/>
-          </p:cNvSpPr>
-          <p:nvPr>
-            <p:ph type="sldImg"/>
-          </p:nvPr>
-        </p:nvSpPr>
-        <p:spPr/>
-      </p:sp>
-      <p:sp>
-        <p:nvSpPr>
-          <p:cNvPr id="3" name="Notes Placeholder 2"/>
-          <p:cNvSpPr>
-            <a:spLocks noGrp="1"/>
-          </p:cNvSpPr>
-          <p:nvPr>
-            <p:ph type="body" idx="1"/>
-          </p:nvPr>
-        </p:nvSpPr>
-        <p:spPr/>
-        <p:txBody>
-          <a:bodyPr/>
-          <a:lstStyle/>
-          <a:p>
-            <a:endParaRPr lang="en-US" dirty="0"/>
-          </a:p>
-        </p:txBody>
-      </p:sp>
-      <p:sp>
-        <p:nvSpPr>
-          <p:cNvPr id="4" name="Slide Number Placeholder 3"/>
-          <p:cNvSpPr>
-            <a:spLocks noGrp="1"/>
-          </p:cNvSpPr>
-          <p:nvPr>
-            <p:ph type="sldNum" sz="quarter" idx="10"/>
-          </p:nvPr>
-        </p:nvSpPr>
-        <p:spPr/>
-        <p:txBody>
-          <a:bodyPr/>
-          <a:lstStyle/>
-          <a:p>
-            <a:fld id="{F7021451-1387-4CA6-816F-3879F97B5CBC}" type="slidenum">
-              <a:rPr lang="en-US"/>
-              <a:t>16</a:t>
-            </a:fld>
-            <a:endParaRPr lang="en-US"/>
-          </a:p>
-        </p:txBody>
-      </p:sp>
-    </p:spTree>
-    <p:extLst>
-      <p:ext uri="{BB962C8B-B14F-4D97-AF65-F5344CB8AC3E}">
-        <p14:creationId xmlns:p14="http://schemas.microsoft.com/office/powerpoint/2010/main" val="1024086991"/>
-      </p:ext>
-    </p:extLst>
-  </p:cSld>
-  <p:clrMapOvr>
-    <a:masterClrMapping/>
-  </p:clrMapOvr>
-</p:notes>
-</file>
-
-<file path=ppt/notesSlides/notesSlide2.xml><?xml version="1.0" encoding="utf-8"?>
-<p:notes xmlns:a="http://schemas.openxmlformats.org/drawingml/2006/main" xmlns:r="http://schemas.openxmlformats.org/officeDocument/2006/relationships" xmlns:p="http://schemas.openxmlformats.org/presentationml/2006/main">
-  <p:cSld>
-    <p:spTree>
-      <p:nvGrpSpPr>
-        <p:cNvPr id="1" name=""/>
-        <p:cNvGrpSpPr/>
-        <p:nvPr/>
-      </p:nvGrpSpPr>
-      <p:grpSpPr>
-        <a:xfrm>
-          <a:off x="0" y="0"/>
-          <a:ext cx="0" cy="0"/>
-          <a:chOff x="0" y="0"/>
-          <a:chExt cx="0" cy="0"/>
-        </a:xfrm>
-      </p:grpSpPr>
-      <p:sp>
-        <p:nvSpPr>
-          <p:cNvPr id="2" name="Slide Image Placeholder 1"/>
-          <p:cNvSpPr>
-            <a:spLocks noGrp="1" noRot="1" noChangeAspect="1"/>
-          </p:cNvSpPr>
-          <p:nvPr>
-            <p:ph type="sldImg"/>
-          </p:nvPr>
-        </p:nvSpPr>
-        <p:spPr/>
-      </p:sp>
-      <p:sp>
-        <p:nvSpPr>
-          <p:cNvPr id="3" name="Notes Placeholder 2"/>
-          <p:cNvSpPr>
-            <a:spLocks noGrp="1"/>
-          </p:cNvSpPr>
-          <p:nvPr>
-            <p:ph type="body" idx="1"/>
-          </p:nvPr>
-        </p:nvSpPr>
-        <p:spPr/>
-        <p:txBody>
-          <a:bodyPr/>
-          <a:lstStyle/>
-          <a:p>
-            <a:endParaRPr lang="en-US" dirty="0"/>
-          </a:p>
-        </p:txBody>
-      </p:sp>
-      <p:sp>
-        <p:nvSpPr>
-          <p:cNvPr id="4" name="Slide Number Placeholder 3"/>
-          <p:cNvSpPr>
-            <a:spLocks noGrp="1"/>
-          </p:cNvSpPr>
-          <p:nvPr>
-            <p:ph type="sldNum" sz="quarter" idx="10"/>
-          </p:nvPr>
-        </p:nvSpPr>
-        <p:spPr/>
-        <p:txBody>
-          <a:bodyPr/>
-          <a:lstStyle/>
-          <a:p>
-            <a:fld id="{F7021451-1387-4CA6-816F-3879F97B5CBC}" type="slidenum">
-              <a:rPr lang="en-US"/>
-              <a:t>2</a:t>
-            </a:fld>
-            <a:endParaRPr lang="en-US"/>
-          </a:p>
-        </p:txBody>
-      </p:sp>
-    </p:spTree>
-    <p:extLst>
-      <p:ext uri="{BB962C8B-B14F-4D97-AF65-F5344CB8AC3E}">
-        <p14:creationId xmlns:p14="http://schemas.microsoft.com/office/powerpoint/2010/main" val="1024086991"/>
-      </p:ext>
-    </p:extLst>
-  </p:cSld>
-  <p:clrMapOvr>
-    <a:masterClrMapping/>
-  </p:clrMapOvr>
-</p:notes>
-</file>
-
-<file path=ppt/notesSlides/notesSlide3.xml><?xml version="1.0" encoding="utf-8"?>
-<p:notes xmlns:a="http://schemas.openxmlformats.org/drawingml/2006/main" xmlns:r="http://schemas.openxmlformats.org/officeDocument/2006/relationships" xmlns:p="http://schemas.openxmlformats.org/presentationml/2006/main">
-  <p:cSld>
-    <p:spTree>
-      <p:nvGrpSpPr>
-        <p:cNvPr id="1" name=""/>
-        <p:cNvGrpSpPr/>
-        <p:nvPr/>
-      </p:nvGrpSpPr>
-      <p:grpSpPr>
-        <a:xfrm>
-          <a:off x="0" y="0"/>
-          <a:ext cx="0" cy="0"/>
-          <a:chOff x="0" y="0"/>
-          <a:chExt cx="0" cy="0"/>
-        </a:xfrm>
-      </p:grpSpPr>
-      <p:sp>
-        <p:nvSpPr>
-          <p:cNvPr id="2" name="Slide Image Placeholder 1"/>
-          <p:cNvSpPr>
-            <a:spLocks noGrp="1" noRot="1" noChangeAspect="1"/>
-          </p:cNvSpPr>
-          <p:nvPr>
-            <p:ph type="sldImg"/>
-          </p:nvPr>
-        </p:nvSpPr>
-        <p:spPr/>
-      </p:sp>
-      <p:sp>
-        <p:nvSpPr>
-          <p:cNvPr id="3" name="Notes Placeholder 2"/>
-          <p:cNvSpPr>
-            <a:spLocks noGrp="1"/>
-          </p:cNvSpPr>
-          <p:nvPr>
-            <p:ph type="body" idx="1"/>
-          </p:nvPr>
-        </p:nvSpPr>
-        <p:spPr/>
-        <p:txBody>
-          <a:bodyPr/>
-          <a:lstStyle/>
-          <a:p>
-            <a:endParaRPr lang="en-US" dirty="0"/>
-          </a:p>
-        </p:txBody>
-      </p:sp>
-      <p:sp>
-        <p:nvSpPr>
-          <p:cNvPr id="4" name="Slide Number Placeholder 3"/>
-          <p:cNvSpPr>
-            <a:spLocks noGrp="1"/>
-          </p:cNvSpPr>
-          <p:nvPr>
-            <p:ph type="sldNum" sz="quarter" idx="10"/>
-          </p:nvPr>
-        </p:nvSpPr>
-        <p:spPr/>
-        <p:txBody>
-          <a:bodyPr/>
-          <a:lstStyle/>
-          <a:p>
-            <a:fld id="{F7021451-1387-4CA6-816F-3879F97B5CBC}" type="slidenum">
-              <a:rPr lang="en-US"/>
-              <a:t>3</a:t>
-            </a:fld>
-            <a:endParaRPr lang="en-US"/>
-          </a:p>
-        </p:txBody>
-      </p:sp>
-    </p:spTree>
-    <p:extLst>
-      <p:ext uri="{BB962C8B-B14F-4D97-AF65-F5344CB8AC3E}">
-        <p14:creationId xmlns:p14="http://schemas.microsoft.com/office/powerpoint/2010/main" val="1024086991"/>
-      </p:ext>
-    </p:extLst>
-  </p:cSld>
-  <p:clrMapOvr>
-    <a:masterClrMapping/>
-  </p:clrMapOvr>
-</p:notes>
-</file>
-
-<file path=ppt/notesSlides/notesSlide4.xml><?xml version="1.0" encoding="utf-8"?>
-<p:notes xmlns:a="http://schemas.openxmlformats.org/drawingml/2006/main" xmlns:r="http://schemas.openxmlformats.org/officeDocument/2006/relationships" xmlns:p="http://schemas.openxmlformats.org/presentationml/2006/main">
-  <p:cSld>
-    <p:spTree>
-      <p:nvGrpSpPr>
-        <p:cNvPr id="1" name=""/>
-        <p:cNvGrpSpPr/>
-        <p:nvPr/>
-      </p:nvGrpSpPr>
-      <p:grpSpPr>
-        <a:xfrm>
-          <a:off x="0" y="0"/>
-          <a:ext cx="0" cy="0"/>
-          <a:chOff x="0" y="0"/>
-          <a:chExt cx="0" cy="0"/>
-        </a:xfrm>
-      </p:grpSpPr>
-      <p:sp>
-        <p:nvSpPr>
-          <p:cNvPr id="2" name="Slide Image Placeholder 1"/>
-          <p:cNvSpPr>
-            <a:spLocks noGrp="1" noRot="1" noChangeAspect="1"/>
-          </p:cNvSpPr>
-          <p:nvPr>
-            <p:ph type="sldImg"/>
-          </p:nvPr>
-        </p:nvSpPr>
-        <p:spPr/>
-      </p:sp>
-      <p:sp>
-        <p:nvSpPr>
-          <p:cNvPr id="3" name="Notes Placeholder 2"/>
-          <p:cNvSpPr>
-            <a:spLocks noGrp="1"/>
-          </p:cNvSpPr>
-          <p:nvPr>
-            <p:ph type="body" idx="1"/>
-          </p:nvPr>
-        </p:nvSpPr>
-        <p:spPr/>
-        <p:txBody>
-          <a:bodyPr/>
-          <a:lstStyle/>
-          <a:p>
-            <a:endParaRPr lang="en-US" dirty="0"/>
-          </a:p>
-        </p:txBody>
-      </p:sp>
-      <p:sp>
-        <p:nvSpPr>
-          <p:cNvPr id="4" name="Slide Number Placeholder 3"/>
-          <p:cNvSpPr>
-            <a:spLocks noGrp="1"/>
-          </p:cNvSpPr>
-          <p:nvPr>
-            <p:ph type="sldNum" sz="quarter" idx="10"/>
-          </p:nvPr>
-        </p:nvSpPr>
-        <p:spPr/>
-        <p:txBody>
-          <a:bodyPr/>
-          <a:lstStyle/>
-          <a:p>
-            <a:fld id="{F7021451-1387-4CA6-816F-3879F97B5CBC}" type="slidenum">
-              <a:rPr lang="en-US"/>
-              <a:t>4</a:t>
-            </a:fld>
-            <a:endParaRPr lang="en-US"/>
-          </a:p>
-        </p:txBody>
-      </p:sp>
-    </p:spTree>
-    <p:extLst>
-      <p:ext uri="{BB962C8B-B14F-4D97-AF65-F5344CB8AC3E}">
-        <p14:creationId xmlns:p14="http://schemas.microsoft.com/office/powerpoint/2010/main" val="1024086991"/>
-      </p:ext>
-    </p:extLst>
-  </p:cSld>
-  <p:clrMapOvr>
-    <a:masterClrMapping/>
-  </p:clrMapOvr>
-</p:notes>
-</file>
-
-<file path=ppt/notesSlides/notesSlide5.xml><?xml version="1.0" encoding="utf-8"?>
-<p:notes xmlns:a="http://schemas.openxmlformats.org/drawingml/2006/main" xmlns:r="http://schemas.openxmlformats.org/officeDocument/2006/relationships" xmlns:p="http://schemas.openxmlformats.org/presentationml/2006/main">
-  <p:cSld>
-    <p:spTree>
-      <p:nvGrpSpPr>
-        <p:cNvPr id="1" name=""/>
-        <p:cNvGrpSpPr/>
-        <p:nvPr/>
-      </p:nvGrpSpPr>
-      <p:grpSpPr>
-        <a:xfrm>
-          <a:off x="0" y="0"/>
-          <a:ext cx="0" cy="0"/>
-          <a:chOff x="0" y="0"/>
-          <a:chExt cx="0" cy="0"/>
-        </a:xfrm>
-      </p:grpSpPr>
-      <p:sp>
-        <p:nvSpPr>
-          <p:cNvPr id="2" name="Slide Image Placeholder 1"/>
-          <p:cNvSpPr>
-            <a:spLocks noGrp="1" noRot="1" noChangeAspect="1"/>
-          </p:cNvSpPr>
-          <p:nvPr>
-            <p:ph type="sldImg"/>
-          </p:nvPr>
-        </p:nvSpPr>
-        <p:spPr/>
-      </p:sp>
-      <p:sp>
-        <p:nvSpPr>
-          <p:cNvPr id="3" name="Notes Placeholder 2"/>
-          <p:cNvSpPr>
-            <a:spLocks noGrp="1"/>
-          </p:cNvSpPr>
-          <p:nvPr>
-            <p:ph type="body" idx="1"/>
-          </p:nvPr>
-        </p:nvSpPr>
-        <p:spPr/>
-        <p:txBody>
-          <a:bodyPr/>
-          <a:lstStyle/>
-          <a:p>
-            <a:endParaRPr lang="en-US" dirty="0"/>
-          </a:p>
-        </p:txBody>
-      </p:sp>
-      <p:sp>
-        <p:nvSpPr>
-          <p:cNvPr id="4" name="Slide Number Placeholder 3"/>
-          <p:cNvSpPr>
-            <a:spLocks noGrp="1"/>
-          </p:cNvSpPr>
-          <p:nvPr>
-            <p:ph type="sldNum" sz="quarter" idx="10"/>
-          </p:nvPr>
-        </p:nvSpPr>
-        <p:spPr/>
-        <p:txBody>
-          <a:bodyPr/>
-          <a:lstStyle/>
-          <a:p>
-            <a:fld id="{F7021451-1387-4CA6-816F-3879F97B5CBC}" type="slidenum">
-              <a:rPr lang="en-US"/>
-              <a:t>5</a:t>
-            </a:fld>
-            <a:endParaRPr lang="en-US"/>
-          </a:p>
-        </p:txBody>
-      </p:sp>
-    </p:spTree>
-    <p:extLst>
-      <p:ext uri="{BB962C8B-B14F-4D97-AF65-F5344CB8AC3E}">
-        <p14:creationId xmlns:p14="http://schemas.microsoft.com/office/powerpoint/2010/main" val="1024086991"/>
-      </p:ext>
-    </p:extLst>
-  </p:cSld>
-  <p:clrMapOvr>
-    <a:masterClrMapping/>
-  </p:clrMapOvr>
-</p:notes>
-</file>
-
-<file path=ppt/notesSlides/notesSlide6.xml><?xml version="1.0" encoding="utf-8"?>
-<p:notes xmlns:a="http://schemas.openxmlformats.org/drawingml/2006/main" xmlns:r="http://schemas.openxmlformats.org/officeDocument/2006/relationships" xmlns:p="http://schemas.openxmlformats.org/presentationml/2006/main">
-  <p:cSld>
-    <p:spTree>
-      <p:nvGrpSpPr>
-        <p:cNvPr id="1" name=""/>
-        <p:cNvGrpSpPr/>
-        <p:nvPr/>
-      </p:nvGrpSpPr>
-      <p:grpSpPr>
-        <a:xfrm>
-          <a:off x="0" y="0"/>
-          <a:ext cx="0" cy="0"/>
-          <a:chOff x="0" y="0"/>
-          <a:chExt cx="0" cy="0"/>
-        </a:xfrm>
-      </p:grpSpPr>
-      <p:sp>
-        <p:nvSpPr>
-          <p:cNvPr id="2" name="Slide Image Placeholder 1"/>
-          <p:cNvSpPr>
-            <a:spLocks noGrp="1" noRot="1" noChangeAspect="1"/>
-          </p:cNvSpPr>
-          <p:nvPr>
-            <p:ph type="sldImg"/>
-          </p:nvPr>
-        </p:nvSpPr>
-        <p:spPr/>
-      </p:sp>
-      <p:sp>
-        <p:nvSpPr>
-          <p:cNvPr id="3" name="Notes Placeholder 2"/>
-          <p:cNvSpPr>
-            <a:spLocks noGrp="1"/>
-          </p:cNvSpPr>
-          <p:nvPr>
-            <p:ph type="body" idx="1"/>
-          </p:nvPr>
-        </p:nvSpPr>
-        <p:spPr/>
-        <p:txBody>
-          <a:bodyPr/>
-          <a:lstStyle/>
-          <a:p>
-            <a:endParaRPr lang="en-US" dirty="0"/>
-          </a:p>
-        </p:txBody>
-      </p:sp>
-      <p:sp>
-        <p:nvSpPr>
-          <p:cNvPr id="4" name="Slide Number Placeholder 3"/>
-          <p:cNvSpPr>
-            <a:spLocks noGrp="1"/>
-          </p:cNvSpPr>
-          <p:nvPr>
-            <p:ph type="sldNum" sz="quarter" idx="10"/>
-          </p:nvPr>
-        </p:nvSpPr>
-        <p:spPr/>
-        <p:txBody>
-          <a:bodyPr/>
-          <a:lstStyle/>
-          <a:p>
-            <a:fld id="{F7021451-1387-4CA6-816F-3879F97B5CBC}" type="slidenum">
-              <a:rPr lang="en-US"/>
-              <a:t>6</a:t>
-            </a:fld>
-            <a:endParaRPr lang="en-US"/>
-          </a:p>
-        </p:txBody>
-      </p:sp>
-    </p:spTree>
-    <p:extLst>
-      <p:ext uri="{BB962C8B-B14F-4D97-AF65-F5344CB8AC3E}">
-        <p14:creationId xmlns:p14="http://schemas.microsoft.com/office/powerpoint/2010/main" val="1024086991"/>
-      </p:ext>
-    </p:extLst>
-  </p:cSld>
-  <p:clrMapOvr>
-    <a:masterClrMapping/>
-  </p:clrMapOvr>
-</p:notes>
-</file>
-
-<file path=ppt/notesSlides/notesSlide7.xml><?xml version="1.0" encoding="utf-8"?>
-<p:notes xmlns:a="http://schemas.openxmlformats.org/drawingml/2006/main" xmlns:r="http://schemas.openxmlformats.org/officeDocument/2006/relationships" xmlns:p="http://schemas.openxmlformats.org/presentationml/2006/main">
-  <p:cSld>
-    <p:spTree>
-      <p:nvGrpSpPr>
-        <p:cNvPr id="1" name=""/>
-        <p:cNvGrpSpPr/>
-        <p:nvPr/>
-      </p:nvGrpSpPr>
-      <p:grpSpPr>
-        <a:xfrm>
-          <a:off x="0" y="0"/>
-          <a:ext cx="0" cy="0"/>
-          <a:chOff x="0" y="0"/>
-          <a:chExt cx="0" cy="0"/>
-        </a:xfrm>
-      </p:grpSpPr>
-      <p:sp>
-        <p:nvSpPr>
-          <p:cNvPr id="2" name="Slide Image Placeholder 1"/>
-          <p:cNvSpPr>
-            <a:spLocks noGrp="1" noRot="1" noChangeAspect="1"/>
-          </p:cNvSpPr>
-          <p:nvPr>
-            <p:ph type="sldImg"/>
-          </p:nvPr>
-        </p:nvSpPr>
-        <p:spPr/>
-      </p:sp>
-      <p:sp>
-        <p:nvSpPr>
-          <p:cNvPr id="3" name="Notes Placeholder 2"/>
-          <p:cNvSpPr>
-            <a:spLocks noGrp="1"/>
-          </p:cNvSpPr>
-          <p:nvPr>
-            <p:ph type="body" idx="1"/>
-          </p:nvPr>
-        </p:nvSpPr>
-        <p:spPr/>
-        <p:txBody>
-          <a:bodyPr/>
-          <a:lstStyle/>
-          <a:p>
-            <a:endParaRPr lang="en-US" dirty="0"/>
-          </a:p>
-        </p:txBody>
-      </p:sp>
-      <p:sp>
-        <p:nvSpPr>
-          <p:cNvPr id="4" name="Slide Number Placeholder 3"/>
-          <p:cNvSpPr>
-            <a:spLocks noGrp="1"/>
-          </p:cNvSpPr>
-          <p:nvPr>
-            <p:ph type="sldNum" sz="quarter" idx="10"/>
-          </p:nvPr>
-        </p:nvSpPr>
-        <p:spPr/>
-        <p:txBody>
-          <a:bodyPr/>
-          <a:lstStyle/>
-          <a:p>
-            <a:fld id="{F7021451-1387-4CA6-816F-3879F97B5CBC}" type="slidenum">
-              <a:rPr lang="en-US"/>
-              <a:t>7</a:t>
-            </a:fld>
-            <a:endParaRPr lang="en-US"/>
-          </a:p>
-        </p:txBody>
-      </p:sp>
-    </p:spTree>
-    <p:extLst>
-      <p:ext uri="{BB962C8B-B14F-4D97-AF65-F5344CB8AC3E}">
-        <p14:creationId xmlns:p14="http://schemas.microsoft.com/office/powerpoint/2010/main" val="1024086991"/>
-      </p:ext>
-    </p:extLst>
-  </p:cSld>
-  <p:clrMapOvr>
-    <a:masterClrMapping/>
-  </p:clrMapOvr>
-</p:notes>
-</file>
-
-<file path=ppt/notesSlides/notesSlide8.xml><?xml version="1.0" encoding="utf-8"?>
-<p:notes xmlns:a="http://schemas.openxmlformats.org/drawingml/2006/main" xmlns:r="http://schemas.openxmlformats.org/officeDocument/2006/relationships" xmlns:p="http://schemas.openxmlformats.org/presentationml/2006/main">
-  <p:cSld>
-    <p:spTree>
-      <p:nvGrpSpPr>
-        <p:cNvPr id="1" name=""/>
-        <p:cNvGrpSpPr/>
-        <p:nvPr/>
-      </p:nvGrpSpPr>
-      <p:grpSpPr>
-        <a:xfrm>
-          <a:off x="0" y="0"/>
-          <a:ext cx="0" cy="0"/>
-          <a:chOff x="0" y="0"/>
-          <a:chExt cx="0" cy="0"/>
-        </a:xfrm>
-      </p:grpSpPr>
-      <p:sp>
-        <p:nvSpPr>
-          <p:cNvPr id="2" name="Slide Image Placeholder 1"/>
-          <p:cNvSpPr>
-            <a:spLocks noGrp="1" noRot="1" noChangeAspect="1"/>
-          </p:cNvSpPr>
-          <p:nvPr>
-            <p:ph type="sldImg"/>
-          </p:nvPr>
-        </p:nvSpPr>
-        <p:spPr/>
-      </p:sp>
-      <p:sp>
-        <p:nvSpPr>
-          <p:cNvPr id="3" name="Notes Placeholder 2"/>
-          <p:cNvSpPr>
-            <a:spLocks noGrp="1"/>
-          </p:cNvSpPr>
-          <p:nvPr>
-            <p:ph type="body" idx="1"/>
-          </p:nvPr>
-        </p:nvSpPr>
-        <p:spPr/>
-        <p:txBody>
-          <a:bodyPr/>
-          <a:lstStyle/>
-          <a:p>
-            <a:endParaRPr lang="en-US" dirty="0"/>
-          </a:p>
-        </p:txBody>
-      </p:sp>
-      <p:sp>
-        <p:nvSpPr>
-          <p:cNvPr id="4" name="Slide Number Placeholder 3"/>
-          <p:cNvSpPr>
-            <a:spLocks noGrp="1"/>
-          </p:cNvSpPr>
-          <p:nvPr>
-            <p:ph type="sldNum" sz="quarter" idx="10"/>
-          </p:nvPr>
-        </p:nvSpPr>
-        <p:spPr/>
-        <p:txBody>
-          <a:bodyPr/>
-          <a:lstStyle/>
-          <a:p>
-            <a:fld id="{F7021451-1387-4CA6-816F-3879F97B5CBC}" type="slidenum">
-              <a:rPr lang="en-US"/>
-              <a:t>8</a:t>
-            </a:fld>
-            <a:endParaRPr lang="en-US"/>
-          </a:p>
-        </p:txBody>
-      </p:sp>
-    </p:spTree>
-    <p:extLst>
-      <p:ext uri="{BB962C8B-B14F-4D97-AF65-F5344CB8AC3E}">
-        <p14:creationId xmlns:p14="http://schemas.microsoft.com/office/powerpoint/2010/main" val="1024086991"/>
-      </p:ext>
-    </p:extLst>
-  </p:cSld>
-  <p:clrMapOvr>
-    <a:masterClrMapping/>
-  </p:clrMapOvr>
-</p:notes>
-</file>
-
-<file path=ppt/notesSlides/notesSlide9.xml><?xml version="1.0" encoding="utf-8"?>
-<p:notes xmlns:a="http://schemas.openxmlformats.org/drawingml/2006/main" xmlns:r="http://schemas.openxmlformats.org/officeDocument/2006/relationships" xmlns:p="http://schemas.openxmlformats.org/presentationml/2006/main">
-  <p:cSld>
-    <p:spTree>
-      <p:nvGrpSpPr>
-        <p:cNvPr id="1" name=""/>
-        <p:cNvGrpSpPr/>
-        <p:nvPr/>
-      </p:nvGrpSpPr>
-      <p:grpSpPr>
-        <a:xfrm>
-          <a:off x="0" y="0"/>
-          <a:ext cx="0" cy="0"/>
-          <a:chOff x="0" y="0"/>
-          <a:chExt cx="0" cy="0"/>
-        </a:xfrm>
-      </p:grpSpPr>
-      <p:sp>
-        <p:nvSpPr>
-          <p:cNvPr id="2" name="Slide Image Placeholder 1"/>
-          <p:cNvSpPr>
-            <a:spLocks noGrp="1" noRot="1" noChangeAspect="1"/>
-          </p:cNvSpPr>
-          <p:nvPr>
-            <p:ph type="sldImg"/>
-          </p:nvPr>
-        </p:nvSpPr>
-        <p:spPr/>
-      </p:sp>
-      <p:sp>
-        <p:nvSpPr>
-          <p:cNvPr id="3" name="Notes Placeholder 2"/>
-          <p:cNvSpPr>
-            <a:spLocks noGrp="1"/>
-          </p:cNvSpPr>
-          <p:nvPr>
-            <p:ph type="body" idx="1"/>
-          </p:nvPr>
-        </p:nvSpPr>
-        <p:spPr/>
-        <p:txBody>
-          <a:bodyPr/>
-          <a:lstStyle/>
-          <a:p>
-            <a:endParaRPr lang="en-US" dirty="0"/>
-          </a:p>
-        </p:txBody>
-      </p:sp>
-      <p:sp>
-        <p:nvSpPr>
-          <p:cNvPr id="4" name="Slide Number Placeholder 3"/>
-          <p:cNvSpPr>
-            <a:spLocks noGrp="1"/>
-          </p:cNvSpPr>
-          <p:nvPr>
-            <p:ph type="sldNum" sz="quarter" idx="10"/>
-          </p:nvPr>
-        </p:nvSpPr>
-        <p:spPr/>
-        <p:txBody>
-          <a:bodyPr/>
-          <a:lstStyle/>
-          <a:p>
-            <a:fld id="{F7021451-1387-4CA6-816F-3879F97B5CBC}" type="slidenum">
-              <a:rPr lang="en-US"/>
-              <a:t>9</a:t>
-            </a:fld>
-            <a:endParaRPr lang="en-US"/>
-          </a:p>
-        </p:txBody>
-      </p:sp>
-    </p:spTree>
-    <p:extLst>
-      <p:ext uri="{BB962C8B-B14F-4D97-AF65-F5344CB8AC3E}">
-        <p14:creationId xmlns:p14="http://schemas.microsoft.com/office/powerpoint/2010/main" val="1024086991"/>
-      </p:ext>
-    </p:extLst>
-  </p:cSld>
-  <p:clrMapOvr>
-    <a:masterClrMapping/>
-  </p:clrMapOvr>
-</p:notes>
-</file>
-
-<file path=ppt/slideLayouts/slideLayout1.xml><?xml version="1.0" encoding="utf-8"?>
+<file path=ppt\slideLayouts\slideLayout1.xml><?xml version="1.0" encoding="utf-8"?>
 <p:sldLayout xmlns:a="http://schemas.openxmlformats.org/drawingml/2006/main" xmlns:r="http://schemas.openxmlformats.org/officeDocument/2006/relationships" xmlns:p="http://schemas.openxmlformats.org/presentationml/2006/main" preserve="1">
   <p:cSld name="DEFAULT">
     <p:bg>
@@ -1626,7 +1720,7 @@
 </p:sldLayout>
 </file>
 
-<file path=ppt/slideMasters/slideMaster1.xml><?xml version="1.0" encoding="utf-8"?>
+<file path=ppt\slideMasters\slideMaster1.xml><?xml version="1.0" encoding="utf-8"?>
 <p:sldMaster xmlns:a="http://schemas.openxmlformats.org/drawingml/2006/main" xmlns:r="http://schemas.openxmlformats.org/officeDocument/2006/relationships" xmlns:p="http://schemas.openxmlformats.org/presentationml/2006/main">
   <p:cSld>
     <p:bg>
@@ -1908,7 +2002,7 @@
 </p:sldMaster>
 </file>
 
-<file path=ppt/slides/slide1.xml><?xml version="1.0" encoding="utf-8"?>
+<file path=ppt\slides\slide1.xml><?xml version="1.0" encoding="utf-8"?>
 <p:sld xmlns:a="http://schemas.openxmlformats.org/drawingml/2006/main" xmlns:r="http://schemas.openxmlformats.org/officeDocument/2006/relationships" xmlns:p="http://schemas.openxmlformats.org/presentationml/2006/main">
   <p:cSld name="Slide 1">
     <p:bg>
@@ -2381,7 +2475,7 @@
 </p:sld>
 </file>
 
-<file path=ppt/slides/slide10.xml><?xml version="1.0" encoding="utf-8"?>
+<file path=ppt\slides\slide10.xml><?xml version="1.0" encoding="utf-8"?>
 <p:sld xmlns:a="http://schemas.openxmlformats.org/drawingml/2006/main" xmlns:r="http://schemas.openxmlformats.org/officeDocument/2006/relationships" xmlns:p="http://schemas.openxmlformats.org/presentationml/2006/main">
   <p:cSld name="Slide 10">
     <p:bg>
@@ -3299,7 +3393,7 @@
 </p:sld>
 </file>
 
-<file path=ppt/slides/slide11.xml><?xml version="1.0" encoding="utf-8"?>
+<file path=ppt\slides\slide11.xml><?xml version="1.0" encoding="utf-8"?>
 <p:sld xmlns:a="http://schemas.openxmlformats.org/drawingml/2006/main" xmlns:r="http://schemas.openxmlformats.org/officeDocument/2006/relationships" xmlns:p="http://schemas.openxmlformats.org/presentationml/2006/main">
   <p:cSld name="Slide 11">
     <p:bg>
@@ -4895,7 +4989,7 @@
 </p:sld>
 </file>
 
-<file path=ppt/slides/slide12.xml><?xml version="1.0" encoding="utf-8"?>
+<file path=ppt\slides\slide12.xml><?xml version="1.0" encoding="utf-8"?>
 <p:sld xmlns:a="http://schemas.openxmlformats.org/drawingml/2006/main" xmlns:r="http://schemas.openxmlformats.org/officeDocument/2006/relationships" xmlns:p="http://schemas.openxmlformats.org/presentationml/2006/main">
   <p:cSld name="Slide 12">
     <p:bg>
@@ -5872,7 +5966,7 @@
 </p:sld>
 </file>
 
-<file path=ppt/slides/slide13.xml><?xml version="1.0" encoding="utf-8"?>
+<file path=ppt\slides\slide13.xml><?xml version="1.0" encoding="utf-8"?>
 <p:sld xmlns:a="http://schemas.openxmlformats.org/drawingml/2006/main" xmlns:r="http://schemas.openxmlformats.org/officeDocument/2006/relationships" xmlns:p="http://schemas.openxmlformats.org/presentationml/2006/main">
   <p:cSld name="Slide 13">
     <p:bg>
@@ -6812,7 +6906,7 @@
 </p:sld>
 </file>
 
-<file path=ppt/slides/slide14.xml><?xml version="1.0" encoding="utf-8"?>
+<file path=ppt\slides\slide14.xml><?xml version="1.0" encoding="utf-8"?>
 <p:sld xmlns:a="http://schemas.openxmlformats.org/drawingml/2006/main" xmlns:r="http://schemas.openxmlformats.org/officeDocument/2006/relationships" xmlns:p="http://schemas.openxmlformats.org/presentationml/2006/main">
   <p:cSld name="Slide 14">
     <p:bg>
@@ -7700,7 +7794,7 @@
 </p:sld>
 </file>
 
-<file path=ppt/slides/slide15.xml><?xml version="1.0" encoding="utf-8"?>
+<file path=ppt\slides\slide15.xml><?xml version="1.0" encoding="utf-8"?>
 <p:sld xmlns:a="http://schemas.openxmlformats.org/drawingml/2006/main" xmlns:r="http://schemas.openxmlformats.org/officeDocument/2006/relationships" xmlns:p="http://schemas.openxmlformats.org/presentationml/2006/main">
   <p:cSld name="Slide 15">
     <p:bg>
@@ -9511,7 +9605,7 @@
 </p:sld>
 </file>
 
-<file path=ppt/slides/slide16.xml><?xml version="1.0" encoding="utf-8"?>
+<file path=ppt\slides\slide16.xml><?xml version="1.0" encoding="utf-8"?>
 <p:sld xmlns:a="http://schemas.openxmlformats.org/drawingml/2006/main" xmlns:r="http://schemas.openxmlformats.org/officeDocument/2006/relationships" xmlns:p="http://schemas.openxmlformats.org/presentationml/2006/main">
   <p:cSld name="Slide 16">
     <p:bg>
@@ -9913,7 +10007,7 @@
 </p:sld>
 </file>
 
-<file path=ppt/slides/slide2.xml><?xml version="1.0" encoding="utf-8"?>
+<file path=ppt\slides\slide2.xml><?xml version="1.0" encoding="utf-8"?>
 <p:sld xmlns:a="http://schemas.openxmlformats.org/drawingml/2006/main" xmlns:r="http://schemas.openxmlformats.org/officeDocument/2006/relationships" xmlns:p="http://schemas.openxmlformats.org/presentationml/2006/main">
   <p:cSld name="Slide 2">
     <p:bg>
@@ -10549,7 +10643,7 @@
 </p:sld>
 </file>
 
-<file path=ppt/slides/slide3.xml><?xml version="1.0" encoding="utf-8"?>
+<file path=ppt\slides\slide3.xml><?xml version="1.0" encoding="utf-8"?>
 <p:sld xmlns:a="http://schemas.openxmlformats.org/drawingml/2006/main" xmlns:r="http://schemas.openxmlformats.org/officeDocument/2006/relationships" xmlns:p="http://schemas.openxmlformats.org/presentationml/2006/main">
   <p:cSld name="Slide 3">
     <p:bg>
@@ -10774,7 +10868,7 @@
                 <a:ea typeface="Calibri" pitchFamily="34" charset="-122"/>
                 <a:cs typeface="Calibri" pitchFamily="34" charset="-120"/>
               </a:rPr>
-              <a:t>An opinionated .NET library for building production-grade multi-agent AI systems — with authentication, memory, context, streaming, telemetry, and evaluation built in.</a:t>
+              <a:t>An opinionated .NET library for building production-grade multi-agent AI systems â€” with authentication, memory, context, streaming, telemetry, and evaluation built in.</a:t>
             </a:r>
             <a:endParaRPr lang="en-US" sz="1550" dirty="0"/>
           </a:p>
@@ -11072,7 +11166,7 @@
                 <a:ea typeface="Calibri" pitchFamily="34" charset="-122"/>
                 <a:cs typeface="Calibri" pitchFamily="34" charset="-120"/>
               </a:rPr>
-              <a:t>Prescribes how agents, routing, memory, and telemetry wire together. Convention over configuration — most things work without ceremony.</a:t>
+              <a:t>Prescribes how agents, routing, memory, and telemetry wire together. Convention over configuration â€” most things work without ceremony.</a:t>
             </a:r>
             <a:endParaRPr lang="en-US" sz="1200" dirty="0"/>
           </a:p>
@@ -11221,7 +11315,7 @@
                 <a:ea typeface="Calibri" pitchFamily="34" charset="-122"/>
                 <a:cs typeface="Calibri" pitchFamily="34" charset="-120"/>
               </a:rPr>
-              <a:t>Azure OpenAI, Cosmos, Redis, AI Search, and App Insights are the default backing services — all configurable and replaceable.</a:t>
+              <a:t>Azure OpenAI, Document Intelligence, Cosmos, Redis, AI Search, and App Insights are the default backing services — all configurable and replaceable.</a:t>
             </a:r>
             <a:endParaRPr lang="en-US" sz="1200" dirty="0"/>
           </a:p>
@@ -11384,7 +11478,7 @@
 </p:sld>
 </file>
 
-<file path=ppt/slides/slide4.xml><?xml version="1.0" encoding="utf-8"?>
+<file path=ppt\slides\slide4.xml><?xml version="1.0" encoding="utf-8"?>
 <p:sld xmlns:a="http://schemas.openxmlformats.org/drawingml/2006/main" xmlns:r="http://schemas.openxmlformats.org/officeDocument/2006/relationships" xmlns:p="http://schemas.openxmlformats.org/presentationml/2006/main">
   <p:cSld name="Slide 4">
     <p:bg>
@@ -12269,7 +12363,7 @@
 </p:sld>
 </file>
 
-<file path=ppt/slides/slide5.xml><?xml version="1.0" encoding="utf-8"?>
+<file path=ppt\slides\slide5.xml><?xml version="1.0" encoding="utf-8"?>
 <p:sld xmlns:a="http://schemas.openxmlformats.org/drawingml/2006/main" xmlns:r="http://schemas.openxmlformats.org/officeDocument/2006/relationships" xmlns:p="http://schemas.openxmlformats.org/presentationml/2006/main">
   <p:cSld name="Slide 5">
     <p:bg>
@@ -13923,7 +14017,7 @@
                 <a:ea typeface="Calibri" pitchFamily="34" charset="-122"/>
                 <a:cs typeface="Calibri" pitchFamily="34" charset="-120"/>
               </a:rPr>
-              <a:t>AI Search</a:t>
+              <a:t>AI Search + Doc Intel</a:t>
             </a:r>
             <a:endParaRPr lang="en-US" sz="1050" dirty="0"/>
           </a:p>
@@ -14040,7 +14134,7 @@
                 <a:ea typeface="Calibri" pitchFamily="34" charset="-122"/>
                 <a:cs typeface="Calibri" pitchFamily="34" charset="-120"/>
               </a:rPr>
-              <a:t>MAF provides the composition model. HelpdeskAI shows one Azure-backed implementation of it - Redis for memory, Cosmos for ticket persistence, AI Search for KB.</a:t>
+              <a:t>MAF provides the composition model. HelpdeskAI shows one Azure-backed implementation of it - Redis for memory, Cosmos for ticket persistence, AI Search for KB, and Document Intelligence for PDF/DOCX OCR.</a:t>
             </a:r>
             <a:endParaRPr lang="en-US" sz="1200" dirty="0"/>
           </a:p>
@@ -14054,7 +14148,7 @@
 </p:sld>
 </file>
 
-<file path=ppt/slides/slide6.xml><?xml version="1.0" encoding="utf-8"?>
+<file path=ppt\slides\slide6.xml><?xml version="1.0" encoding="utf-8"?>
 <p:sld xmlns:a="http://schemas.openxmlformats.org/drawingml/2006/main" xmlns:r="http://schemas.openxmlformats.org/officeDocument/2006/relationships" xmlns:p="http://schemas.openxmlformats.org/presentationml/2006/main">
   <p:cSld name="Slide 6">
     <p:bg>
@@ -15786,7 +15880,7 @@
 </p:sld>
 </file>
 
-<file path=ppt/slides/slide7.xml><?xml version="1.0" encoding="utf-8"?>
+<file path=ppt\slides\slide7.xml><?xml version="1.0" encoding="utf-8"?>
 <p:sld xmlns:a="http://schemas.openxmlformats.org/drawingml/2006/main" xmlns:r="http://schemas.openxmlformats.org/officeDocument/2006/relationships" xmlns:p="http://schemas.openxmlformats.org/presentationml/2006/main">
   <p:cSld name="Slide 7">
     <p:bg>
@@ -16647,7 +16741,7 @@
 </p:sld>
 </file>
 
-<file path=ppt/slides/slide8.xml><?xml version="1.0" encoding="utf-8"?>
+<file path=ppt\slides\slide8.xml><?xml version="1.0" encoding="utf-8"?>
 <p:sld xmlns:a="http://schemas.openxmlformats.org/drawingml/2006/main" xmlns:r="http://schemas.openxmlformats.org/officeDocument/2006/relationships" xmlns:p="http://schemas.openxmlformats.org/presentationml/2006/main">
   <p:cSld name="Slide 8">
     <p:bg>
@@ -17623,7 +17717,7 @@
 </p:sld>
 </file>
 
-<file path=ppt/slides/slide9.xml><?xml version="1.0" encoding="utf-8"?>
+<file path=ppt\slides\slide9.xml><?xml version="1.0" encoding="utf-8"?>
 <p:sld xmlns:a="http://schemas.openxmlformats.org/drawingml/2006/main" xmlns:r="http://schemas.openxmlformats.org/officeDocument/2006/relationships" xmlns:p="http://schemas.openxmlformats.org/presentationml/2006/main">
   <p:cSld name="Slide 9">
     <p:bg>
@@ -18295,7 +18389,11 @@
 </p:sld>
 </file>
 
-<file path=ppt/theme/theme1.xml><?xml version="1.0" encoding="utf-8"?>
+<file path=ppt\tableStyles.xml><?xml version="1.0" encoding="utf-8"?>
+<a:tblStyleLst xmlns:a="http://schemas.openxmlformats.org/drawingml/2006/main" def="{5C22544A-7EE6-4342-B048-85BDC9FD1C3A}"/>
+</file>
+
+<file path=ppt\theme\theme1.xml><?xml version="1.0" encoding="utf-8"?>
 <a:theme xmlns:a="http://schemas.openxmlformats.org/drawingml/2006/main" name="Office Theme">
   <a:themeElements>
     <a:clrScheme name="Office">
@@ -18590,7 +18688,7 @@
 </a:theme>
 </file>
 
-<file path=ppt/theme/theme2.xml><?xml version="1.0" encoding="utf-8"?>
+<file path=ppt\theme\theme2.xml><?xml version="1.0" encoding="utf-8"?>
 <a:theme xmlns:a="http://schemas.openxmlformats.org/drawingml/2006/main" name="Office Theme">
   <a:themeElements>
     <a:clrScheme name="Office">
@@ -18903,4 +19001,35 @@
     </a:ext>
   </a:extLst>
 </a:theme>
+</file>
+
+<file path=ppt\viewProps.xml><?xml version="1.0" encoding="utf-8"?>
+<p:viewPr xmlns:a="http://schemas.openxmlformats.org/drawingml/2006/main" xmlns:r="http://schemas.openxmlformats.org/officeDocument/2006/relationships" xmlns:p="http://schemas.openxmlformats.org/presentationml/2006/main">
+  <p:normalViewPr horzBarState="maximized">
+    <p:restoredLeft sz="15611"/>
+    <p:restoredTop sz="94610"/>
+  </p:normalViewPr>
+  <p:slideViewPr>
+    <p:cSldViewPr snapToGrid="0" snapToObjects="1">
+      <p:cViewPr varScale="1">
+        <p:scale>
+          <a:sx n="135" d="100"/>
+          <a:sy n="135" d="100"/>
+        </p:scale>
+        <p:origin x="924" y="336"/>
+      </p:cViewPr>
+      <p:guideLst/>
+    </p:cSldViewPr>
+  </p:slideViewPr>
+  <p:notesTextViewPr>
+    <p:cViewPr>
+      <p:scale>
+        <a:sx n="1" d="1"/>
+        <a:sy n="1" d="1"/>
+      </p:scale>
+      <p:origin x="0" y="0"/>
+    </p:cViewPr>
+  </p:notesTextViewPr>
+  <p:gridSpacing cx="76200" cy="76200"/>
+</p:viewPr>
 </file>
</xml_diff>

<commit_message>
docs: strengthen conference script and slide messaging
</commit_message>
<xml_diff>
--- a/conference/HelpdeskAI-Kolkata-2026.pptx
+++ b/conference/HelpdeskAI-Kolkata-2026.pptx
@@ -1,8 +1,8 @@
 
 <file path=docProps\app.xml><?xml version="1.0" encoding="utf-8"?>
 <Properties xmlns="http://schemas.openxmlformats.org/officeDocument/2006/extended-properties" xmlns:vt="http://schemas.openxmlformats.org/officeDocument/2006/docPropsVTypes">
-  <TotalTime>32</TotalTime>
-  <Words>2224</Words>
+  <TotalTime>34</TotalTime>
+  <Words>2238</Words>
   <Application>Microsoft Office PowerPoint</Application>
   <PresentationFormat>On-screen Show (16:9)</PresentationFormat>
   <Paragraphs>265</Paragraphs>
@@ -71,9 +71,9 @@
   <dc:subject>PptxGenJS Presentation</dc:subject>
   <dc:creator>PptxGenJS</dc:creator>
   <cp:lastModifiedBy>Choudhury, Sreyan</cp:lastModifiedBy>
-  <cp:revision>2</cp:revision>
+  <cp:revision>4</cp:revision>
   <dcterms:created xsi:type="dcterms:W3CDTF">2026-04-03T14:22:34Z</dcterms:created>
-  <dcterms:modified xsi:type="dcterms:W3CDTF">2026-04-03T14:57:20Z</dcterms:modified>
+  <dcterms:modified xsi:type="dcterms:W3CDTF">2026-04-04T06:20:01Z</dcterms:modified>
 </cp:coreProperties>
 </file>
 
@@ -7216,7 +7216,7 @@
                 <a:ea typeface="Calibri" pitchFamily="34" charset="-122"/>
                 <a:cs typeface="Calibri" pitchFamily="34" charset="-120"/>
               </a:rPr>
-              <a:t>An LLM API call is not a system. Routing, memory, auth, streaming, and evaluation need to be built consistently - MAF does that.</a:t>
+              <a:t>An LLM API call is not a system. Routing, memory, auth, skills, streaming, and evaluation need to be built consistently - MAF does that.</a:t>
             </a:r>
             <a:endParaRPr lang="en-US" sz="1250" dirty="0"/>
           </a:p>
@@ -10868,7 +10868,7 @@
                 <a:ea typeface="Calibri" pitchFamily="34" charset="-122"/>
                 <a:cs typeface="Calibri" pitchFamily="34" charset="-120"/>
               </a:rPr>
-              <a:t>An opinionated .NET library for building production-grade multi-agent AI systems â€” with authentication, memory, context, streaming, telemetry, and evaluation built in.</a:t>
+              <a:t>An opinionated .NET library for building production-grade multi-agent AI systems — with authentication, memory, context, skills, streaming, telemetry, and evaluation built in.</a:t>
             </a:r>
             <a:endParaRPr lang="en-US" sz="1550" dirty="0"/>
           </a:p>
@@ -11166,7 +11166,7 @@
                 <a:ea typeface="Calibri" pitchFamily="34" charset="-122"/>
                 <a:cs typeface="Calibri" pitchFamily="34" charset="-120"/>
               </a:rPr>
-              <a:t>Prescribes how agents, routing, memory, and telemetry wire together. Convention over configuration â€” most things work without ceremony.</a:t>
+              <a:t>Prescribes how agents, routing, memory, and telemetry wire together. Convention over configuration â€“ most things work without ceremony.</a:t>
             </a:r>
             <a:endParaRPr lang="en-US" sz="1200" dirty="0"/>
           </a:p>
@@ -11315,7 +11315,7 @@
                 <a:ea typeface="Calibri" pitchFamily="34" charset="-122"/>
                 <a:cs typeface="Calibri" pitchFamily="34" charset="-120"/>
               </a:rPr>
-              <a:t>Azure OpenAI, Document Intelligence, Cosmos, Redis, AI Search, and App Insights are the default backing services — all configurable and replaceable.</a:t>
+              <a:t>Azure OpenAI, Document Intelligence, Cosmos, Redis, AI Search, and App Insights are the default backing services â€” all configurable and replaceable.</a:t>
             </a:r>
             <a:endParaRPr lang="en-US" sz="1200" dirty="0"/>
           </a:p>
@@ -19013,10 +19013,10 @@
     <p:cSldViewPr snapToGrid="0" snapToObjects="1">
       <p:cViewPr varScale="1">
         <p:scale>
-          <a:sx n="135" d="100"/>
-          <a:sy n="135" d="100"/>
+          <a:sx n="130" d="100"/>
+          <a:sy n="130" d="100"/>
         </p:scale>
-        <p:origin x="924" y="336"/>
+        <p:origin x="1074" y="336"/>
       </p:cViewPr>
       <p:guideLst/>
     </p:cSldViewPr>

</xml_diff>

<commit_message>
chore: align solution to MAF v1 and refresh dependencies
</commit_message>
<xml_diff>
--- a/conference/HelpdeskAI-Kolkata-2026.pptx
+++ b/conference/HelpdeskAI-Kolkata-2026.pptx
@@ -1,1568 +1,5 @@
 
-<file path=docProps\app.xml><?xml version="1.0" encoding="utf-8"?>
-<Properties xmlns="http://schemas.openxmlformats.org/officeDocument/2006/extended-properties" xmlns:vt="http://schemas.openxmlformats.org/officeDocument/2006/docPropsVTypes">
-  <TotalTime>34</TotalTime>
-  <Words>2238</Words>
-  <Application>Microsoft Office PowerPoint</Application>
-  <PresentationFormat>On-screen Show (16:9)</PresentationFormat>
-  <Paragraphs>265</Paragraphs>
-  <Slides>16</Slides>
-  <Notes>16</Notes>
-  <HiddenSlides>0</HiddenSlides>
-  <MMClips>0</MMClips>
-  <ScaleCrop>false</ScaleCrop>
-  <HeadingPairs>
-    <vt:vector size="6" baseType="variant">
-      <vt:variant>
-        <vt:lpstr>Fonts Used</vt:lpstr>
-      </vt:variant>
-      <vt:variant>
-        <vt:i4>3</vt:i4>
-      </vt:variant>
-      <vt:variant>
-        <vt:lpstr>Theme</vt:lpstr>
-      </vt:variant>
-      <vt:variant>
-        <vt:i4>1</vt:i4>
-      </vt:variant>
-      <vt:variant>
-        <vt:lpstr>Slide Titles</vt:lpstr>
-      </vt:variant>
-      <vt:variant>
-        <vt:i4>16</vt:i4>
-      </vt:variant>
-    </vt:vector>
-  </HeadingPairs>
-  <TitlesOfParts>
-    <vt:vector size="20" baseType="lpstr">
-      <vt:lpstr>Arial</vt:lpstr>
-      <vt:lpstr>Calibri</vt:lpstr>
-      <vt:lpstr>Consolas</vt:lpstr>
-      <vt:lpstr>Office Theme</vt:lpstr>
-      <vt:lpstr>PowerPoint Presentation</vt:lpstr>
-      <vt:lpstr>PowerPoint Presentation</vt:lpstr>
-      <vt:lpstr>PowerPoint Presentation</vt:lpstr>
-      <vt:lpstr>PowerPoint Presentation</vt:lpstr>
-      <vt:lpstr>PowerPoint Presentation</vt:lpstr>
-      <vt:lpstr>PowerPoint Presentation</vt:lpstr>
-      <vt:lpstr>PowerPoint Presentation</vt:lpstr>
-      <vt:lpstr>PowerPoint Presentation</vt:lpstr>
-      <vt:lpstr>PowerPoint Presentation</vt:lpstr>
-      <vt:lpstr>PowerPoint Presentation</vt:lpstr>
-      <vt:lpstr>PowerPoint Presentation</vt:lpstr>
-      <vt:lpstr>PowerPoint Presentation</vt:lpstr>
-      <vt:lpstr>PowerPoint Presentation</vt:lpstr>
-      <vt:lpstr>PowerPoint Presentation</vt:lpstr>
-      <vt:lpstr>PowerPoint Presentation</vt:lpstr>
-      <vt:lpstr>PowerPoint Presentation</vt:lpstr>
-    </vt:vector>
-  </TitlesOfParts>
-  <Company>PptxGenJS</Company>
-  <LinksUpToDate>false</LinksUpToDate>
-  <SharedDoc>false</SharedDoc>
-  <HyperlinksChanged>false</HyperlinksChanged>
-  <AppVersion>16.0000</AppVersion>
-</Properties>
-</file>
-
-<file path=docProps\core.xml><?xml version="1.0" encoding="utf-8"?>
-<cp:coreProperties xmlns:cp="http://schemas.openxmlformats.org/package/2006/metadata/core-properties" xmlns:dc="http://purl.org/dc/elements/1.1/" xmlns:dcterms="http://purl.org/dc/terms/" xmlns:dcmitype="http://purl.org/dc/dcmitype/" xmlns:xsi="http://www.w3.org/2001/XMLSchema-instance">
-  <dc:title>Building Production Multi-Agent Systems with MAF</dc:title>
-  <dc:subject>PptxGenJS Presentation</dc:subject>
-  <dc:creator>PptxGenJS</dc:creator>
-  <cp:lastModifiedBy>Choudhury, Sreyan</cp:lastModifiedBy>
-  <cp:revision>4</cp:revision>
-  <dcterms:created xsi:type="dcterms:W3CDTF">2026-04-03T14:22:34Z</dcterms:created>
-  <dcterms:modified xsi:type="dcterms:W3CDTF">2026-04-04T06:20:01Z</dcterms:modified>
-</cp:coreProperties>
-</file>
-
-<file path=ppt\notesMasters\notesMaster1.xml><?xml version="1.0" encoding="utf-8"?>
-<p:notesMaster xmlns:a="http://schemas.openxmlformats.org/drawingml/2006/main" xmlns:r="http://schemas.openxmlformats.org/officeDocument/2006/relationships" xmlns:p="http://schemas.openxmlformats.org/presentationml/2006/main">
-  <p:cSld>
-    <p:bg>
-      <p:bgRef idx="1001">
-        <a:schemeClr val="bg1"/>
-      </p:bgRef>
-    </p:bg>
-    <p:spTree>
-      <p:nvGrpSpPr>
-        <p:cNvPr id="1" name=""/>
-        <p:cNvGrpSpPr/>
-        <p:nvPr/>
-      </p:nvGrpSpPr>
-      <p:grpSpPr>
-        <a:xfrm>
-          <a:off x="0" y="0"/>
-          <a:ext cx="0" cy="0"/>
-          <a:chOff x="0" y="0"/>
-          <a:chExt cx="0" cy="0"/>
-        </a:xfrm>
-      </p:grpSpPr>
-    </p:spTree>
-    <p:extLst>
-      <p:ext uri="{BB962C8B-B14F-4D97-AF65-F5344CB8AC3E}">
-        <p14:creationId xmlns:p14="http://schemas.microsoft.com/office/powerpoint/2010/main" val="776189880"/>
-      </p:ext>
-    </p:extLst>
-  </p:cSld>
-  <p:clrMap bg1="lt1" tx1="dk1" bg2="lt2" tx2="dk2" accent1="accent1" accent2="accent2" accent3="accent3" accent4="accent4" accent5="accent5" accent6="accent6" hlink="hlink" folHlink="folHlink"/>
-  <p:notesStyle>
-    <a:lvl1pPr marL="0" algn="l" defTabSz="914400" rtl="0" eaLnBrk="1" latinLnBrk="0" hangingPunct="1">
-      <a:defRPr sz="1200" kern="1200">
-        <a:solidFill>
-          <a:schemeClr val="tx1"/>
-        </a:solidFill>
-        <a:latin typeface="+mn-lt"/>
-        <a:ea typeface="+mn-ea"/>
-        <a:cs typeface="+mn-cs"/>
-      </a:defRPr>
-    </a:lvl1pPr>
-    <a:lvl2pPr marL="457200" algn="l" defTabSz="914400" rtl="0" eaLnBrk="1" latinLnBrk="0" hangingPunct="1">
-      <a:defRPr sz="1200" kern="1200">
-        <a:solidFill>
-          <a:schemeClr val="tx1"/>
-        </a:solidFill>
-        <a:latin typeface="+mn-lt"/>
-        <a:ea typeface="+mn-ea"/>
-        <a:cs typeface="+mn-cs"/>
-      </a:defRPr>
-    </a:lvl2pPr>
-    <a:lvl3pPr marL="914400" algn="l" defTabSz="914400" rtl="0" eaLnBrk="1" latinLnBrk="0" hangingPunct="1">
-      <a:defRPr sz="1200" kern="1200">
-        <a:solidFill>
-          <a:schemeClr val="tx1"/>
-        </a:solidFill>
-        <a:latin typeface="+mn-lt"/>
-        <a:ea typeface="+mn-ea"/>
-        <a:cs typeface="+mn-cs"/>
-      </a:defRPr>
-    </a:lvl3pPr>
-    <a:lvl4pPr marL="1371600" algn="l" defTabSz="914400" rtl="0" eaLnBrk="1" latinLnBrk="0" hangingPunct="1">
-      <a:defRPr sz="1200" kern="1200">
-        <a:solidFill>
-          <a:schemeClr val="tx1"/>
-        </a:solidFill>
-        <a:latin typeface="+mn-lt"/>
-        <a:ea typeface="+mn-ea"/>
-        <a:cs typeface="+mn-cs"/>
-      </a:defRPr>
-    </a:lvl4pPr>
-    <a:lvl5pPr marL="1828800" algn="l" defTabSz="914400" rtl="0" eaLnBrk="1" latinLnBrk="0" hangingPunct="1">
-      <a:defRPr sz="1200" kern="1200">
-        <a:solidFill>
-          <a:schemeClr val="tx1"/>
-        </a:solidFill>
-        <a:latin typeface="+mn-lt"/>
-        <a:ea typeface="+mn-ea"/>
-        <a:cs typeface="+mn-cs"/>
-      </a:defRPr>
-    </a:lvl5pPr>
-    <a:lvl6pPr marL="2286000" algn="l" defTabSz="914400" rtl="0" eaLnBrk="1" latinLnBrk="0" hangingPunct="1">
-      <a:defRPr sz="1200" kern="1200">
-        <a:solidFill>
-          <a:schemeClr val="tx1"/>
-        </a:solidFill>
-        <a:latin typeface="+mn-lt"/>
-        <a:ea typeface="+mn-ea"/>
-        <a:cs typeface="+mn-cs"/>
-      </a:defRPr>
-    </a:lvl6pPr>
-    <a:lvl7pPr marL="2743200" algn="l" defTabSz="914400" rtl="0" eaLnBrk="1" latinLnBrk="0" hangingPunct="1">
-      <a:defRPr sz="1200" kern="1200">
-        <a:solidFill>
-          <a:schemeClr val="tx1"/>
-        </a:solidFill>
-        <a:latin typeface="+mn-lt"/>
-        <a:ea typeface="+mn-ea"/>
-        <a:cs typeface="+mn-cs"/>
-      </a:defRPr>
-    </a:lvl7pPr>
-    <a:lvl8pPr marL="3200400" algn="l" defTabSz="914400" rtl="0" eaLnBrk="1" latinLnBrk="0" hangingPunct="1">
-      <a:defRPr sz="1200" kern="1200">
-        <a:solidFill>
-          <a:schemeClr val="tx1"/>
-        </a:solidFill>
-        <a:latin typeface="+mn-lt"/>
-        <a:ea typeface="+mn-ea"/>
-        <a:cs typeface="+mn-cs"/>
-      </a:defRPr>
-    </a:lvl8pPr>
-    <a:lvl9pPr marL="3657600" algn="l" defTabSz="914400" rtl="0" eaLnBrk="1" latinLnBrk="0" hangingPunct="1">
-      <a:defRPr sz="1200" kern="1200">
-        <a:solidFill>
-          <a:schemeClr val="tx1"/>
-        </a:solidFill>
-        <a:latin typeface="+mn-lt"/>
-        <a:ea typeface="+mn-ea"/>
-        <a:cs typeface="+mn-cs"/>
-      </a:defRPr>
-    </a:lvl9pPr>
-  </p:notesStyle>
-</p:notesMaster>
-</file>
-
-<file path=ppt\notesSlides\notesSlide1.xml><?xml version="1.0" encoding="utf-8"?>
-<p:notes xmlns:a="http://schemas.openxmlformats.org/drawingml/2006/main" xmlns:r="http://schemas.openxmlformats.org/officeDocument/2006/relationships" xmlns:p="http://schemas.openxmlformats.org/presentationml/2006/main">
-  <p:cSld>
-    <p:spTree>
-      <p:nvGrpSpPr>
-        <p:cNvPr id="1" name=""/>
-        <p:cNvGrpSpPr/>
-        <p:nvPr/>
-      </p:nvGrpSpPr>
-      <p:grpSpPr>
-        <a:xfrm>
-          <a:off x="0" y="0"/>
-          <a:ext cx="0" cy="0"/>
-          <a:chOff x="0" y="0"/>
-          <a:chExt cx="0" cy="0"/>
-        </a:xfrm>
-      </p:grpSpPr>
-      <p:sp>
-        <p:nvSpPr>
-          <p:cNvPr id="2" name="Slide Image Placeholder 1"/>
-          <p:cNvSpPr>
-            <a:spLocks noGrp="1" noRot="1" noChangeAspect="1"/>
-          </p:cNvSpPr>
-          <p:nvPr>
-            <p:ph type="sldImg"/>
-          </p:nvPr>
-        </p:nvSpPr>
-        <p:spPr/>
-      </p:sp>
-      <p:sp>
-        <p:nvSpPr>
-          <p:cNvPr id="3" name="Notes Placeholder 2"/>
-          <p:cNvSpPr>
-            <a:spLocks noGrp="1"/>
-          </p:cNvSpPr>
-          <p:nvPr>
-            <p:ph type="body" idx="1"/>
-          </p:nvPr>
-        </p:nvSpPr>
-        <p:spPr/>
-        <p:txBody>
-          <a:bodyPr/>
-          <a:lstStyle/>
-          <a:p>
-            <a:endParaRPr lang="en-US" dirty="0"/>
-          </a:p>
-        </p:txBody>
-      </p:sp>
-      <p:sp>
-        <p:nvSpPr>
-          <p:cNvPr id="4" name="Slide Number Placeholder 3"/>
-          <p:cNvSpPr>
-            <a:spLocks noGrp="1"/>
-          </p:cNvSpPr>
-          <p:nvPr>
-            <p:ph type="sldNum" sz="quarter" idx="10"/>
-          </p:nvPr>
-        </p:nvSpPr>
-        <p:spPr/>
-        <p:txBody>
-          <a:bodyPr/>
-          <a:lstStyle/>
-          <a:p>
-            <a:fld id="{F7021451-1387-4CA6-816F-3879F97B5CBC}" type="slidenum">
-              <a:rPr lang="en-US"/>
-              <a:t>1</a:t>
-            </a:fld>
-            <a:endParaRPr lang="en-US"/>
-          </a:p>
-        </p:txBody>
-      </p:sp>
-    </p:spTree>
-    <p:extLst>
-      <p:ext uri="{BB962C8B-B14F-4D97-AF65-F5344CB8AC3E}">
-        <p14:creationId xmlns:p14="http://schemas.microsoft.com/office/powerpoint/2010/main" val="1024086991"/>
-      </p:ext>
-    </p:extLst>
-  </p:cSld>
-  <p:clrMapOvr>
-    <a:masterClrMapping/>
-  </p:clrMapOvr>
-</p:notes>
-</file>
-
-<file path=ppt\notesSlides\notesSlide10.xml><?xml version="1.0" encoding="utf-8"?>
-<p:notes xmlns:a="http://schemas.openxmlformats.org/drawingml/2006/main" xmlns:r="http://schemas.openxmlformats.org/officeDocument/2006/relationships" xmlns:p="http://schemas.openxmlformats.org/presentationml/2006/main">
-  <p:cSld>
-    <p:spTree>
-      <p:nvGrpSpPr>
-        <p:cNvPr id="1" name=""/>
-        <p:cNvGrpSpPr/>
-        <p:nvPr/>
-      </p:nvGrpSpPr>
-      <p:grpSpPr>
-        <a:xfrm>
-          <a:off x="0" y="0"/>
-          <a:ext cx="0" cy="0"/>
-          <a:chOff x="0" y="0"/>
-          <a:chExt cx="0" cy="0"/>
-        </a:xfrm>
-      </p:grpSpPr>
-      <p:sp>
-        <p:nvSpPr>
-          <p:cNvPr id="2" name="Slide Image Placeholder 1"/>
-          <p:cNvSpPr>
-            <a:spLocks noGrp="1" noRot="1" noChangeAspect="1"/>
-          </p:cNvSpPr>
-          <p:nvPr>
-            <p:ph type="sldImg"/>
-          </p:nvPr>
-        </p:nvSpPr>
-        <p:spPr/>
-      </p:sp>
-      <p:sp>
-        <p:nvSpPr>
-          <p:cNvPr id="3" name="Notes Placeholder 2"/>
-          <p:cNvSpPr>
-            <a:spLocks noGrp="1"/>
-          </p:cNvSpPr>
-          <p:nvPr>
-            <p:ph type="body" idx="1"/>
-          </p:nvPr>
-        </p:nvSpPr>
-        <p:spPr/>
-        <p:txBody>
-          <a:bodyPr/>
-          <a:lstStyle/>
-          <a:p>
-            <a:endParaRPr lang="en-US" dirty="0"/>
-          </a:p>
-        </p:txBody>
-      </p:sp>
-      <p:sp>
-        <p:nvSpPr>
-          <p:cNvPr id="4" name="Slide Number Placeholder 3"/>
-          <p:cNvSpPr>
-            <a:spLocks noGrp="1"/>
-          </p:cNvSpPr>
-          <p:nvPr>
-            <p:ph type="sldNum" sz="quarter" idx="10"/>
-          </p:nvPr>
-        </p:nvSpPr>
-        <p:spPr/>
-        <p:txBody>
-          <a:bodyPr/>
-          <a:lstStyle/>
-          <a:p>
-            <a:fld id="{F7021451-1387-4CA6-816F-3879F97B5CBC}" type="slidenum">
-              <a:rPr lang="en-US"/>
-              <a:t>10</a:t>
-            </a:fld>
-            <a:endParaRPr lang="en-US"/>
-          </a:p>
-        </p:txBody>
-      </p:sp>
-    </p:spTree>
-    <p:extLst>
-      <p:ext uri="{BB962C8B-B14F-4D97-AF65-F5344CB8AC3E}">
-        <p14:creationId xmlns:p14="http://schemas.microsoft.com/office/powerpoint/2010/main" val="1024086991"/>
-      </p:ext>
-    </p:extLst>
-  </p:cSld>
-  <p:clrMapOvr>
-    <a:masterClrMapping/>
-  </p:clrMapOvr>
-</p:notes>
-</file>
-
-<file path=ppt\notesSlides\notesSlide11.xml><?xml version="1.0" encoding="utf-8"?>
-<p:notes xmlns:a="http://schemas.openxmlformats.org/drawingml/2006/main" xmlns:r="http://schemas.openxmlformats.org/officeDocument/2006/relationships" xmlns:p="http://schemas.openxmlformats.org/presentationml/2006/main">
-  <p:cSld>
-    <p:spTree>
-      <p:nvGrpSpPr>
-        <p:cNvPr id="1" name=""/>
-        <p:cNvGrpSpPr/>
-        <p:nvPr/>
-      </p:nvGrpSpPr>
-      <p:grpSpPr>
-        <a:xfrm>
-          <a:off x="0" y="0"/>
-          <a:ext cx="0" cy="0"/>
-          <a:chOff x="0" y="0"/>
-          <a:chExt cx="0" cy="0"/>
-        </a:xfrm>
-      </p:grpSpPr>
-      <p:sp>
-        <p:nvSpPr>
-          <p:cNvPr id="2" name="Slide Image Placeholder 1"/>
-          <p:cNvSpPr>
-            <a:spLocks noGrp="1" noRot="1" noChangeAspect="1"/>
-          </p:cNvSpPr>
-          <p:nvPr>
-            <p:ph type="sldImg"/>
-          </p:nvPr>
-        </p:nvSpPr>
-        <p:spPr/>
-      </p:sp>
-      <p:sp>
-        <p:nvSpPr>
-          <p:cNvPr id="3" name="Notes Placeholder 2"/>
-          <p:cNvSpPr>
-            <a:spLocks noGrp="1"/>
-          </p:cNvSpPr>
-          <p:nvPr>
-            <p:ph type="body" idx="1"/>
-          </p:nvPr>
-        </p:nvSpPr>
-        <p:spPr/>
-        <p:txBody>
-          <a:bodyPr/>
-          <a:lstStyle/>
-          <a:p>
-            <a:endParaRPr lang="en-US" dirty="0"/>
-          </a:p>
-        </p:txBody>
-      </p:sp>
-      <p:sp>
-        <p:nvSpPr>
-          <p:cNvPr id="4" name="Slide Number Placeholder 3"/>
-          <p:cNvSpPr>
-            <a:spLocks noGrp="1"/>
-          </p:cNvSpPr>
-          <p:nvPr>
-            <p:ph type="sldNum" sz="quarter" idx="10"/>
-          </p:nvPr>
-        </p:nvSpPr>
-        <p:spPr/>
-        <p:txBody>
-          <a:bodyPr/>
-          <a:lstStyle/>
-          <a:p>
-            <a:fld id="{F7021451-1387-4CA6-816F-3879F97B5CBC}" type="slidenum">
-              <a:rPr lang="en-US"/>
-              <a:t>11</a:t>
-            </a:fld>
-            <a:endParaRPr lang="en-US"/>
-          </a:p>
-        </p:txBody>
-      </p:sp>
-    </p:spTree>
-    <p:extLst>
-      <p:ext uri="{BB962C8B-B14F-4D97-AF65-F5344CB8AC3E}">
-        <p14:creationId xmlns:p14="http://schemas.microsoft.com/office/powerpoint/2010/main" val="1024086991"/>
-      </p:ext>
-    </p:extLst>
-  </p:cSld>
-  <p:clrMapOvr>
-    <a:masterClrMapping/>
-  </p:clrMapOvr>
-</p:notes>
-</file>
-
-<file path=ppt\notesSlides\notesSlide12.xml><?xml version="1.0" encoding="utf-8"?>
-<p:notes xmlns:a="http://schemas.openxmlformats.org/drawingml/2006/main" xmlns:r="http://schemas.openxmlformats.org/officeDocument/2006/relationships" xmlns:p="http://schemas.openxmlformats.org/presentationml/2006/main">
-  <p:cSld>
-    <p:spTree>
-      <p:nvGrpSpPr>
-        <p:cNvPr id="1" name=""/>
-        <p:cNvGrpSpPr/>
-        <p:nvPr/>
-      </p:nvGrpSpPr>
-      <p:grpSpPr>
-        <a:xfrm>
-          <a:off x="0" y="0"/>
-          <a:ext cx="0" cy="0"/>
-          <a:chOff x="0" y="0"/>
-          <a:chExt cx="0" cy="0"/>
-        </a:xfrm>
-      </p:grpSpPr>
-      <p:sp>
-        <p:nvSpPr>
-          <p:cNvPr id="2" name="Slide Image Placeholder 1"/>
-          <p:cNvSpPr>
-            <a:spLocks noGrp="1" noRot="1" noChangeAspect="1"/>
-          </p:cNvSpPr>
-          <p:nvPr>
-            <p:ph type="sldImg"/>
-          </p:nvPr>
-        </p:nvSpPr>
-        <p:spPr/>
-      </p:sp>
-      <p:sp>
-        <p:nvSpPr>
-          <p:cNvPr id="3" name="Notes Placeholder 2"/>
-          <p:cNvSpPr>
-            <a:spLocks noGrp="1"/>
-          </p:cNvSpPr>
-          <p:nvPr>
-            <p:ph type="body" idx="1"/>
-          </p:nvPr>
-        </p:nvSpPr>
-        <p:spPr/>
-        <p:txBody>
-          <a:bodyPr/>
-          <a:lstStyle/>
-          <a:p>
-            <a:endParaRPr lang="en-US" dirty="0"/>
-          </a:p>
-        </p:txBody>
-      </p:sp>
-      <p:sp>
-        <p:nvSpPr>
-          <p:cNvPr id="4" name="Slide Number Placeholder 3"/>
-          <p:cNvSpPr>
-            <a:spLocks noGrp="1"/>
-          </p:cNvSpPr>
-          <p:nvPr>
-            <p:ph type="sldNum" sz="quarter" idx="10"/>
-          </p:nvPr>
-        </p:nvSpPr>
-        <p:spPr/>
-        <p:txBody>
-          <a:bodyPr/>
-          <a:lstStyle/>
-          <a:p>
-            <a:fld id="{F7021451-1387-4CA6-816F-3879F97B5CBC}" type="slidenum">
-              <a:rPr lang="en-US"/>
-              <a:t>12</a:t>
-            </a:fld>
-            <a:endParaRPr lang="en-US"/>
-          </a:p>
-        </p:txBody>
-      </p:sp>
-    </p:spTree>
-    <p:extLst>
-      <p:ext uri="{BB962C8B-B14F-4D97-AF65-F5344CB8AC3E}">
-        <p14:creationId xmlns:p14="http://schemas.microsoft.com/office/powerpoint/2010/main" val="1024086991"/>
-      </p:ext>
-    </p:extLst>
-  </p:cSld>
-  <p:clrMapOvr>
-    <a:masterClrMapping/>
-  </p:clrMapOvr>
-</p:notes>
-</file>
-
-<file path=ppt\notesSlides\notesSlide13.xml><?xml version="1.0" encoding="utf-8"?>
-<p:notes xmlns:a="http://schemas.openxmlformats.org/drawingml/2006/main" xmlns:r="http://schemas.openxmlformats.org/officeDocument/2006/relationships" xmlns:p="http://schemas.openxmlformats.org/presentationml/2006/main">
-  <p:cSld>
-    <p:spTree>
-      <p:nvGrpSpPr>
-        <p:cNvPr id="1" name=""/>
-        <p:cNvGrpSpPr/>
-        <p:nvPr/>
-      </p:nvGrpSpPr>
-      <p:grpSpPr>
-        <a:xfrm>
-          <a:off x="0" y="0"/>
-          <a:ext cx="0" cy="0"/>
-          <a:chOff x="0" y="0"/>
-          <a:chExt cx="0" cy="0"/>
-        </a:xfrm>
-      </p:grpSpPr>
-      <p:sp>
-        <p:nvSpPr>
-          <p:cNvPr id="2" name="Slide Image Placeholder 1"/>
-          <p:cNvSpPr>
-            <a:spLocks noGrp="1" noRot="1" noChangeAspect="1"/>
-          </p:cNvSpPr>
-          <p:nvPr>
-            <p:ph type="sldImg"/>
-          </p:nvPr>
-        </p:nvSpPr>
-        <p:spPr/>
-      </p:sp>
-      <p:sp>
-        <p:nvSpPr>
-          <p:cNvPr id="3" name="Notes Placeholder 2"/>
-          <p:cNvSpPr>
-            <a:spLocks noGrp="1"/>
-          </p:cNvSpPr>
-          <p:nvPr>
-            <p:ph type="body" idx="1"/>
-          </p:nvPr>
-        </p:nvSpPr>
-        <p:spPr/>
-        <p:txBody>
-          <a:bodyPr/>
-          <a:lstStyle/>
-          <a:p>
-            <a:endParaRPr lang="en-US" dirty="0"/>
-          </a:p>
-        </p:txBody>
-      </p:sp>
-      <p:sp>
-        <p:nvSpPr>
-          <p:cNvPr id="4" name="Slide Number Placeholder 3"/>
-          <p:cNvSpPr>
-            <a:spLocks noGrp="1"/>
-          </p:cNvSpPr>
-          <p:nvPr>
-            <p:ph type="sldNum" sz="quarter" idx="10"/>
-          </p:nvPr>
-        </p:nvSpPr>
-        <p:spPr/>
-        <p:txBody>
-          <a:bodyPr/>
-          <a:lstStyle/>
-          <a:p>
-            <a:fld id="{F7021451-1387-4CA6-816F-3879F97B5CBC}" type="slidenum">
-              <a:rPr lang="en-US"/>
-              <a:t>13</a:t>
-            </a:fld>
-            <a:endParaRPr lang="en-US"/>
-          </a:p>
-        </p:txBody>
-      </p:sp>
-    </p:spTree>
-    <p:extLst>
-      <p:ext uri="{BB962C8B-B14F-4D97-AF65-F5344CB8AC3E}">
-        <p14:creationId xmlns:p14="http://schemas.microsoft.com/office/powerpoint/2010/main" val="1024086991"/>
-      </p:ext>
-    </p:extLst>
-  </p:cSld>
-  <p:clrMapOvr>
-    <a:masterClrMapping/>
-  </p:clrMapOvr>
-</p:notes>
-</file>
-
-<file path=ppt\notesSlides\notesSlide14.xml><?xml version="1.0" encoding="utf-8"?>
-<p:notes xmlns:a="http://schemas.openxmlformats.org/drawingml/2006/main" xmlns:r="http://schemas.openxmlformats.org/officeDocument/2006/relationships" xmlns:p="http://schemas.openxmlformats.org/presentationml/2006/main">
-  <p:cSld>
-    <p:spTree>
-      <p:nvGrpSpPr>
-        <p:cNvPr id="1" name=""/>
-        <p:cNvGrpSpPr/>
-        <p:nvPr/>
-      </p:nvGrpSpPr>
-      <p:grpSpPr>
-        <a:xfrm>
-          <a:off x="0" y="0"/>
-          <a:ext cx="0" cy="0"/>
-          <a:chOff x="0" y="0"/>
-          <a:chExt cx="0" cy="0"/>
-        </a:xfrm>
-      </p:grpSpPr>
-      <p:sp>
-        <p:nvSpPr>
-          <p:cNvPr id="2" name="Slide Image Placeholder 1"/>
-          <p:cNvSpPr>
-            <a:spLocks noGrp="1" noRot="1" noChangeAspect="1"/>
-          </p:cNvSpPr>
-          <p:nvPr>
-            <p:ph type="sldImg"/>
-          </p:nvPr>
-        </p:nvSpPr>
-        <p:spPr/>
-      </p:sp>
-      <p:sp>
-        <p:nvSpPr>
-          <p:cNvPr id="3" name="Notes Placeholder 2"/>
-          <p:cNvSpPr>
-            <a:spLocks noGrp="1"/>
-          </p:cNvSpPr>
-          <p:nvPr>
-            <p:ph type="body" idx="1"/>
-          </p:nvPr>
-        </p:nvSpPr>
-        <p:spPr/>
-        <p:txBody>
-          <a:bodyPr/>
-          <a:lstStyle/>
-          <a:p>
-            <a:endParaRPr lang="en-US" dirty="0"/>
-          </a:p>
-        </p:txBody>
-      </p:sp>
-      <p:sp>
-        <p:nvSpPr>
-          <p:cNvPr id="4" name="Slide Number Placeholder 3"/>
-          <p:cNvSpPr>
-            <a:spLocks noGrp="1"/>
-          </p:cNvSpPr>
-          <p:nvPr>
-            <p:ph type="sldNum" sz="quarter" idx="10"/>
-          </p:nvPr>
-        </p:nvSpPr>
-        <p:spPr/>
-        <p:txBody>
-          <a:bodyPr/>
-          <a:lstStyle/>
-          <a:p>
-            <a:fld id="{F7021451-1387-4CA6-816F-3879F97B5CBC}" type="slidenum">
-              <a:rPr lang="en-US"/>
-              <a:t>14</a:t>
-            </a:fld>
-            <a:endParaRPr lang="en-US"/>
-          </a:p>
-        </p:txBody>
-      </p:sp>
-    </p:spTree>
-    <p:extLst>
-      <p:ext uri="{BB962C8B-B14F-4D97-AF65-F5344CB8AC3E}">
-        <p14:creationId xmlns:p14="http://schemas.microsoft.com/office/powerpoint/2010/main" val="1024086991"/>
-      </p:ext>
-    </p:extLst>
-  </p:cSld>
-  <p:clrMapOvr>
-    <a:masterClrMapping/>
-  </p:clrMapOvr>
-</p:notes>
-</file>
-
-<file path=ppt\notesSlides\notesSlide15.xml><?xml version="1.0" encoding="utf-8"?>
-<p:notes xmlns:a="http://schemas.openxmlformats.org/drawingml/2006/main" xmlns:r="http://schemas.openxmlformats.org/officeDocument/2006/relationships" xmlns:p="http://schemas.openxmlformats.org/presentationml/2006/main">
-  <p:cSld>
-    <p:spTree>
-      <p:nvGrpSpPr>
-        <p:cNvPr id="1" name=""/>
-        <p:cNvGrpSpPr/>
-        <p:nvPr/>
-      </p:nvGrpSpPr>
-      <p:grpSpPr>
-        <a:xfrm>
-          <a:off x="0" y="0"/>
-          <a:ext cx="0" cy="0"/>
-          <a:chOff x="0" y="0"/>
-          <a:chExt cx="0" cy="0"/>
-        </a:xfrm>
-      </p:grpSpPr>
-      <p:sp>
-        <p:nvSpPr>
-          <p:cNvPr id="2" name="Slide Image Placeholder 1"/>
-          <p:cNvSpPr>
-            <a:spLocks noGrp="1" noRot="1" noChangeAspect="1"/>
-          </p:cNvSpPr>
-          <p:nvPr>
-            <p:ph type="sldImg"/>
-          </p:nvPr>
-        </p:nvSpPr>
-        <p:spPr/>
-      </p:sp>
-      <p:sp>
-        <p:nvSpPr>
-          <p:cNvPr id="3" name="Notes Placeholder 2"/>
-          <p:cNvSpPr>
-            <a:spLocks noGrp="1"/>
-          </p:cNvSpPr>
-          <p:nvPr>
-            <p:ph type="body" idx="1"/>
-          </p:nvPr>
-        </p:nvSpPr>
-        <p:spPr/>
-        <p:txBody>
-          <a:bodyPr/>
-          <a:lstStyle/>
-          <a:p>
-            <a:endParaRPr lang="en-US" dirty="0"/>
-          </a:p>
-        </p:txBody>
-      </p:sp>
-      <p:sp>
-        <p:nvSpPr>
-          <p:cNvPr id="4" name="Slide Number Placeholder 3"/>
-          <p:cNvSpPr>
-            <a:spLocks noGrp="1"/>
-          </p:cNvSpPr>
-          <p:nvPr>
-            <p:ph type="sldNum" sz="quarter" idx="10"/>
-          </p:nvPr>
-        </p:nvSpPr>
-        <p:spPr/>
-        <p:txBody>
-          <a:bodyPr/>
-          <a:lstStyle/>
-          <a:p>
-            <a:fld id="{F7021451-1387-4CA6-816F-3879F97B5CBC}" type="slidenum">
-              <a:rPr lang="en-US"/>
-              <a:t>15</a:t>
-            </a:fld>
-            <a:endParaRPr lang="en-US"/>
-          </a:p>
-        </p:txBody>
-      </p:sp>
-    </p:spTree>
-    <p:extLst>
-      <p:ext uri="{BB962C8B-B14F-4D97-AF65-F5344CB8AC3E}">
-        <p14:creationId xmlns:p14="http://schemas.microsoft.com/office/powerpoint/2010/main" val="1024086991"/>
-      </p:ext>
-    </p:extLst>
-  </p:cSld>
-  <p:clrMapOvr>
-    <a:masterClrMapping/>
-  </p:clrMapOvr>
-</p:notes>
-</file>
-
-<file path=ppt\notesSlides\notesSlide16.xml><?xml version="1.0" encoding="utf-8"?>
-<p:notes xmlns:a="http://schemas.openxmlformats.org/drawingml/2006/main" xmlns:r="http://schemas.openxmlformats.org/officeDocument/2006/relationships" xmlns:p="http://schemas.openxmlformats.org/presentationml/2006/main">
-  <p:cSld>
-    <p:spTree>
-      <p:nvGrpSpPr>
-        <p:cNvPr id="1" name=""/>
-        <p:cNvGrpSpPr/>
-        <p:nvPr/>
-      </p:nvGrpSpPr>
-      <p:grpSpPr>
-        <a:xfrm>
-          <a:off x="0" y="0"/>
-          <a:ext cx="0" cy="0"/>
-          <a:chOff x="0" y="0"/>
-          <a:chExt cx="0" cy="0"/>
-        </a:xfrm>
-      </p:grpSpPr>
-      <p:sp>
-        <p:nvSpPr>
-          <p:cNvPr id="2" name="Slide Image Placeholder 1"/>
-          <p:cNvSpPr>
-            <a:spLocks noGrp="1" noRot="1" noChangeAspect="1"/>
-          </p:cNvSpPr>
-          <p:nvPr>
-            <p:ph type="sldImg"/>
-          </p:nvPr>
-        </p:nvSpPr>
-        <p:spPr/>
-      </p:sp>
-      <p:sp>
-        <p:nvSpPr>
-          <p:cNvPr id="3" name="Notes Placeholder 2"/>
-          <p:cNvSpPr>
-            <a:spLocks noGrp="1"/>
-          </p:cNvSpPr>
-          <p:nvPr>
-            <p:ph type="body" idx="1"/>
-          </p:nvPr>
-        </p:nvSpPr>
-        <p:spPr/>
-        <p:txBody>
-          <a:bodyPr/>
-          <a:lstStyle/>
-          <a:p>
-            <a:endParaRPr lang="en-US" dirty="0"/>
-          </a:p>
-        </p:txBody>
-      </p:sp>
-      <p:sp>
-        <p:nvSpPr>
-          <p:cNvPr id="4" name="Slide Number Placeholder 3"/>
-          <p:cNvSpPr>
-            <a:spLocks noGrp="1"/>
-          </p:cNvSpPr>
-          <p:nvPr>
-            <p:ph type="sldNum" sz="quarter" idx="10"/>
-          </p:nvPr>
-        </p:nvSpPr>
-        <p:spPr/>
-        <p:txBody>
-          <a:bodyPr/>
-          <a:lstStyle/>
-          <a:p>
-            <a:fld id="{F7021451-1387-4CA6-816F-3879F97B5CBC}" type="slidenum">
-              <a:rPr lang="en-US"/>
-              <a:t>16</a:t>
-            </a:fld>
-            <a:endParaRPr lang="en-US"/>
-          </a:p>
-        </p:txBody>
-      </p:sp>
-    </p:spTree>
-    <p:extLst>
-      <p:ext uri="{BB962C8B-B14F-4D97-AF65-F5344CB8AC3E}">
-        <p14:creationId xmlns:p14="http://schemas.microsoft.com/office/powerpoint/2010/main" val="1024086991"/>
-      </p:ext>
-    </p:extLst>
-  </p:cSld>
-  <p:clrMapOvr>
-    <a:masterClrMapping/>
-  </p:clrMapOvr>
-</p:notes>
-</file>
-
-<file path=ppt\notesSlides\notesSlide2.xml><?xml version="1.0" encoding="utf-8"?>
-<p:notes xmlns:a="http://schemas.openxmlformats.org/drawingml/2006/main" xmlns:r="http://schemas.openxmlformats.org/officeDocument/2006/relationships" xmlns:p="http://schemas.openxmlformats.org/presentationml/2006/main">
-  <p:cSld>
-    <p:spTree>
-      <p:nvGrpSpPr>
-        <p:cNvPr id="1" name=""/>
-        <p:cNvGrpSpPr/>
-        <p:nvPr/>
-      </p:nvGrpSpPr>
-      <p:grpSpPr>
-        <a:xfrm>
-          <a:off x="0" y="0"/>
-          <a:ext cx="0" cy="0"/>
-          <a:chOff x="0" y="0"/>
-          <a:chExt cx="0" cy="0"/>
-        </a:xfrm>
-      </p:grpSpPr>
-      <p:sp>
-        <p:nvSpPr>
-          <p:cNvPr id="2" name="Slide Image Placeholder 1"/>
-          <p:cNvSpPr>
-            <a:spLocks noGrp="1" noRot="1" noChangeAspect="1"/>
-          </p:cNvSpPr>
-          <p:nvPr>
-            <p:ph type="sldImg"/>
-          </p:nvPr>
-        </p:nvSpPr>
-        <p:spPr/>
-      </p:sp>
-      <p:sp>
-        <p:nvSpPr>
-          <p:cNvPr id="3" name="Notes Placeholder 2"/>
-          <p:cNvSpPr>
-            <a:spLocks noGrp="1"/>
-          </p:cNvSpPr>
-          <p:nvPr>
-            <p:ph type="body" idx="1"/>
-          </p:nvPr>
-        </p:nvSpPr>
-        <p:spPr/>
-        <p:txBody>
-          <a:bodyPr/>
-          <a:lstStyle/>
-          <a:p>
-            <a:endParaRPr lang="en-US" dirty="0"/>
-          </a:p>
-        </p:txBody>
-      </p:sp>
-      <p:sp>
-        <p:nvSpPr>
-          <p:cNvPr id="4" name="Slide Number Placeholder 3"/>
-          <p:cNvSpPr>
-            <a:spLocks noGrp="1"/>
-          </p:cNvSpPr>
-          <p:nvPr>
-            <p:ph type="sldNum" sz="quarter" idx="10"/>
-          </p:nvPr>
-        </p:nvSpPr>
-        <p:spPr/>
-        <p:txBody>
-          <a:bodyPr/>
-          <a:lstStyle/>
-          <a:p>
-            <a:fld id="{F7021451-1387-4CA6-816F-3879F97B5CBC}" type="slidenum">
-              <a:rPr lang="en-US"/>
-              <a:t>2</a:t>
-            </a:fld>
-            <a:endParaRPr lang="en-US"/>
-          </a:p>
-        </p:txBody>
-      </p:sp>
-    </p:spTree>
-    <p:extLst>
-      <p:ext uri="{BB962C8B-B14F-4D97-AF65-F5344CB8AC3E}">
-        <p14:creationId xmlns:p14="http://schemas.microsoft.com/office/powerpoint/2010/main" val="1024086991"/>
-      </p:ext>
-    </p:extLst>
-  </p:cSld>
-  <p:clrMapOvr>
-    <a:masterClrMapping/>
-  </p:clrMapOvr>
-</p:notes>
-</file>
-
-<file path=ppt\notesSlides\notesSlide3.xml><?xml version="1.0" encoding="utf-8"?>
-<p:notes xmlns:a="http://schemas.openxmlformats.org/drawingml/2006/main" xmlns:r="http://schemas.openxmlformats.org/officeDocument/2006/relationships" xmlns:p="http://schemas.openxmlformats.org/presentationml/2006/main">
-  <p:cSld>
-    <p:spTree>
-      <p:nvGrpSpPr>
-        <p:cNvPr id="1" name=""/>
-        <p:cNvGrpSpPr/>
-        <p:nvPr/>
-      </p:nvGrpSpPr>
-      <p:grpSpPr>
-        <a:xfrm>
-          <a:off x="0" y="0"/>
-          <a:ext cx="0" cy="0"/>
-          <a:chOff x="0" y="0"/>
-          <a:chExt cx="0" cy="0"/>
-        </a:xfrm>
-      </p:grpSpPr>
-      <p:sp>
-        <p:nvSpPr>
-          <p:cNvPr id="2" name="Slide Image Placeholder 1"/>
-          <p:cNvSpPr>
-            <a:spLocks noGrp="1" noRot="1" noChangeAspect="1"/>
-          </p:cNvSpPr>
-          <p:nvPr>
-            <p:ph type="sldImg"/>
-          </p:nvPr>
-        </p:nvSpPr>
-        <p:spPr/>
-      </p:sp>
-      <p:sp>
-        <p:nvSpPr>
-          <p:cNvPr id="3" name="Notes Placeholder 2"/>
-          <p:cNvSpPr>
-            <a:spLocks noGrp="1"/>
-          </p:cNvSpPr>
-          <p:nvPr>
-            <p:ph type="body" idx="1"/>
-          </p:nvPr>
-        </p:nvSpPr>
-        <p:spPr/>
-        <p:txBody>
-          <a:bodyPr/>
-          <a:lstStyle/>
-          <a:p>
-            <a:endParaRPr lang="en-US" dirty="0"/>
-          </a:p>
-        </p:txBody>
-      </p:sp>
-      <p:sp>
-        <p:nvSpPr>
-          <p:cNvPr id="4" name="Slide Number Placeholder 3"/>
-          <p:cNvSpPr>
-            <a:spLocks noGrp="1"/>
-          </p:cNvSpPr>
-          <p:nvPr>
-            <p:ph type="sldNum" sz="quarter" idx="10"/>
-          </p:nvPr>
-        </p:nvSpPr>
-        <p:spPr/>
-        <p:txBody>
-          <a:bodyPr/>
-          <a:lstStyle/>
-          <a:p>
-            <a:fld id="{F7021451-1387-4CA6-816F-3879F97B5CBC}" type="slidenum">
-              <a:rPr lang="en-US"/>
-              <a:t>3</a:t>
-            </a:fld>
-            <a:endParaRPr lang="en-US"/>
-          </a:p>
-        </p:txBody>
-      </p:sp>
-    </p:spTree>
-    <p:extLst>
-      <p:ext uri="{BB962C8B-B14F-4D97-AF65-F5344CB8AC3E}">
-        <p14:creationId xmlns:p14="http://schemas.microsoft.com/office/powerpoint/2010/main" val="1024086991"/>
-      </p:ext>
-    </p:extLst>
-  </p:cSld>
-  <p:clrMapOvr>
-    <a:masterClrMapping/>
-  </p:clrMapOvr>
-</p:notes>
-</file>
-
-<file path=ppt\notesSlides\notesSlide4.xml><?xml version="1.0" encoding="utf-8"?>
-<p:notes xmlns:a="http://schemas.openxmlformats.org/drawingml/2006/main" xmlns:r="http://schemas.openxmlformats.org/officeDocument/2006/relationships" xmlns:p="http://schemas.openxmlformats.org/presentationml/2006/main">
-  <p:cSld>
-    <p:spTree>
-      <p:nvGrpSpPr>
-        <p:cNvPr id="1" name=""/>
-        <p:cNvGrpSpPr/>
-        <p:nvPr/>
-      </p:nvGrpSpPr>
-      <p:grpSpPr>
-        <a:xfrm>
-          <a:off x="0" y="0"/>
-          <a:ext cx="0" cy="0"/>
-          <a:chOff x="0" y="0"/>
-          <a:chExt cx="0" cy="0"/>
-        </a:xfrm>
-      </p:grpSpPr>
-      <p:sp>
-        <p:nvSpPr>
-          <p:cNvPr id="2" name="Slide Image Placeholder 1"/>
-          <p:cNvSpPr>
-            <a:spLocks noGrp="1" noRot="1" noChangeAspect="1"/>
-          </p:cNvSpPr>
-          <p:nvPr>
-            <p:ph type="sldImg"/>
-          </p:nvPr>
-        </p:nvSpPr>
-        <p:spPr/>
-      </p:sp>
-      <p:sp>
-        <p:nvSpPr>
-          <p:cNvPr id="3" name="Notes Placeholder 2"/>
-          <p:cNvSpPr>
-            <a:spLocks noGrp="1"/>
-          </p:cNvSpPr>
-          <p:nvPr>
-            <p:ph type="body" idx="1"/>
-          </p:nvPr>
-        </p:nvSpPr>
-        <p:spPr/>
-        <p:txBody>
-          <a:bodyPr/>
-          <a:lstStyle/>
-          <a:p>
-            <a:endParaRPr lang="en-US" dirty="0"/>
-          </a:p>
-        </p:txBody>
-      </p:sp>
-      <p:sp>
-        <p:nvSpPr>
-          <p:cNvPr id="4" name="Slide Number Placeholder 3"/>
-          <p:cNvSpPr>
-            <a:spLocks noGrp="1"/>
-          </p:cNvSpPr>
-          <p:nvPr>
-            <p:ph type="sldNum" sz="quarter" idx="10"/>
-          </p:nvPr>
-        </p:nvSpPr>
-        <p:spPr/>
-        <p:txBody>
-          <a:bodyPr/>
-          <a:lstStyle/>
-          <a:p>
-            <a:fld id="{F7021451-1387-4CA6-816F-3879F97B5CBC}" type="slidenum">
-              <a:rPr lang="en-US"/>
-              <a:t>4</a:t>
-            </a:fld>
-            <a:endParaRPr lang="en-US"/>
-          </a:p>
-        </p:txBody>
-      </p:sp>
-    </p:spTree>
-    <p:extLst>
-      <p:ext uri="{BB962C8B-B14F-4D97-AF65-F5344CB8AC3E}">
-        <p14:creationId xmlns:p14="http://schemas.microsoft.com/office/powerpoint/2010/main" val="1024086991"/>
-      </p:ext>
-    </p:extLst>
-  </p:cSld>
-  <p:clrMapOvr>
-    <a:masterClrMapping/>
-  </p:clrMapOvr>
-</p:notes>
-</file>
-
-<file path=ppt\notesSlides\notesSlide5.xml><?xml version="1.0" encoding="utf-8"?>
-<p:notes xmlns:a="http://schemas.openxmlformats.org/drawingml/2006/main" xmlns:r="http://schemas.openxmlformats.org/officeDocument/2006/relationships" xmlns:p="http://schemas.openxmlformats.org/presentationml/2006/main">
-  <p:cSld>
-    <p:spTree>
-      <p:nvGrpSpPr>
-        <p:cNvPr id="1" name=""/>
-        <p:cNvGrpSpPr/>
-        <p:nvPr/>
-      </p:nvGrpSpPr>
-      <p:grpSpPr>
-        <a:xfrm>
-          <a:off x="0" y="0"/>
-          <a:ext cx="0" cy="0"/>
-          <a:chOff x="0" y="0"/>
-          <a:chExt cx="0" cy="0"/>
-        </a:xfrm>
-      </p:grpSpPr>
-      <p:sp>
-        <p:nvSpPr>
-          <p:cNvPr id="2" name="Slide Image Placeholder 1"/>
-          <p:cNvSpPr>
-            <a:spLocks noGrp="1" noRot="1" noChangeAspect="1"/>
-          </p:cNvSpPr>
-          <p:nvPr>
-            <p:ph type="sldImg"/>
-          </p:nvPr>
-        </p:nvSpPr>
-        <p:spPr/>
-      </p:sp>
-      <p:sp>
-        <p:nvSpPr>
-          <p:cNvPr id="3" name="Notes Placeholder 2"/>
-          <p:cNvSpPr>
-            <a:spLocks noGrp="1"/>
-          </p:cNvSpPr>
-          <p:nvPr>
-            <p:ph type="body" idx="1"/>
-          </p:nvPr>
-        </p:nvSpPr>
-        <p:spPr/>
-        <p:txBody>
-          <a:bodyPr/>
-          <a:lstStyle/>
-          <a:p>
-            <a:endParaRPr lang="en-US" dirty="0"/>
-          </a:p>
-        </p:txBody>
-      </p:sp>
-      <p:sp>
-        <p:nvSpPr>
-          <p:cNvPr id="4" name="Slide Number Placeholder 3"/>
-          <p:cNvSpPr>
-            <a:spLocks noGrp="1"/>
-          </p:cNvSpPr>
-          <p:nvPr>
-            <p:ph type="sldNum" sz="quarter" idx="10"/>
-          </p:nvPr>
-        </p:nvSpPr>
-        <p:spPr/>
-        <p:txBody>
-          <a:bodyPr/>
-          <a:lstStyle/>
-          <a:p>
-            <a:fld id="{F7021451-1387-4CA6-816F-3879F97B5CBC}" type="slidenum">
-              <a:rPr lang="en-US"/>
-              <a:t>5</a:t>
-            </a:fld>
-            <a:endParaRPr lang="en-US"/>
-          </a:p>
-        </p:txBody>
-      </p:sp>
-    </p:spTree>
-    <p:extLst>
-      <p:ext uri="{BB962C8B-B14F-4D97-AF65-F5344CB8AC3E}">
-        <p14:creationId xmlns:p14="http://schemas.microsoft.com/office/powerpoint/2010/main" val="1024086991"/>
-      </p:ext>
-    </p:extLst>
-  </p:cSld>
-  <p:clrMapOvr>
-    <a:masterClrMapping/>
-  </p:clrMapOvr>
-</p:notes>
-</file>
-
-<file path=ppt\notesSlides\notesSlide6.xml><?xml version="1.0" encoding="utf-8"?>
-<p:notes xmlns:a="http://schemas.openxmlformats.org/drawingml/2006/main" xmlns:r="http://schemas.openxmlformats.org/officeDocument/2006/relationships" xmlns:p="http://schemas.openxmlformats.org/presentationml/2006/main">
-  <p:cSld>
-    <p:spTree>
-      <p:nvGrpSpPr>
-        <p:cNvPr id="1" name=""/>
-        <p:cNvGrpSpPr/>
-        <p:nvPr/>
-      </p:nvGrpSpPr>
-      <p:grpSpPr>
-        <a:xfrm>
-          <a:off x="0" y="0"/>
-          <a:ext cx="0" cy="0"/>
-          <a:chOff x="0" y="0"/>
-          <a:chExt cx="0" cy="0"/>
-        </a:xfrm>
-      </p:grpSpPr>
-      <p:sp>
-        <p:nvSpPr>
-          <p:cNvPr id="2" name="Slide Image Placeholder 1"/>
-          <p:cNvSpPr>
-            <a:spLocks noGrp="1" noRot="1" noChangeAspect="1"/>
-          </p:cNvSpPr>
-          <p:nvPr>
-            <p:ph type="sldImg"/>
-          </p:nvPr>
-        </p:nvSpPr>
-        <p:spPr/>
-      </p:sp>
-      <p:sp>
-        <p:nvSpPr>
-          <p:cNvPr id="3" name="Notes Placeholder 2"/>
-          <p:cNvSpPr>
-            <a:spLocks noGrp="1"/>
-          </p:cNvSpPr>
-          <p:nvPr>
-            <p:ph type="body" idx="1"/>
-          </p:nvPr>
-        </p:nvSpPr>
-        <p:spPr/>
-        <p:txBody>
-          <a:bodyPr/>
-          <a:lstStyle/>
-          <a:p>
-            <a:endParaRPr lang="en-US" dirty="0"/>
-          </a:p>
-        </p:txBody>
-      </p:sp>
-      <p:sp>
-        <p:nvSpPr>
-          <p:cNvPr id="4" name="Slide Number Placeholder 3"/>
-          <p:cNvSpPr>
-            <a:spLocks noGrp="1"/>
-          </p:cNvSpPr>
-          <p:nvPr>
-            <p:ph type="sldNum" sz="quarter" idx="10"/>
-          </p:nvPr>
-        </p:nvSpPr>
-        <p:spPr/>
-        <p:txBody>
-          <a:bodyPr/>
-          <a:lstStyle/>
-          <a:p>
-            <a:fld id="{F7021451-1387-4CA6-816F-3879F97B5CBC}" type="slidenum">
-              <a:rPr lang="en-US"/>
-              <a:t>6</a:t>
-            </a:fld>
-            <a:endParaRPr lang="en-US"/>
-          </a:p>
-        </p:txBody>
-      </p:sp>
-    </p:spTree>
-    <p:extLst>
-      <p:ext uri="{BB962C8B-B14F-4D97-AF65-F5344CB8AC3E}">
-        <p14:creationId xmlns:p14="http://schemas.microsoft.com/office/powerpoint/2010/main" val="1024086991"/>
-      </p:ext>
-    </p:extLst>
-  </p:cSld>
-  <p:clrMapOvr>
-    <a:masterClrMapping/>
-  </p:clrMapOvr>
-</p:notes>
-</file>
-
-<file path=ppt\notesSlides\notesSlide7.xml><?xml version="1.0" encoding="utf-8"?>
-<p:notes xmlns:a="http://schemas.openxmlformats.org/drawingml/2006/main" xmlns:r="http://schemas.openxmlformats.org/officeDocument/2006/relationships" xmlns:p="http://schemas.openxmlformats.org/presentationml/2006/main">
-  <p:cSld>
-    <p:spTree>
-      <p:nvGrpSpPr>
-        <p:cNvPr id="1" name=""/>
-        <p:cNvGrpSpPr/>
-        <p:nvPr/>
-      </p:nvGrpSpPr>
-      <p:grpSpPr>
-        <a:xfrm>
-          <a:off x="0" y="0"/>
-          <a:ext cx="0" cy="0"/>
-          <a:chOff x="0" y="0"/>
-          <a:chExt cx="0" cy="0"/>
-        </a:xfrm>
-      </p:grpSpPr>
-      <p:sp>
-        <p:nvSpPr>
-          <p:cNvPr id="2" name="Slide Image Placeholder 1"/>
-          <p:cNvSpPr>
-            <a:spLocks noGrp="1" noRot="1" noChangeAspect="1"/>
-          </p:cNvSpPr>
-          <p:nvPr>
-            <p:ph type="sldImg"/>
-          </p:nvPr>
-        </p:nvSpPr>
-        <p:spPr/>
-      </p:sp>
-      <p:sp>
-        <p:nvSpPr>
-          <p:cNvPr id="3" name="Notes Placeholder 2"/>
-          <p:cNvSpPr>
-            <a:spLocks noGrp="1"/>
-          </p:cNvSpPr>
-          <p:nvPr>
-            <p:ph type="body" idx="1"/>
-          </p:nvPr>
-        </p:nvSpPr>
-        <p:spPr/>
-        <p:txBody>
-          <a:bodyPr/>
-          <a:lstStyle/>
-          <a:p>
-            <a:endParaRPr lang="en-US" dirty="0"/>
-          </a:p>
-        </p:txBody>
-      </p:sp>
-      <p:sp>
-        <p:nvSpPr>
-          <p:cNvPr id="4" name="Slide Number Placeholder 3"/>
-          <p:cNvSpPr>
-            <a:spLocks noGrp="1"/>
-          </p:cNvSpPr>
-          <p:nvPr>
-            <p:ph type="sldNum" sz="quarter" idx="10"/>
-          </p:nvPr>
-        </p:nvSpPr>
-        <p:spPr/>
-        <p:txBody>
-          <a:bodyPr/>
-          <a:lstStyle/>
-          <a:p>
-            <a:fld id="{F7021451-1387-4CA6-816F-3879F97B5CBC}" type="slidenum">
-              <a:rPr lang="en-US"/>
-              <a:t>7</a:t>
-            </a:fld>
-            <a:endParaRPr lang="en-US"/>
-          </a:p>
-        </p:txBody>
-      </p:sp>
-    </p:spTree>
-    <p:extLst>
-      <p:ext uri="{BB962C8B-B14F-4D97-AF65-F5344CB8AC3E}">
-        <p14:creationId xmlns:p14="http://schemas.microsoft.com/office/powerpoint/2010/main" val="1024086991"/>
-      </p:ext>
-    </p:extLst>
-  </p:cSld>
-  <p:clrMapOvr>
-    <a:masterClrMapping/>
-  </p:clrMapOvr>
-</p:notes>
-</file>
-
-<file path=ppt\notesSlides\notesSlide8.xml><?xml version="1.0" encoding="utf-8"?>
-<p:notes xmlns:a="http://schemas.openxmlformats.org/drawingml/2006/main" xmlns:r="http://schemas.openxmlformats.org/officeDocument/2006/relationships" xmlns:p="http://schemas.openxmlformats.org/presentationml/2006/main">
-  <p:cSld>
-    <p:spTree>
-      <p:nvGrpSpPr>
-        <p:cNvPr id="1" name=""/>
-        <p:cNvGrpSpPr/>
-        <p:nvPr/>
-      </p:nvGrpSpPr>
-      <p:grpSpPr>
-        <a:xfrm>
-          <a:off x="0" y="0"/>
-          <a:ext cx="0" cy="0"/>
-          <a:chOff x="0" y="0"/>
-          <a:chExt cx="0" cy="0"/>
-        </a:xfrm>
-      </p:grpSpPr>
-      <p:sp>
-        <p:nvSpPr>
-          <p:cNvPr id="2" name="Slide Image Placeholder 1"/>
-          <p:cNvSpPr>
-            <a:spLocks noGrp="1" noRot="1" noChangeAspect="1"/>
-          </p:cNvSpPr>
-          <p:nvPr>
-            <p:ph type="sldImg"/>
-          </p:nvPr>
-        </p:nvSpPr>
-        <p:spPr/>
-      </p:sp>
-      <p:sp>
-        <p:nvSpPr>
-          <p:cNvPr id="3" name="Notes Placeholder 2"/>
-          <p:cNvSpPr>
-            <a:spLocks noGrp="1"/>
-          </p:cNvSpPr>
-          <p:nvPr>
-            <p:ph type="body" idx="1"/>
-          </p:nvPr>
-        </p:nvSpPr>
-        <p:spPr/>
-        <p:txBody>
-          <a:bodyPr/>
-          <a:lstStyle/>
-          <a:p>
-            <a:endParaRPr lang="en-US" dirty="0"/>
-          </a:p>
-        </p:txBody>
-      </p:sp>
-      <p:sp>
-        <p:nvSpPr>
-          <p:cNvPr id="4" name="Slide Number Placeholder 3"/>
-          <p:cNvSpPr>
-            <a:spLocks noGrp="1"/>
-          </p:cNvSpPr>
-          <p:nvPr>
-            <p:ph type="sldNum" sz="quarter" idx="10"/>
-          </p:nvPr>
-        </p:nvSpPr>
-        <p:spPr/>
-        <p:txBody>
-          <a:bodyPr/>
-          <a:lstStyle/>
-          <a:p>
-            <a:fld id="{F7021451-1387-4CA6-816F-3879F97B5CBC}" type="slidenum">
-              <a:rPr lang="en-US"/>
-              <a:t>8</a:t>
-            </a:fld>
-            <a:endParaRPr lang="en-US"/>
-          </a:p>
-        </p:txBody>
-      </p:sp>
-    </p:spTree>
-    <p:extLst>
-      <p:ext uri="{BB962C8B-B14F-4D97-AF65-F5344CB8AC3E}">
-        <p14:creationId xmlns:p14="http://schemas.microsoft.com/office/powerpoint/2010/main" val="1024086991"/>
-      </p:ext>
-    </p:extLst>
-  </p:cSld>
-  <p:clrMapOvr>
-    <a:masterClrMapping/>
-  </p:clrMapOvr>
-</p:notes>
-</file>
-
-<file path=ppt\notesSlides\notesSlide9.xml><?xml version="1.0" encoding="utf-8"?>
-<p:notes xmlns:a="http://schemas.openxmlformats.org/drawingml/2006/main" xmlns:r="http://schemas.openxmlformats.org/officeDocument/2006/relationships" xmlns:p="http://schemas.openxmlformats.org/presentationml/2006/main">
-  <p:cSld>
-    <p:spTree>
-      <p:nvGrpSpPr>
-        <p:cNvPr id="1" name=""/>
-        <p:cNvGrpSpPr/>
-        <p:nvPr/>
-      </p:nvGrpSpPr>
-      <p:grpSpPr>
-        <a:xfrm>
-          <a:off x="0" y="0"/>
-          <a:ext cx="0" cy="0"/>
-          <a:chOff x="0" y="0"/>
-          <a:chExt cx="0" cy="0"/>
-        </a:xfrm>
-      </p:grpSpPr>
-      <p:sp>
-        <p:nvSpPr>
-          <p:cNvPr id="2" name="Slide Image Placeholder 1"/>
-          <p:cNvSpPr>
-            <a:spLocks noGrp="1" noRot="1" noChangeAspect="1"/>
-          </p:cNvSpPr>
-          <p:nvPr>
-            <p:ph type="sldImg"/>
-          </p:nvPr>
-        </p:nvSpPr>
-        <p:spPr/>
-      </p:sp>
-      <p:sp>
-        <p:nvSpPr>
-          <p:cNvPr id="3" name="Notes Placeholder 2"/>
-          <p:cNvSpPr>
-            <a:spLocks noGrp="1"/>
-          </p:cNvSpPr>
-          <p:nvPr>
-            <p:ph type="body" idx="1"/>
-          </p:nvPr>
-        </p:nvSpPr>
-        <p:spPr/>
-        <p:txBody>
-          <a:bodyPr/>
-          <a:lstStyle/>
-          <a:p>
-            <a:endParaRPr lang="en-US" dirty="0"/>
-          </a:p>
-        </p:txBody>
-      </p:sp>
-      <p:sp>
-        <p:nvSpPr>
-          <p:cNvPr id="4" name="Slide Number Placeholder 3"/>
-          <p:cNvSpPr>
-            <a:spLocks noGrp="1"/>
-          </p:cNvSpPr>
-          <p:nvPr>
-            <p:ph type="sldNum" sz="quarter" idx="10"/>
-          </p:nvPr>
-        </p:nvSpPr>
-        <p:spPr/>
-        <p:txBody>
-          <a:bodyPr/>
-          <a:lstStyle/>
-          <a:p>
-            <a:fld id="{F7021451-1387-4CA6-816F-3879F97B5CBC}" type="slidenum">
-              <a:rPr lang="en-US"/>
-              <a:t>9</a:t>
-            </a:fld>
-            <a:endParaRPr lang="en-US"/>
-          </a:p>
-        </p:txBody>
-      </p:sp>
-    </p:spTree>
-    <p:extLst>
-      <p:ext uri="{BB962C8B-B14F-4D97-AF65-F5344CB8AC3E}">
-        <p14:creationId xmlns:p14="http://schemas.microsoft.com/office/powerpoint/2010/main" val="1024086991"/>
-      </p:ext>
-    </p:extLst>
-  </p:cSld>
-  <p:clrMapOvr>
-    <a:masterClrMapping/>
-  </p:clrMapOvr>
-</p:notes>
-</file>
-
-<file path=ppt\presProps.xml><?xml version="1.0" encoding="utf-8"?>
-<p:presentationPr xmlns:a="http://schemas.openxmlformats.org/drawingml/2006/main" xmlns:r="http://schemas.openxmlformats.org/officeDocument/2006/relationships" xmlns:p="http://schemas.openxmlformats.org/presentationml/2006/main">
-  <p:extLst>
-    <p:ext uri="{E76CE94A-603C-4142-B9EB-6D1370010A27}">
-      <p14:discardImageEditData xmlns:p14="http://schemas.microsoft.com/office/powerpoint/2010/main" val="0"/>
-    </p:ext>
-    <p:ext uri="{D31A062A-798A-4329-ABDD-BBA856620510}">
-      <p14:defaultImageDpi xmlns:p14="http://schemas.microsoft.com/office/powerpoint/2010/main" val="220"/>
-    </p:ext>
-    <p:ext uri="{FD5EFAAD-0ECE-453E-9831-46B23BE46B34}">
-      <p15:chartTrackingRefBased xmlns:p15="http://schemas.microsoft.com/office/powerpoint/2012/main" val="0"/>
-    </p:ext>
-  </p:extLst>
-</p:presentationPr>
-</file>
-
-<file path=ppt\presentation.xml><?xml version="1.0" encoding="utf-8"?>
+<file path=ppt/presentation.xml><?xml version="1.0" encoding="utf-8"?>
 <p:presentation xmlns:a="http://schemas.openxmlformats.org/drawingml/2006/main" xmlns:r="http://schemas.openxmlformats.org/officeDocument/2006/relationships" xmlns:p="http://schemas.openxmlformats.org/presentationml/2006/main" saveSubsetFonts="1" autoCompressPictures="0">
   <p:sldMasterIdLst>
     <p:sldMasterId id="2147483648" r:id="rId1"/>
@@ -1690,7 +127,1588 @@
 </p:presentation>
 </file>
 
-<file path=ppt\slideLayouts\slideLayout1.xml><?xml version="1.0" encoding="utf-8"?>
+<file path=ppt/notesMasters/notesMaster1.xml><?xml version="1.0" encoding="utf-8"?>
+<p:notesMaster xmlns:a="http://schemas.openxmlformats.org/drawingml/2006/main" xmlns:r="http://schemas.openxmlformats.org/officeDocument/2006/relationships" xmlns:p="http://schemas.openxmlformats.org/presentationml/2006/main">
+  <p:cSld>
+    <p:bg>
+      <p:bgRef idx="1001">
+        <a:schemeClr val="bg1"/>
+      </p:bgRef>
+    </p:bg>
+    <p:spTree>
+      <p:nvGrpSpPr>
+        <p:cNvPr id="1" name=""/>
+        <p:cNvGrpSpPr/>
+        <p:nvPr/>
+      </p:nvGrpSpPr>
+      <p:grpSpPr>
+        <a:xfrm>
+          <a:off x="0" y="0"/>
+          <a:ext cx="0" cy="0"/>
+          <a:chOff x="0" y="0"/>
+          <a:chExt cx="0" cy="0"/>
+        </a:xfrm>
+      </p:grpSpPr>
+    </p:spTree>
+    <p:extLst>
+      <p:ext uri="{BB962C8B-B14F-4D97-AF65-F5344CB8AC3E}">
+        <p14:creationId xmlns:p14="http://schemas.microsoft.com/office/powerpoint/2010/main" val="776189880"/>
+      </p:ext>
+    </p:extLst>
+  </p:cSld>
+  <p:clrMap bg1="lt1" tx1="dk1" bg2="lt2" tx2="dk2" accent1="accent1" accent2="accent2" accent3="accent3" accent4="accent4" accent5="accent5" accent6="accent6" hlink="hlink" folHlink="folHlink"/>
+  <p:notesStyle>
+    <a:lvl1pPr marL="0" algn="l" defTabSz="914400" rtl="0" eaLnBrk="1" latinLnBrk="0" hangingPunct="1">
+      <a:defRPr sz="1200" kern="1200">
+        <a:solidFill>
+          <a:schemeClr val="tx1"/>
+        </a:solidFill>
+        <a:latin typeface="+mn-lt"/>
+        <a:ea typeface="+mn-ea"/>
+        <a:cs typeface="+mn-cs"/>
+      </a:defRPr>
+    </a:lvl1pPr>
+    <a:lvl2pPr marL="457200" algn="l" defTabSz="914400" rtl="0" eaLnBrk="1" latinLnBrk="0" hangingPunct="1">
+      <a:defRPr sz="1200" kern="1200">
+        <a:solidFill>
+          <a:schemeClr val="tx1"/>
+        </a:solidFill>
+        <a:latin typeface="+mn-lt"/>
+        <a:ea typeface="+mn-ea"/>
+        <a:cs typeface="+mn-cs"/>
+      </a:defRPr>
+    </a:lvl2pPr>
+    <a:lvl3pPr marL="914400" algn="l" defTabSz="914400" rtl="0" eaLnBrk="1" latinLnBrk="0" hangingPunct="1">
+      <a:defRPr sz="1200" kern="1200">
+        <a:solidFill>
+          <a:schemeClr val="tx1"/>
+        </a:solidFill>
+        <a:latin typeface="+mn-lt"/>
+        <a:ea typeface="+mn-ea"/>
+        <a:cs typeface="+mn-cs"/>
+      </a:defRPr>
+    </a:lvl3pPr>
+    <a:lvl4pPr marL="1371600" algn="l" defTabSz="914400" rtl="0" eaLnBrk="1" latinLnBrk="0" hangingPunct="1">
+      <a:defRPr sz="1200" kern="1200">
+        <a:solidFill>
+          <a:schemeClr val="tx1"/>
+        </a:solidFill>
+        <a:latin typeface="+mn-lt"/>
+        <a:ea typeface="+mn-ea"/>
+        <a:cs typeface="+mn-cs"/>
+      </a:defRPr>
+    </a:lvl4pPr>
+    <a:lvl5pPr marL="1828800" algn="l" defTabSz="914400" rtl="0" eaLnBrk="1" latinLnBrk="0" hangingPunct="1">
+      <a:defRPr sz="1200" kern="1200">
+        <a:solidFill>
+          <a:schemeClr val="tx1"/>
+        </a:solidFill>
+        <a:latin typeface="+mn-lt"/>
+        <a:ea typeface="+mn-ea"/>
+        <a:cs typeface="+mn-cs"/>
+      </a:defRPr>
+    </a:lvl5pPr>
+    <a:lvl6pPr marL="2286000" algn="l" defTabSz="914400" rtl="0" eaLnBrk="1" latinLnBrk="0" hangingPunct="1">
+      <a:defRPr sz="1200" kern="1200">
+        <a:solidFill>
+          <a:schemeClr val="tx1"/>
+        </a:solidFill>
+        <a:latin typeface="+mn-lt"/>
+        <a:ea typeface="+mn-ea"/>
+        <a:cs typeface="+mn-cs"/>
+      </a:defRPr>
+    </a:lvl6pPr>
+    <a:lvl7pPr marL="2743200" algn="l" defTabSz="914400" rtl="0" eaLnBrk="1" latinLnBrk="0" hangingPunct="1">
+      <a:defRPr sz="1200" kern="1200">
+        <a:solidFill>
+          <a:schemeClr val="tx1"/>
+        </a:solidFill>
+        <a:latin typeface="+mn-lt"/>
+        <a:ea typeface="+mn-ea"/>
+        <a:cs typeface="+mn-cs"/>
+      </a:defRPr>
+    </a:lvl7pPr>
+    <a:lvl8pPr marL="3200400" algn="l" defTabSz="914400" rtl="0" eaLnBrk="1" latinLnBrk="0" hangingPunct="1">
+      <a:defRPr sz="1200" kern="1200">
+        <a:solidFill>
+          <a:schemeClr val="tx1"/>
+        </a:solidFill>
+        <a:latin typeface="+mn-lt"/>
+        <a:ea typeface="+mn-ea"/>
+        <a:cs typeface="+mn-cs"/>
+      </a:defRPr>
+    </a:lvl8pPr>
+    <a:lvl9pPr marL="3657600" algn="l" defTabSz="914400" rtl="0" eaLnBrk="1" latinLnBrk="0" hangingPunct="1">
+      <a:defRPr sz="1200" kern="1200">
+        <a:solidFill>
+          <a:schemeClr val="tx1"/>
+        </a:solidFill>
+        <a:latin typeface="+mn-lt"/>
+        <a:ea typeface="+mn-ea"/>
+        <a:cs typeface="+mn-cs"/>
+      </a:defRPr>
+    </a:lvl9pPr>
+  </p:notesStyle>
+</p:notesMaster>
+</file>
+
+<file path=ppt/notesSlides/notesSlide1.xml><?xml version="1.0" encoding="utf-8"?>
+<p:notes xmlns:a="http://schemas.openxmlformats.org/drawingml/2006/main" xmlns:r="http://schemas.openxmlformats.org/officeDocument/2006/relationships" xmlns:p="http://schemas.openxmlformats.org/presentationml/2006/main">
+  <p:cSld>
+    <p:spTree>
+      <p:nvGrpSpPr>
+        <p:cNvPr id="1" name=""/>
+        <p:cNvGrpSpPr/>
+        <p:nvPr/>
+      </p:nvGrpSpPr>
+      <p:grpSpPr>
+        <a:xfrm>
+          <a:off x="0" y="0"/>
+          <a:ext cx="0" cy="0"/>
+          <a:chOff x="0" y="0"/>
+          <a:chExt cx="0" cy="0"/>
+        </a:xfrm>
+      </p:grpSpPr>
+      <p:sp>
+        <p:nvSpPr>
+          <p:cNvPr id="2" name="Slide Image Placeholder 1"/>
+          <p:cNvSpPr>
+            <a:spLocks noGrp="1" noRot="1" noChangeAspect="1"/>
+          </p:cNvSpPr>
+          <p:nvPr>
+            <p:ph type="sldImg"/>
+          </p:nvPr>
+        </p:nvSpPr>
+        <p:spPr/>
+        <p:txBody>
+          <a:bodyPr/>
+          <a:lstStyle/>
+          <a:p>
+            <a:endParaRPr lang="en-US"/>
+          </a:p>
+        </p:txBody>
+      </p:sp>
+      <p:sp>
+        <p:nvSpPr>
+          <p:cNvPr id="3" name="Notes Placeholder 2"/>
+          <p:cNvSpPr>
+            <a:spLocks noGrp="1"/>
+          </p:cNvSpPr>
+          <p:nvPr>
+            <p:ph type="body" idx="1"/>
+          </p:nvPr>
+        </p:nvSpPr>
+        <p:spPr/>
+        <p:txBody>
+          <a:bodyPr/>
+          <a:lstStyle/>
+          <a:p>
+            <a:endParaRPr lang="en-US" dirty="0"/>
+          </a:p>
+        </p:txBody>
+      </p:sp>
+      <p:sp>
+        <p:nvSpPr>
+          <p:cNvPr id="4" name="Slide Number Placeholder 3"/>
+          <p:cNvSpPr>
+            <a:spLocks noGrp="1"/>
+          </p:cNvSpPr>
+          <p:nvPr>
+            <p:ph type="sldNum" sz="quarter" idx="10"/>
+          </p:nvPr>
+        </p:nvSpPr>
+        <p:spPr/>
+        <p:txBody>
+          <a:bodyPr/>
+          <a:lstStyle/>
+          <a:p>
+            <a:fld id="{F7021451-1387-4CA6-816F-3879F97B5CBC}" type="slidenum">
+              <a:rPr lang="en-US"/>
+              <a:t>1</a:t>
+            </a:fld>
+            <a:endParaRPr lang="en-US"/>
+          </a:p>
+        </p:txBody>
+      </p:sp>
+    </p:spTree>
+    <p:extLst>
+      <p:ext uri="{BB962C8B-B14F-4D97-AF65-F5344CB8AC3E}">
+        <p14:creationId xmlns:p14="http://schemas.microsoft.com/office/powerpoint/2010/main" val="1024086991"/>
+      </p:ext>
+    </p:extLst>
+  </p:cSld>
+  <p:clrMapOvr>
+    <a:masterClrMapping/>
+  </p:clrMapOvr>
+</p:notes>
+</file>
+
+<file path=ppt/notesSlides/notesSlide10.xml><?xml version="1.0" encoding="utf-8"?>
+<p:notes xmlns:a="http://schemas.openxmlformats.org/drawingml/2006/main" xmlns:r="http://schemas.openxmlformats.org/officeDocument/2006/relationships" xmlns:p="http://schemas.openxmlformats.org/presentationml/2006/main">
+  <p:cSld>
+    <p:spTree>
+      <p:nvGrpSpPr>
+        <p:cNvPr id="1" name=""/>
+        <p:cNvGrpSpPr/>
+        <p:nvPr/>
+      </p:nvGrpSpPr>
+      <p:grpSpPr>
+        <a:xfrm>
+          <a:off x="0" y="0"/>
+          <a:ext cx="0" cy="0"/>
+          <a:chOff x="0" y="0"/>
+          <a:chExt cx="0" cy="0"/>
+        </a:xfrm>
+      </p:grpSpPr>
+      <p:sp>
+        <p:nvSpPr>
+          <p:cNvPr id="2" name="Slide Image Placeholder 1"/>
+          <p:cNvSpPr>
+            <a:spLocks noGrp="1" noRot="1" noChangeAspect="1"/>
+          </p:cNvSpPr>
+          <p:nvPr>
+            <p:ph type="sldImg"/>
+          </p:nvPr>
+        </p:nvSpPr>
+        <p:spPr/>
+        <p:txBody>
+          <a:bodyPr/>
+          <a:lstStyle/>
+          <a:p>
+            <a:endParaRPr lang="en-US"/>
+          </a:p>
+        </p:txBody>
+      </p:sp>
+      <p:sp>
+        <p:nvSpPr>
+          <p:cNvPr id="3" name="Notes Placeholder 2"/>
+          <p:cNvSpPr>
+            <a:spLocks noGrp="1"/>
+          </p:cNvSpPr>
+          <p:nvPr>
+            <p:ph type="body" idx="1"/>
+          </p:nvPr>
+        </p:nvSpPr>
+        <p:spPr/>
+        <p:txBody>
+          <a:bodyPr/>
+          <a:lstStyle/>
+          <a:p>
+            <a:endParaRPr lang="en-US" dirty="0"/>
+          </a:p>
+        </p:txBody>
+      </p:sp>
+      <p:sp>
+        <p:nvSpPr>
+          <p:cNvPr id="4" name="Slide Number Placeholder 3"/>
+          <p:cNvSpPr>
+            <a:spLocks noGrp="1"/>
+          </p:cNvSpPr>
+          <p:nvPr>
+            <p:ph type="sldNum" sz="quarter" idx="10"/>
+          </p:nvPr>
+        </p:nvSpPr>
+        <p:spPr/>
+        <p:txBody>
+          <a:bodyPr/>
+          <a:lstStyle/>
+          <a:p>
+            <a:fld id="{F7021451-1387-4CA6-816F-3879F97B5CBC}" type="slidenum">
+              <a:rPr lang="en-US"/>
+              <a:t>10</a:t>
+            </a:fld>
+            <a:endParaRPr lang="en-US"/>
+          </a:p>
+        </p:txBody>
+      </p:sp>
+    </p:spTree>
+    <p:extLst>
+      <p:ext uri="{BB962C8B-B14F-4D97-AF65-F5344CB8AC3E}">
+        <p14:creationId xmlns:p14="http://schemas.microsoft.com/office/powerpoint/2010/main" val="1024086991"/>
+      </p:ext>
+    </p:extLst>
+  </p:cSld>
+  <p:clrMapOvr>
+    <a:masterClrMapping/>
+  </p:clrMapOvr>
+</p:notes>
+</file>
+
+<file path=ppt/notesSlides/notesSlide11.xml><?xml version="1.0" encoding="utf-8"?>
+<p:notes xmlns:a="http://schemas.openxmlformats.org/drawingml/2006/main" xmlns:r="http://schemas.openxmlformats.org/officeDocument/2006/relationships" xmlns:p="http://schemas.openxmlformats.org/presentationml/2006/main">
+  <p:cSld>
+    <p:spTree>
+      <p:nvGrpSpPr>
+        <p:cNvPr id="1" name=""/>
+        <p:cNvGrpSpPr/>
+        <p:nvPr/>
+      </p:nvGrpSpPr>
+      <p:grpSpPr>
+        <a:xfrm>
+          <a:off x="0" y="0"/>
+          <a:ext cx="0" cy="0"/>
+          <a:chOff x="0" y="0"/>
+          <a:chExt cx="0" cy="0"/>
+        </a:xfrm>
+      </p:grpSpPr>
+      <p:sp>
+        <p:nvSpPr>
+          <p:cNvPr id="2" name="Slide Image Placeholder 1"/>
+          <p:cNvSpPr>
+            <a:spLocks noGrp="1" noRot="1" noChangeAspect="1"/>
+          </p:cNvSpPr>
+          <p:nvPr>
+            <p:ph type="sldImg"/>
+          </p:nvPr>
+        </p:nvSpPr>
+        <p:spPr/>
+        <p:txBody>
+          <a:bodyPr/>
+          <a:lstStyle/>
+          <a:p>
+            <a:endParaRPr lang="en-US"/>
+          </a:p>
+        </p:txBody>
+      </p:sp>
+      <p:sp>
+        <p:nvSpPr>
+          <p:cNvPr id="3" name="Notes Placeholder 2"/>
+          <p:cNvSpPr>
+            <a:spLocks noGrp="1"/>
+          </p:cNvSpPr>
+          <p:nvPr>
+            <p:ph type="body" idx="1"/>
+          </p:nvPr>
+        </p:nvSpPr>
+        <p:spPr/>
+        <p:txBody>
+          <a:bodyPr/>
+          <a:lstStyle/>
+          <a:p>
+            <a:endParaRPr lang="en-US" dirty="0"/>
+          </a:p>
+        </p:txBody>
+      </p:sp>
+      <p:sp>
+        <p:nvSpPr>
+          <p:cNvPr id="4" name="Slide Number Placeholder 3"/>
+          <p:cNvSpPr>
+            <a:spLocks noGrp="1"/>
+          </p:cNvSpPr>
+          <p:nvPr>
+            <p:ph type="sldNum" sz="quarter" idx="10"/>
+          </p:nvPr>
+        </p:nvSpPr>
+        <p:spPr/>
+        <p:txBody>
+          <a:bodyPr/>
+          <a:lstStyle/>
+          <a:p>
+            <a:fld id="{F7021451-1387-4CA6-816F-3879F97B5CBC}" type="slidenum">
+              <a:rPr lang="en-US"/>
+              <a:t>11</a:t>
+            </a:fld>
+            <a:endParaRPr lang="en-US"/>
+          </a:p>
+        </p:txBody>
+      </p:sp>
+    </p:spTree>
+    <p:extLst>
+      <p:ext uri="{BB962C8B-B14F-4D97-AF65-F5344CB8AC3E}">
+        <p14:creationId xmlns:p14="http://schemas.microsoft.com/office/powerpoint/2010/main" val="1024086991"/>
+      </p:ext>
+    </p:extLst>
+  </p:cSld>
+  <p:clrMapOvr>
+    <a:masterClrMapping/>
+  </p:clrMapOvr>
+</p:notes>
+</file>
+
+<file path=ppt/notesSlides/notesSlide12.xml><?xml version="1.0" encoding="utf-8"?>
+<p:notes xmlns:a="http://schemas.openxmlformats.org/drawingml/2006/main" xmlns:r="http://schemas.openxmlformats.org/officeDocument/2006/relationships" xmlns:p="http://schemas.openxmlformats.org/presentationml/2006/main">
+  <p:cSld>
+    <p:spTree>
+      <p:nvGrpSpPr>
+        <p:cNvPr id="1" name=""/>
+        <p:cNvGrpSpPr/>
+        <p:nvPr/>
+      </p:nvGrpSpPr>
+      <p:grpSpPr>
+        <a:xfrm>
+          <a:off x="0" y="0"/>
+          <a:ext cx="0" cy="0"/>
+          <a:chOff x="0" y="0"/>
+          <a:chExt cx="0" cy="0"/>
+        </a:xfrm>
+      </p:grpSpPr>
+      <p:sp>
+        <p:nvSpPr>
+          <p:cNvPr id="2" name="Slide Image Placeholder 1"/>
+          <p:cNvSpPr>
+            <a:spLocks noGrp="1" noRot="1" noChangeAspect="1"/>
+          </p:cNvSpPr>
+          <p:nvPr>
+            <p:ph type="sldImg"/>
+          </p:nvPr>
+        </p:nvSpPr>
+        <p:spPr/>
+        <p:txBody>
+          <a:bodyPr/>
+          <a:lstStyle/>
+          <a:p>
+            <a:endParaRPr lang="en-US"/>
+          </a:p>
+        </p:txBody>
+      </p:sp>
+      <p:sp>
+        <p:nvSpPr>
+          <p:cNvPr id="3" name="Notes Placeholder 2"/>
+          <p:cNvSpPr>
+            <a:spLocks noGrp="1"/>
+          </p:cNvSpPr>
+          <p:nvPr>
+            <p:ph type="body" idx="1"/>
+          </p:nvPr>
+        </p:nvSpPr>
+        <p:spPr/>
+        <p:txBody>
+          <a:bodyPr/>
+          <a:lstStyle/>
+          <a:p>
+            <a:endParaRPr lang="en-US" dirty="0"/>
+          </a:p>
+        </p:txBody>
+      </p:sp>
+      <p:sp>
+        <p:nvSpPr>
+          <p:cNvPr id="4" name="Slide Number Placeholder 3"/>
+          <p:cNvSpPr>
+            <a:spLocks noGrp="1"/>
+          </p:cNvSpPr>
+          <p:nvPr>
+            <p:ph type="sldNum" sz="quarter" idx="10"/>
+          </p:nvPr>
+        </p:nvSpPr>
+        <p:spPr/>
+        <p:txBody>
+          <a:bodyPr/>
+          <a:lstStyle/>
+          <a:p>
+            <a:fld id="{F7021451-1387-4CA6-816F-3879F97B5CBC}" type="slidenum">
+              <a:rPr lang="en-US"/>
+              <a:t>12</a:t>
+            </a:fld>
+            <a:endParaRPr lang="en-US"/>
+          </a:p>
+        </p:txBody>
+      </p:sp>
+    </p:spTree>
+    <p:extLst>
+      <p:ext uri="{BB962C8B-B14F-4D97-AF65-F5344CB8AC3E}">
+        <p14:creationId xmlns:p14="http://schemas.microsoft.com/office/powerpoint/2010/main" val="1024086991"/>
+      </p:ext>
+    </p:extLst>
+  </p:cSld>
+  <p:clrMapOvr>
+    <a:masterClrMapping/>
+  </p:clrMapOvr>
+</p:notes>
+</file>
+
+<file path=ppt/notesSlides/notesSlide13.xml><?xml version="1.0" encoding="utf-8"?>
+<p:notes xmlns:a="http://schemas.openxmlformats.org/drawingml/2006/main" xmlns:r="http://schemas.openxmlformats.org/officeDocument/2006/relationships" xmlns:p="http://schemas.openxmlformats.org/presentationml/2006/main">
+  <p:cSld>
+    <p:spTree>
+      <p:nvGrpSpPr>
+        <p:cNvPr id="1" name=""/>
+        <p:cNvGrpSpPr/>
+        <p:nvPr/>
+      </p:nvGrpSpPr>
+      <p:grpSpPr>
+        <a:xfrm>
+          <a:off x="0" y="0"/>
+          <a:ext cx="0" cy="0"/>
+          <a:chOff x="0" y="0"/>
+          <a:chExt cx="0" cy="0"/>
+        </a:xfrm>
+      </p:grpSpPr>
+      <p:sp>
+        <p:nvSpPr>
+          <p:cNvPr id="2" name="Slide Image Placeholder 1"/>
+          <p:cNvSpPr>
+            <a:spLocks noGrp="1" noRot="1" noChangeAspect="1"/>
+          </p:cNvSpPr>
+          <p:nvPr>
+            <p:ph type="sldImg"/>
+          </p:nvPr>
+        </p:nvSpPr>
+        <p:spPr/>
+        <p:txBody>
+          <a:bodyPr/>
+          <a:lstStyle/>
+          <a:p>
+            <a:endParaRPr lang="en-US"/>
+          </a:p>
+        </p:txBody>
+      </p:sp>
+      <p:sp>
+        <p:nvSpPr>
+          <p:cNvPr id="3" name="Notes Placeholder 2"/>
+          <p:cNvSpPr>
+            <a:spLocks noGrp="1"/>
+          </p:cNvSpPr>
+          <p:nvPr>
+            <p:ph type="body" idx="1"/>
+          </p:nvPr>
+        </p:nvSpPr>
+        <p:spPr/>
+        <p:txBody>
+          <a:bodyPr/>
+          <a:lstStyle/>
+          <a:p>
+            <a:endParaRPr lang="en-US" dirty="0"/>
+          </a:p>
+        </p:txBody>
+      </p:sp>
+      <p:sp>
+        <p:nvSpPr>
+          <p:cNvPr id="4" name="Slide Number Placeholder 3"/>
+          <p:cNvSpPr>
+            <a:spLocks noGrp="1"/>
+          </p:cNvSpPr>
+          <p:nvPr>
+            <p:ph type="sldNum" sz="quarter" idx="10"/>
+          </p:nvPr>
+        </p:nvSpPr>
+        <p:spPr/>
+        <p:txBody>
+          <a:bodyPr/>
+          <a:lstStyle/>
+          <a:p>
+            <a:fld id="{F7021451-1387-4CA6-816F-3879F97B5CBC}" type="slidenum">
+              <a:rPr lang="en-US"/>
+              <a:t>13</a:t>
+            </a:fld>
+            <a:endParaRPr lang="en-US"/>
+          </a:p>
+        </p:txBody>
+      </p:sp>
+    </p:spTree>
+    <p:extLst>
+      <p:ext uri="{BB962C8B-B14F-4D97-AF65-F5344CB8AC3E}">
+        <p14:creationId xmlns:p14="http://schemas.microsoft.com/office/powerpoint/2010/main" val="1024086991"/>
+      </p:ext>
+    </p:extLst>
+  </p:cSld>
+  <p:clrMapOvr>
+    <a:masterClrMapping/>
+  </p:clrMapOvr>
+</p:notes>
+</file>
+
+<file path=ppt/notesSlides/notesSlide14.xml><?xml version="1.0" encoding="utf-8"?>
+<p:notes xmlns:a="http://schemas.openxmlformats.org/drawingml/2006/main" xmlns:r="http://schemas.openxmlformats.org/officeDocument/2006/relationships" xmlns:p="http://schemas.openxmlformats.org/presentationml/2006/main">
+  <p:cSld>
+    <p:spTree>
+      <p:nvGrpSpPr>
+        <p:cNvPr id="1" name=""/>
+        <p:cNvGrpSpPr/>
+        <p:nvPr/>
+      </p:nvGrpSpPr>
+      <p:grpSpPr>
+        <a:xfrm>
+          <a:off x="0" y="0"/>
+          <a:ext cx="0" cy="0"/>
+          <a:chOff x="0" y="0"/>
+          <a:chExt cx="0" cy="0"/>
+        </a:xfrm>
+      </p:grpSpPr>
+      <p:sp>
+        <p:nvSpPr>
+          <p:cNvPr id="2" name="Slide Image Placeholder 1"/>
+          <p:cNvSpPr>
+            <a:spLocks noGrp="1" noRot="1" noChangeAspect="1"/>
+          </p:cNvSpPr>
+          <p:nvPr>
+            <p:ph type="sldImg"/>
+          </p:nvPr>
+        </p:nvSpPr>
+        <p:spPr/>
+        <p:txBody>
+          <a:bodyPr/>
+          <a:lstStyle/>
+          <a:p>
+            <a:endParaRPr lang="en-US"/>
+          </a:p>
+        </p:txBody>
+      </p:sp>
+      <p:sp>
+        <p:nvSpPr>
+          <p:cNvPr id="3" name="Notes Placeholder 2"/>
+          <p:cNvSpPr>
+            <a:spLocks noGrp="1"/>
+          </p:cNvSpPr>
+          <p:nvPr>
+            <p:ph type="body" idx="1"/>
+          </p:nvPr>
+        </p:nvSpPr>
+        <p:spPr/>
+        <p:txBody>
+          <a:bodyPr/>
+          <a:lstStyle/>
+          <a:p>
+            <a:endParaRPr lang="en-US" dirty="0"/>
+          </a:p>
+        </p:txBody>
+      </p:sp>
+      <p:sp>
+        <p:nvSpPr>
+          <p:cNvPr id="4" name="Slide Number Placeholder 3"/>
+          <p:cNvSpPr>
+            <a:spLocks noGrp="1"/>
+          </p:cNvSpPr>
+          <p:nvPr>
+            <p:ph type="sldNum" sz="quarter" idx="10"/>
+          </p:nvPr>
+        </p:nvSpPr>
+        <p:spPr/>
+        <p:txBody>
+          <a:bodyPr/>
+          <a:lstStyle/>
+          <a:p>
+            <a:fld id="{F7021451-1387-4CA6-816F-3879F97B5CBC}" type="slidenum">
+              <a:rPr lang="en-US"/>
+              <a:t>14</a:t>
+            </a:fld>
+            <a:endParaRPr lang="en-US"/>
+          </a:p>
+        </p:txBody>
+      </p:sp>
+    </p:spTree>
+    <p:extLst>
+      <p:ext uri="{BB962C8B-B14F-4D97-AF65-F5344CB8AC3E}">
+        <p14:creationId xmlns:p14="http://schemas.microsoft.com/office/powerpoint/2010/main" val="1024086991"/>
+      </p:ext>
+    </p:extLst>
+  </p:cSld>
+  <p:clrMapOvr>
+    <a:masterClrMapping/>
+  </p:clrMapOvr>
+</p:notes>
+</file>
+
+<file path=ppt/notesSlides/notesSlide15.xml><?xml version="1.0" encoding="utf-8"?>
+<p:notes xmlns:a="http://schemas.openxmlformats.org/drawingml/2006/main" xmlns:r="http://schemas.openxmlformats.org/officeDocument/2006/relationships" xmlns:p="http://schemas.openxmlformats.org/presentationml/2006/main">
+  <p:cSld>
+    <p:spTree>
+      <p:nvGrpSpPr>
+        <p:cNvPr id="1" name=""/>
+        <p:cNvGrpSpPr/>
+        <p:nvPr/>
+      </p:nvGrpSpPr>
+      <p:grpSpPr>
+        <a:xfrm>
+          <a:off x="0" y="0"/>
+          <a:ext cx="0" cy="0"/>
+          <a:chOff x="0" y="0"/>
+          <a:chExt cx="0" cy="0"/>
+        </a:xfrm>
+      </p:grpSpPr>
+      <p:sp>
+        <p:nvSpPr>
+          <p:cNvPr id="2" name="Slide Image Placeholder 1"/>
+          <p:cNvSpPr>
+            <a:spLocks noGrp="1" noRot="1" noChangeAspect="1"/>
+          </p:cNvSpPr>
+          <p:nvPr>
+            <p:ph type="sldImg"/>
+          </p:nvPr>
+        </p:nvSpPr>
+        <p:spPr/>
+        <p:txBody>
+          <a:bodyPr/>
+          <a:lstStyle/>
+          <a:p>
+            <a:endParaRPr lang="en-US"/>
+          </a:p>
+        </p:txBody>
+      </p:sp>
+      <p:sp>
+        <p:nvSpPr>
+          <p:cNvPr id="3" name="Notes Placeholder 2"/>
+          <p:cNvSpPr>
+            <a:spLocks noGrp="1"/>
+          </p:cNvSpPr>
+          <p:nvPr>
+            <p:ph type="body" idx="1"/>
+          </p:nvPr>
+        </p:nvSpPr>
+        <p:spPr/>
+        <p:txBody>
+          <a:bodyPr/>
+          <a:lstStyle/>
+          <a:p>
+            <a:endParaRPr lang="en-US" dirty="0"/>
+          </a:p>
+        </p:txBody>
+      </p:sp>
+      <p:sp>
+        <p:nvSpPr>
+          <p:cNvPr id="4" name="Slide Number Placeholder 3"/>
+          <p:cNvSpPr>
+            <a:spLocks noGrp="1"/>
+          </p:cNvSpPr>
+          <p:nvPr>
+            <p:ph type="sldNum" sz="quarter" idx="10"/>
+          </p:nvPr>
+        </p:nvSpPr>
+        <p:spPr/>
+        <p:txBody>
+          <a:bodyPr/>
+          <a:lstStyle/>
+          <a:p>
+            <a:fld id="{F7021451-1387-4CA6-816F-3879F97B5CBC}" type="slidenum">
+              <a:rPr lang="en-US"/>
+              <a:t>15</a:t>
+            </a:fld>
+            <a:endParaRPr lang="en-US"/>
+          </a:p>
+        </p:txBody>
+      </p:sp>
+    </p:spTree>
+    <p:extLst>
+      <p:ext uri="{BB962C8B-B14F-4D97-AF65-F5344CB8AC3E}">
+        <p14:creationId xmlns:p14="http://schemas.microsoft.com/office/powerpoint/2010/main" val="1024086991"/>
+      </p:ext>
+    </p:extLst>
+  </p:cSld>
+  <p:clrMapOvr>
+    <a:masterClrMapping/>
+  </p:clrMapOvr>
+</p:notes>
+</file>
+
+<file path=ppt/notesSlides/notesSlide16.xml><?xml version="1.0" encoding="utf-8"?>
+<p:notes xmlns:a="http://schemas.openxmlformats.org/drawingml/2006/main" xmlns:r="http://schemas.openxmlformats.org/officeDocument/2006/relationships" xmlns:p="http://schemas.openxmlformats.org/presentationml/2006/main">
+  <p:cSld>
+    <p:spTree>
+      <p:nvGrpSpPr>
+        <p:cNvPr id="1" name=""/>
+        <p:cNvGrpSpPr/>
+        <p:nvPr/>
+      </p:nvGrpSpPr>
+      <p:grpSpPr>
+        <a:xfrm>
+          <a:off x="0" y="0"/>
+          <a:ext cx="0" cy="0"/>
+          <a:chOff x="0" y="0"/>
+          <a:chExt cx="0" cy="0"/>
+        </a:xfrm>
+      </p:grpSpPr>
+      <p:sp>
+        <p:nvSpPr>
+          <p:cNvPr id="2" name="Slide Image Placeholder 1"/>
+          <p:cNvSpPr>
+            <a:spLocks noGrp="1" noRot="1" noChangeAspect="1"/>
+          </p:cNvSpPr>
+          <p:nvPr>
+            <p:ph type="sldImg"/>
+          </p:nvPr>
+        </p:nvSpPr>
+        <p:spPr/>
+        <p:txBody>
+          <a:bodyPr/>
+          <a:lstStyle/>
+          <a:p>
+            <a:endParaRPr lang="en-US"/>
+          </a:p>
+        </p:txBody>
+      </p:sp>
+      <p:sp>
+        <p:nvSpPr>
+          <p:cNvPr id="3" name="Notes Placeholder 2"/>
+          <p:cNvSpPr>
+            <a:spLocks noGrp="1"/>
+          </p:cNvSpPr>
+          <p:nvPr>
+            <p:ph type="body" idx="1"/>
+          </p:nvPr>
+        </p:nvSpPr>
+        <p:spPr/>
+        <p:txBody>
+          <a:bodyPr/>
+          <a:lstStyle/>
+          <a:p>
+            <a:endParaRPr lang="en-US" dirty="0"/>
+          </a:p>
+        </p:txBody>
+      </p:sp>
+      <p:sp>
+        <p:nvSpPr>
+          <p:cNvPr id="4" name="Slide Number Placeholder 3"/>
+          <p:cNvSpPr>
+            <a:spLocks noGrp="1"/>
+          </p:cNvSpPr>
+          <p:nvPr>
+            <p:ph type="sldNum" sz="quarter" idx="10"/>
+          </p:nvPr>
+        </p:nvSpPr>
+        <p:spPr/>
+        <p:txBody>
+          <a:bodyPr/>
+          <a:lstStyle/>
+          <a:p>
+            <a:fld id="{F7021451-1387-4CA6-816F-3879F97B5CBC}" type="slidenum">
+              <a:rPr lang="en-US"/>
+              <a:t>16</a:t>
+            </a:fld>
+            <a:endParaRPr lang="en-US"/>
+          </a:p>
+        </p:txBody>
+      </p:sp>
+    </p:spTree>
+    <p:extLst>
+      <p:ext uri="{BB962C8B-B14F-4D97-AF65-F5344CB8AC3E}">
+        <p14:creationId xmlns:p14="http://schemas.microsoft.com/office/powerpoint/2010/main" val="1024086991"/>
+      </p:ext>
+    </p:extLst>
+  </p:cSld>
+  <p:clrMapOvr>
+    <a:masterClrMapping/>
+  </p:clrMapOvr>
+</p:notes>
+</file>
+
+<file path=ppt/notesSlides/notesSlide2.xml><?xml version="1.0" encoding="utf-8"?>
+<p:notes xmlns:a="http://schemas.openxmlformats.org/drawingml/2006/main" xmlns:r="http://schemas.openxmlformats.org/officeDocument/2006/relationships" xmlns:p="http://schemas.openxmlformats.org/presentationml/2006/main">
+  <p:cSld>
+    <p:spTree>
+      <p:nvGrpSpPr>
+        <p:cNvPr id="1" name=""/>
+        <p:cNvGrpSpPr/>
+        <p:nvPr/>
+      </p:nvGrpSpPr>
+      <p:grpSpPr>
+        <a:xfrm>
+          <a:off x="0" y="0"/>
+          <a:ext cx="0" cy="0"/>
+          <a:chOff x="0" y="0"/>
+          <a:chExt cx="0" cy="0"/>
+        </a:xfrm>
+      </p:grpSpPr>
+      <p:sp>
+        <p:nvSpPr>
+          <p:cNvPr id="2" name="Slide Image Placeholder 1"/>
+          <p:cNvSpPr>
+            <a:spLocks noGrp="1" noRot="1" noChangeAspect="1"/>
+          </p:cNvSpPr>
+          <p:nvPr>
+            <p:ph type="sldImg"/>
+          </p:nvPr>
+        </p:nvSpPr>
+        <p:spPr/>
+        <p:txBody>
+          <a:bodyPr/>
+          <a:lstStyle/>
+          <a:p>
+            <a:endParaRPr lang="en-US"/>
+          </a:p>
+        </p:txBody>
+      </p:sp>
+      <p:sp>
+        <p:nvSpPr>
+          <p:cNvPr id="3" name="Notes Placeholder 2"/>
+          <p:cNvSpPr>
+            <a:spLocks noGrp="1"/>
+          </p:cNvSpPr>
+          <p:nvPr>
+            <p:ph type="body" idx="1"/>
+          </p:nvPr>
+        </p:nvSpPr>
+        <p:spPr/>
+        <p:txBody>
+          <a:bodyPr/>
+          <a:lstStyle/>
+          <a:p>
+            <a:endParaRPr lang="en-US" dirty="0"/>
+          </a:p>
+        </p:txBody>
+      </p:sp>
+      <p:sp>
+        <p:nvSpPr>
+          <p:cNvPr id="4" name="Slide Number Placeholder 3"/>
+          <p:cNvSpPr>
+            <a:spLocks noGrp="1"/>
+          </p:cNvSpPr>
+          <p:nvPr>
+            <p:ph type="sldNum" sz="quarter" idx="10"/>
+          </p:nvPr>
+        </p:nvSpPr>
+        <p:spPr/>
+        <p:txBody>
+          <a:bodyPr/>
+          <a:lstStyle/>
+          <a:p>
+            <a:fld id="{F7021451-1387-4CA6-816F-3879F97B5CBC}" type="slidenum">
+              <a:rPr lang="en-US"/>
+              <a:t>2</a:t>
+            </a:fld>
+            <a:endParaRPr lang="en-US"/>
+          </a:p>
+        </p:txBody>
+      </p:sp>
+    </p:spTree>
+    <p:extLst>
+      <p:ext uri="{BB962C8B-B14F-4D97-AF65-F5344CB8AC3E}">
+        <p14:creationId xmlns:p14="http://schemas.microsoft.com/office/powerpoint/2010/main" val="1024086991"/>
+      </p:ext>
+    </p:extLst>
+  </p:cSld>
+  <p:clrMapOvr>
+    <a:masterClrMapping/>
+  </p:clrMapOvr>
+</p:notes>
+</file>
+
+<file path=ppt/notesSlides/notesSlide3.xml><?xml version="1.0" encoding="utf-8"?>
+<p:notes xmlns:a="http://schemas.openxmlformats.org/drawingml/2006/main" xmlns:r="http://schemas.openxmlformats.org/officeDocument/2006/relationships" xmlns:p="http://schemas.openxmlformats.org/presentationml/2006/main">
+  <p:cSld>
+    <p:spTree>
+      <p:nvGrpSpPr>
+        <p:cNvPr id="1" name=""/>
+        <p:cNvGrpSpPr/>
+        <p:nvPr/>
+      </p:nvGrpSpPr>
+      <p:grpSpPr>
+        <a:xfrm>
+          <a:off x="0" y="0"/>
+          <a:ext cx="0" cy="0"/>
+          <a:chOff x="0" y="0"/>
+          <a:chExt cx="0" cy="0"/>
+        </a:xfrm>
+      </p:grpSpPr>
+      <p:sp>
+        <p:nvSpPr>
+          <p:cNvPr id="2" name="Slide Image Placeholder 1"/>
+          <p:cNvSpPr>
+            <a:spLocks noGrp="1" noRot="1" noChangeAspect="1"/>
+          </p:cNvSpPr>
+          <p:nvPr>
+            <p:ph type="sldImg"/>
+          </p:nvPr>
+        </p:nvSpPr>
+        <p:spPr/>
+        <p:txBody>
+          <a:bodyPr/>
+          <a:lstStyle/>
+          <a:p>
+            <a:endParaRPr lang="en-US"/>
+          </a:p>
+        </p:txBody>
+      </p:sp>
+      <p:sp>
+        <p:nvSpPr>
+          <p:cNvPr id="3" name="Notes Placeholder 2"/>
+          <p:cNvSpPr>
+            <a:spLocks noGrp="1"/>
+          </p:cNvSpPr>
+          <p:nvPr>
+            <p:ph type="body" idx="1"/>
+          </p:nvPr>
+        </p:nvSpPr>
+        <p:spPr/>
+        <p:txBody>
+          <a:bodyPr/>
+          <a:lstStyle/>
+          <a:p>
+            <a:endParaRPr lang="en-US" dirty="0"/>
+          </a:p>
+        </p:txBody>
+      </p:sp>
+      <p:sp>
+        <p:nvSpPr>
+          <p:cNvPr id="4" name="Slide Number Placeholder 3"/>
+          <p:cNvSpPr>
+            <a:spLocks noGrp="1"/>
+          </p:cNvSpPr>
+          <p:nvPr>
+            <p:ph type="sldNum" sz="quarter" idx="10"/>
+          </p:nvPr>
+        </p:nvSpPr>
+        <p:spPr/>
+        <p:txBody>
+          <a:bodyPr/>
+          <a:lstStyle/>
+          <a:p>
+            <a:fld id="{F7021451-1387-4CA6-816F-3879F97B5CBC}" type="slidenum">
+              <a:rPr lang="en-US"/>
+              <a:t>3</a:t>
+            </a:fld>
+            <a:endParaRPr lang="en-US"/>
+          </a:p>
+        </p:txBody>
+      </p:sp>
+    </p:spTree>
+    <p:extLst>
+      <p:ext uri="{BB962C8B-B14F-4D97-AF65-F5344CB8AC3E}">
+        <p14:creationId xmlns:p14="http://schemas.microsoft.com/office/powerpoint/2010/main" val="1024086991"/>
+      </p:ext>
+    </p:extLst>
+  </p:cSld>
+  <p:clrMapOvr>
+    <a:masterClrMapping/>
+  </p:clrMapOvr>
+</p:notes>
+</file>
+
+<file path=ppt/notesSlides/notesSlide4.xml><?xml version="1.0" encoding="utf-8"?>
+<p:notes xmlns:a="http://schemas.openxmlformats.org/drawingml/2006/main" xmlns:r="http://schemas.openxmlformats.org/officeDocument/2006/relationships" xmlns:p="http://schemas.openxmlformats.org/presentationml/2006/main">
+  <p:cSld>
+    <p:spTree>
+      <p:nvGrpSpPr>
+        <p:cNvPr id="1" name=""/>
+        <p:cNvGrpSpPr/>
+        <p:nvPr/>
+      </p:nvGrpSpPr>
+      <p:grpSpPr>
+        <a:xfrm>
+          <a:off x="0" y="0"/>
+          <a:ext cx="0" cy="0"/>
+          <a:chOff x="0" y="0"/>
+          <a:chExt cx="0" cy="0"/>
+        </a:xfrm>
+      </p:grpSpPr>
+      <p:sp>
+        <p:nvSpPr>
+          <p:cNvPr id="2" name="Slide Image Placeholder 1"/>
+          <p:cNvSpPr>
+            <a:spLocks noGrp="1" noRot="1" noChangeAspect="1"/>
+          </p:cNvSpPr>
+          <p:nvPr>
+            <p:ph type="sldImg"/>
+          </p:nvPr>
+        </p:nvSpPr>
+        <p:spPr/>
+        <p:txBody>
+          <a:bodyPr/>
+          <a:lstStyle/>
+          <a:p>
+            <a:endParaRPr lang="en-US"/>
+          </a:p>
+        </p:txBody>
+      </p:sp>
+      <p:sp>
+        <p:nvSpPr>
+          <p:cNvPr id="3" name="Notes Placeholder 2"/>
+          <p:cNvSpPr>
+            <a:spLocks noGrp="1"/>
+          </p:cNvSpPr>
+          <p:nvPr>
+            <p:ph type="body" idx="1"/>
+          </p:nvPr>
+        </p:nvSpPr>
+        <p:spPr/>
+        <p:txBody>
+          <a:bodyPr/>
+          <a:lstStyle/>
+          <a:p>
+            <a:endParaRPr lang="en-US" dirty="0"/>
+          </a:p>
+        </p:txBody>
+      </p:sp>
+      <p:sp>
+        <p:nvSpPr>
+          <p:cNvPr id="4" name="Slide Number Placeholder 3"/>
+          <p:cNvSpPr>
+            <a:spLocks noGrp="1"/>
+          </p:cNvSpPr>
+          <p:nvPr>
+            <p:ph type="sldNum" sz="quarter" idx="10"/>
+          </p:nvPr>
+        </p:nvSpPr>
+        <p:spPr/>
+        <p:txBody>
+          <a:bodyPr/>
+          <a:lstStyle/>
+          <a:p>
+            <a:fld id="{F7021451-1387-4CA6-816F-3879F97B5CBC}" type="slidenum">
+              <a:rPr lang="en-US"/>
+              <a:t>4</a:t>
+            </a:fld>
+            <a:endParaRPr lang="en-US"/>
+          </a:p>
+        </p:txBody>
+      </p:sp>
+    </p:spTree>
+    <p:extLst>
+      <p:ext uri="{BB962C8B-B14F-4D97-AF65-F5344CB8AC3E}">
+        <p14:creationId xmlns:p14="http://schemas.microsoft.com/office/powerpoint/2010/main" val="1024086991"/>
+      </p:ext>
+    </p:extLst>
+  </p:cSld>
+  <p:clrMapOvr>
+    <a:masterClrMapping/>
+  </p:clrMapOvr>
+</p:notes>
+</file>
+
+<file path=ppt/notesSlides/notesSlide5.xml><?xml version="1.0" encoding="utf-8"?>
+<p:notes xmlns:a="http://schemas.openxmlformats.org/drawingml/2006/main" xmlns:r="http://schemas.openxmlformats.org/officeDocument/2006/relationships" xmlns:p="http://schemas.openxmlformats.org/presentationml/2006/main">
+  <p:cSld>
+    <p:spTree>
+      <p:nvGrpSpPr>
+        <p:cNvPr id="1" name=""/>
+        <p:cNvGrpSpPr/>
+        <p:nvPr/>
+      </p:nvGrpSpPr>
+      <p:grpSpPr>
+        <a:xfrm>
+          <a:off x="0" y="0"/>
+          <a:ext cx="0" cy="0"/>
+          <a:chOff x="0" y="0"/>
+          <a:chExt cx="0" cy="0"/>
+        </a:xfrm>
+      </p:grpSpPr>
+      <p:sp>
+        <p:nvSpPr>
+          <p:cNvPr id="2" name="Slide Image Placeholder 1"/>
+          <p:cNvSpPr>
+            <a:spLocks noGrp="1" noRot="1" noChangeAspect="1"/>
+          </p:cNvSpPr>
+          <p:nvPr>
+            <p:ph type="sldImg"/>
+          </p:nvPr>
+        </p:nvSpPr>
+        <p:spPr/>
+        <p:txBody>
+          <a:bodyPr/>
+          <a:lstStyle/>
+          <a:p>
+            <a:endParaRPr lang="en-US"/>
+          </a:p>
+        </p:txBody>
+      </p:sp>
+      <p:sp>
+        <p:nvSpPr>
+          <p:cNvPr id="3" name="Notes Placeholder 2"/>
+          <p:cNvSpPr>
+            <a:spLocks noGrp="1"/>
+          </p:cNvSpPr>
+          <p:nvPr>
+            <p:ph type="body" idx="1"/>
+          </p:nvPr>
+        </p:nvSpPr>
+        <p:spPr/>
+        <p:txBody>
+          <a:bodyPr/>
+          <a:lstStyle/>
+          <a:p>
+            <a:endParaRPr lang="en-US" dirty="0"/>
+          </a:p>
+        </p:txBody>
+      </p:sp>
+      <p:sp>
+        <p:nvSpPr>
+          <p:cNvPr id="4" name="Slide Number Placeholder 3"/>
+          <p:cNvSpPr>
+            <a:spLocks noGrp="1"/>
+          </p:cNvSpPr>
+          <p:nvPr>
+            <p:ph type="sldNum" sz="quarter" idx="10"/>
+          </p:nvPr>
+        </p:nvSpPr>
+        <p:spPr/>
+        <p:txBody>
+          <a:bodyPr/>
+          <a:lstStyle/>
+          <a:p>
+            <a:fld id="{F7021451-1387-4CA6-816F-3879F97B5CBC}" type="slidenum">
+              <a:rPr lang="en-US"/>
+              <a:t>5</a:t>
+            </a:fld>
+            <a:endParaRPr lang="en-US"/>
+          </a:p>
+        </p:txBody>
+      </p:sp>
+    </p:spTree>
+    <p:extLst>
+      <p:ext uri="{BB962C8B-B14F-4D97-AF65-F5344CB8AC3E}">
+        <p14:creationId xmlns:p14="http://schemas.microsoft.com/office/powerpoint/2010/main" val="1024086991"/>
+      </p:ext>
+    </p:extLst>
+  </p:cSld>
+  <p:clrMapOvr>
+    <a:masterClrMapping/>
+  </p:clrMapOvr>
+</p:notes>
+</file>
+
+<file path=ppt/notesSlides/notesSlide6.xml><?xml version="1.0" encoding="utf-8"?>
+<p:notes xmlns:a="http://schemas.openxmlformats.org/drawingml/2006/main" xmlns:r="http://schemas.openxmlformats.org/officeDocument/2006/relationships" xmlns:p="http://schemas.openxmlformats.org/presentationml/2006/main">
+  <p:cSld>
+    <p:spTree>
+      <p:nvGrpSpPr>
+        <p:cNvPr id="1" name=""/>
+        <p:cNvGrpSpPr/>
+        <p:nvPr/>
+      </p:nvGrpSpPr>
+      <p:grpSpPr>
+        <a:xfrm>
+          <a:off x="0" y="0"/>
+          <a:ext cx="0" cy="0"/>
+          <a:chOff x="0" y="0"/>
+          <a:chExt cx="0" cy="0"/>
+        </a:xfrm>
+      </p:grpSpPr>
+      <p:sp>
+        <p:nvSpPr>
+          <p:cNvPr id="2" name="Slide Image Placeholder 1"/>
+          <p:cNvSpPr>
+            <a:spLocks noGrp="1" noRot="1" noChangeAspect="1"/>
+          </p:cNvSpPr>
+          <p:nvPr>
+            <p:ph type="sldImg"/>
+          </p:nvPr>
+        </p:nvSpPr>
+        <p:spPr/>
+        <p:txBody>
+          <a:bodyPr/>
+          <a:lstStyle/>
+          <a:p>
+            <a:endParaRPr lang="en-US"/>
+          </a:p>
+        </p:txBody>
+      </p:sp>
+      <p:sp>
+        <p:nvSpPr>
+          <p:cNvPr id="3" name="Notes Placeholder 2"/>
+          <p:cNvSpPr>
+            <a:spLocks noGrp="1"/>
+          </p:cNvSpPr>
+          <p:nvPr>
+            <p:ph type="body" idx="1"/>
+          </p:nvPr>
+        </p:nvSpPr>
+        <p:spPr/>
+        <p:txBody>
+          <a:bodyPr/>
+          <a:lstStyle/>
+          <a:p>
+            <a:endParaRPr lang="en-US" dirty="0"/>
+          </a:p>
+        </p:txBody>
+      </p:sp>
+      <p:sp>
+        <p:nvSpPr>
+          <p:cNvPr id="4" name="Slide Number Placeholder 3"/>
+          <p:cNvSpPr>
+            <a:spLocks noGrp="1"/>
+          </p:cNvSpPr>
+          <p:nvPr>
+            <p:ph type="sldNum" sz="quarter" idx="10"/>
+          </p:nvPr>
+        </p:nvSpPr>
+        <p:spPr/>
+        <p:txBody>
+          <a:bodyPr/>
+          <a:lstStyle/>
+          <a:p>
+            <a:fld id="{F7021451-1387-4CA6-816F-3879F97B5CBC}" type="slidenum">
+              <a:rPr lang="en-US"/>
+              <a:t>6</a:t>
+            </a:fld>
+            <a:endParaRPr lang="en-US"/>
+          </a:p>
+        </p:txBody>
+      </p:sp>
+    </p:spTree>
+    <p:extLst>
+      <p:ext uri="{BB962C8B-B14F-4D97-AF65-F5344CB8AC3E}">
+        <p14:creationId xmlns:p14="http://schemas.microsoft.com/office/powerpoint/2010/main" val="1024086991"/>
+      </p:ext>
+    </p:extLst>
+  </p:cSld>
+  <p:clrMapOvr>
+    <a:masterClrMapping/>
+  </p:clrMapOvr>
+</p:notes>
+</file>
+
+<file path=ppt/notesSlides/notesSlide7.xml><?xml version="1.0" encoding="utf-8"?>
+<p:notes xmlns:a="http://schemas.openxmlformats.org/drawingml/2006/main" xmlns:r="http://schemas.openxmlformats.org/officeDocument/2006/relationships" xmlns:p="http://schemas.openxmlformats.org/presentationml/2006/main">
+  <p:cSld>
+    <p:spTree>
+      <p:nvGrpSpPr>
+        <p:cNvPr id="1" name=""/>
+        <p:cNvGrpSpPr/>
+        <p:nvPr/>
+      </p:nvGrpSpPr>
+      <p:grpSpPr>
+        <a:xfrm>
+          <a:off x="0" y="0"/>
+          <a:ext cx="0" cy="0"/>
+          <a:chOff x="0" y="0"/>
+          <a:chExt cx="0" cy="0"/>
+        </a:xfrm>
+      </p:grpSpPr>
+      <p:sp>
+        <p:nvSpPr>
+          <p:cNvPr id="2" name="Slide Image Placeholder 1"/>
+          <p:cNvSpPr>
+            <a:spLocks noGrp="1" noRot="1" noChangeAspect="1"/>
+          </p:cNvSpPr>
+          <p:nvPr>
+            <p:ph type="sldImg"/>
+          </p:nvPr>
+        </p:nvSpPr>
+        <p:spPr/>
+        <p:txBody>
+          <a:bodyPr/>
+          <a:lstStyle/>
+          <a:p>
+            <a:endParaRPr lang="en-US"/>
+          </a:p>
+        </p:txBody>
+      </p:sp>
+      <p:sp>
+        <p:nvSpPr>
+          <p:cNvPr id="3" name="Notes Placeholder 2"/>
+          <p:cNvSpPr>
+            <a:spLocks noGrp="1"/>
+          </p:cNvSpPr>
+          <p:nvPr>
+            <p:ph type="body" idx="1"/>
+          </p:nvPr>
+        </p:nvSpPr>
+        <p:spPr/>
+        <p:txBody>
+          <a:bodyPr/>
+          <a:lstStyle/>
+          <a:p>
+            <a:endParaRPr lang="en-US" dirty="0"/>
+          </a:p>
+        </p:txBody>
+      </p:sp>
+      <p:sp>
+        <p:nvSpPr>
+          <p:cNvPr id="4" name="Slide Number Placeholder 3"/>
+          <p:cNvSpPr>
+            <a:spLocks noGrp="1"/>
+          </p:cNvSpPr>
+          <p:nvPr>
+            <p:ph type="sldNum" sz="quarter" idx="10"/>
+          </p:nvPr>
+        </p:nvSpPr>
+        <p:spPr/>
+        <p:txBody>
+          <a:bodyPr/>
+          <a:lstStyle/>
+          <a:p>
+            <a:fld id="{F7021451-1387-4CA6-816F-3879F97B5CBC}" type="slidenum">
+              <a:rPr lang="en-US"/>
+              <a:t>7</a:t>
+            </a:fld>
+            <a:endParaRPr lang="en-US"/>
+          </a:p>
+        </p:txBody>
+      </p:sp>
+    </p:spTree>
+    <p:extLst>
+      <p:ext uri="{BB962C8B-B14F-4D97-AF65-F5344CB8AC3E}">
+        <p14:creationId xmlns:p14="http://schemas.microsoft.com/office/powerpoint/2010/main" val="1024086991"/>
+      </p:ext>
+    </p:extLst>
+  </p:cSld>
+  <p:clrMapOvr>
+    <a:masterClrMapping/>
+  </p:clrMapOvr>
+</p:notes>
+</file>
+
+<file path=ppt/notesSlides/notesSlide8.xml><?xml version="1.0" encoding="utf-8"?>
+<p:notes xmlns:a="http://schemas.openxmlformats.org/drawingml/2006/main" xmlns:r="http://schemas.openxmlformats.org/officeDocument/2006/relationships" xmlns:p="http://schemas.openxmlformats.org/presentationml/2006/main">
+  <p:cSld>
+    <p:spTree>
+      <p:nvGrpSpPr>
+        <p:cNvPr id="1" name=""/>
+        <p:cNvGrpSpPr/>
+        <p:nvPr/>
+      </p:nvGrpSpPr>
+      <p:grpSpPr>
+        <a:xfrm>
+          <a:off x="0" y="0"/>
+          <a:ext cx="0" cy="0"/>
+          <a:chOff x="0" y="0"/>
+          <a:chExt cx="0" cy="0"/>
+        </a:xfrm>
+      </p:grpSpPr>
+      <p:sp>
+        <p:nvSpPr>
+          <p:cNvPr id="2" name="Slide Image Placeholder 1"/>
+          <p:cNvSpPr>
+            <a:spLocks noGrp="1" noRot="1" noChangeAspect="1"/>
+          </p:cNvSpPr>
+          <p:nvPr>
+            <p:ph type="sldImg"/>
+          </p:nvPr>
+        </p:nvSpPr>
+        <p:spPr/>
+        <p:txBody>
+          <a:bodyPr/>
+          <a:lstStyle/>
+          <a:p>
+            <a:endParaRPr lang="en-US"/>
+          </a:p>
+        </p:txBody>
+      </p:sp>
+      <p:sp>
+        <p:nvSpPr>
+          <p:cNvPr id="3" name="Notes Placeholder 2"/>
+          <p:cNvSpPr>
+            <a:spLocks noGrp="1"/>
+          </p:cNvSpPr>
+          <p:nvPr>
+            <p:ph type="body" idx="1"/>
+          </p:nvPr>
+        </p:nvSpPr>
+        <p:spPr/>
+        <p:txBody>
+          <a:bodyPr/>
+          <a:lstStyle/>
+          <a:p>
+            <a:endParaRPr lang="en-US" dirty="0"/>
+          </a:p>
+        </p:txBody>
+      </p:sp>
+      <p:sp>
+        <p:nvSpPr>
+          <p:cNvPr id="4" name="Slide Number Placeholder 3"/>
+          <p:cNvSpPr>
+            <a:spLocks noGrp="1"/>
+          </p:cNvSpPr>
+          <p:nvPr>
+            <p:ph type="sldNum" sz="quarter" idx="10"/>
+          </p:nvPr>
+        </p:nvSpPr>
+        <p:spPr/>
+        <p:txBody>
+          <a:bodyPr/>
+          <a:lstStyle/>
+          <a:p>
+            <a:fld id="{F7021451-1387-4CA6-816F-3879F97B5CBC}" type="slidenum">
+              <a:rPr lang="en-US"/>
+              <a:t>8</a:t>
+            </a:fld>
+            <a:endParaRPr lang="en-US"/>
+          </a:p>
+        </p:txBody>
+      </p:sp>
+    </p:spTree>
+    <p:extLst>
+      <p:ext uri="{BB962C8B-B14F-4D97-AF65-F5344CB8AC3E}">
+        <p14:creationId xmlns:p14="http://schemas.microsoft.com/office/powerpoint/2010/main" val="1024086991"/>
+      </p:ext>
+    </p:extLst>
+  </p:cSld>
+  <p:clrMapOvr>
+    <a:masterClrMapping/>
+  </p:clrMapOvr>
+</p:notes>
+</file>
+
+<file path=ppt/notesSlides/notesSlide9.xml><?xml version="1.0" encoding="utf-8"?>
+<p:notes xmlns:a="http://schemas.openxmlformats.org/drawingml/2006/main" xmlns:r="http://schemas.openxmlformats.org/officeDocument/2006/relationships" xmlns:p="http://schemas.openxmlformats.org/presentationml/2006/main">
+  <p:cSld>
+    <p:spTree>
+      <p:nvGrpSpPr>
+        <p:cNvPr id="1" name=""/>
+        <p:cNvGrpSpPr/>
+        <p:nvPr/>
+      </p:nvGrpSpPr>
+      <p:grpSpPr>
+        <a:xfrm>
+          <a:off x="0" y="0"/>
+          <a:ext cx="0" cy="0"/>
+          <a:chOff x="0" y="0"/>
+          <a:chExt cx="0" cy="0"/>
+        </a:xfrm>
+      </p:grpSpPr>
+      <p:sp>
+        <p:nvSpPr>
+          <p:cNvPr id="2" name="Slide Image Placeholder 1"/>
+          <p:cNvSpPr>
+            <a:spLocks noGrp="1" noRot="1" noChangeAspect="1"/>
+          </p:cNvSpPr>
+          <p:nvPr>
+            <p:ph type="sldImg"/>
+          </p:nvPr>
+        </p:nvSpPr>
+        <p:spPr/>
+        <p:txBody>
+          <a:bodyPr/>
+          <a:lstStyle/>
+          <a:p>
+            <a:endParaRPr lang="en-US"/>
+          </a:p>
+        </p:txBody>
+      </p:sp>
+      <p:sp>
+        <p:nvSpPr>
+          <p:cNvPr id="3" name="Notes Placeholder 2"/>
+          <p:cNvSpPr>
+            <a:spLocks noGrp="1"/>
+          </p:cNvSpPr>
+          <p:nvPr>
+            <p:ph type="body" idx="1"/>
+          </p:nvPr>
+        </p:nvSpPr>
+        <p:spPr/>
+        <p:txBody>
+          <a:bodyPr/>
+          <a:lstStyle/>
+          <a:p>
+            <a:endParaRPr lang="en-US" dirty="0"/>
+          </a:p>
+        </p:txBody>
+      </p:sp>
+      <p:sp>
+        <p:nvSpPr>
+          <p:cNvPr id="4" name="Slide Number Placeholder 3"/>
+          <p:cNvSpPr>
+            <a:spLocks noGrp="1"/>
+          </p:cNvSpPr>
+          <p:nvPr>
+            <p:ph type="sldNum" sz="quarter" idx="10"/>
+          </p:nvPr>
+        </p:nvSpPr>
+        <p:spPr/>
+        <p:txBody>
+          <a:bodyPr/>
+          <a:lstStyle/>
+          <a:p>
+            <a:fld id="{F7021451-1387-4CA6-816F-3879F97B5CBC}" type="slidenum">
+              <a:rPr lang="en-US"/>
+              <a:t>9</a:t>
+            </a:fld>
+            <a:endParaRPr lang="en-US"/>
+          </a:p>
+        </p:txBody>
+      </p:sp>
+    </p:spTree>
+    <p:extLst>
+      <p:ext uri="{BB962C8B-B14F-4D97-AF65-F5344CB8AC3E}">
+        <p14:creationId xmlns:p14="http://schemas.microsoft.com/office/powerpoint/2010/main" val="1024086991"/>
+      </p:ext>
+    </p:extLst>
+  </p:cSld>
+  <p:clrMapOvr>
+    <a:masterClrMapping/>
+  </p:clrMapOvr>
+</p:notes>
+</file>
+
+<file path=ppt/slideLayouts/slideLayout1.xml><?xml version="1.0" encoding="utf-8"?>
 <p:sldLayout xmlns:a="http://schemas.openxmlformats.org/drawingml/2006/main" xmlns:r="http://schemas.openxmlformats.org/officeDocument/2006/relationships" xmlns:p="http://schemas.openxmlformats.org/presentationml/2006/main" preserve="1">
   <p:cSld name="DEFAULT">
     <p:bg>
@@ -1720,7 +1738,7 @@
 </p:sldLayout>
 </file>
 
-<file path=ppt\slideMasters\slideMaster1.xml><?xml version="1.0" encoding="utf-8"?>
+<file path=ppt/slideMasters/slideMaster1.xml><?xml version="1.0" encoding="utf-8"?>
 <p:sldMaster xmlns:a="http://schemas.openxmlformats.org/drawingml/2006/main" xmlns:r="http://schemas.openxmlformats.org/officeDocument/2006/relationships" xmlns:p="http://schemas.openxmlformats.org/presentationml/2006/main">
   <p:cSld>
     <p:bg>
@@ -2002,7 +2020,7 @@
 </p:sldMaster>
 </file>
 
-<file path=ppt\slides\slide1.xml><?xml version="1.0" encoding="utf-8"?>
+<file path=ppt/slides/slide1.xml><?xml version="1.0" encoding="utf-8"?>
 <p:sld xmlns:a="http://schemas.openxmlformats.org/drawingml/2006/main" xmlns:r="http://schemas.openxmlformats.org/officeDocument/2006/relationships" xmlns:p="http://schemas.openxmlformats.org/presentationml/2006/main">
   <p:cSld name="Slide 1">
     <p:bg>
@@ -2475,7 +2493,7 @@
 </p:sld>
 </file>
 
-<file path=ppt\slides\slide10.xml><?xml version="1.0" encoding="utf-8"?>
+<file path=ppt/slides/slide10.xml><?xml version="1.0" encoding="utf-8"?>
 <p:sld xmlns:a="http://schemas.openxmlformats.org/drawingml/2006/main" xmlns:r="http://schemas.openxmlformats.org/officeDocument/2006/relationships" xmlns:p="http://schemas.openxmlformats.org/presentationml/2006/main">
   <p:cSld name="Slide 10">
     <p:bg>
@@ -3393,7 +3411,7 @@
 </p:sld>
 </file>
 
-<file path=ppt\slides\slide11.xml><?xml version="1.0" encoding="utf-8"?>
+<file path=ppt/slides/slide11.xml><?xml version="1.0" encoding="utf-8"?>
 <p:sld xmlns:a="http://schemas.openxmlformats.org/drawingml/2006/main" xmlns:r="http://schemas.openxmlformats.org/officeDocument/2006/relationships" xmlns:p="http://schemas.openxmlformats.org/presentationml/2006/main">
   <p:cSld name="Slide 11">
     <p:bg>
@@ -4989,7 +5007,7 @@
 </p:sld>
 </file>
 
-<file path=ppt\slides\slide12.xml><?xml version="1.0" encoding="utf-8"?>
+<file path=ppt/slides/slide12.xml><?xml version="1.0" encoding="utf-8"?>
 <p:sld xmlns:a="http://schemas.openxmlformats.org/drawingml/2006/main" xmlns:r="http://schemas.openxmlformats.org/officeDocument/2006/relationships" xmlns:p="http://schemas.openxmlformats.org/presentationml/2006/main">
   <p:cSld name="Slide 12">
     <p:bg>
@@ -5966,7 +5984,7 @@
 </p:sld>
 </file>
 
-<file path=ppt\slides\slide13.xml><?xml version="1.0" encoding="utf-8"?>
+<file path=ppt/slides/slide13.xml><?xml version="1.0" encoding="utf-8"?>
 <p:sld xmlns:a="http://schemas.openxmlformats.org/drawingml/2006/main" xmlns:r="http://schemas.openxmlformats.org/officeDocument/2006/relationships" xmlns:p="http://schemas.openxmlformats.org/presentationml/2006/main">
   <p:cSld name="Slide 13">
     <p:bg>
@@ -6906,7 +6924,7 @@
 </p:sld>
 </file>
 
-<file path=ppt\slides\slide14.xml><?xml version="1.0" encoding="utf-8"?>
+<file path=ppt/slides/slide14.xml><?xml version="1.0" encoding="utf-8"?>
 <p:sld xmlns:a="http://schemas.openxmlformats.org/drawingml/2006/main" xmlns:r="http://schemas.openxmlformats.org/officeDocument/2006/relationships" xmlns:p="http://schemas.openxmlformats.org/presentationml/2006/main">
   <p:cSld name="Slide 14">
     <p:bg>
@@ -7794,7 +7812,7 @@
 </p:sld>
 </file>
 
-<file path=ppt\slides\slide15.xml><?xml version="1.0" encoding="utf-8"?>
+<file path=ppt/slides/slide15.xml><?xml version="1.0" encoding="utf-8"?>
 <p:sld xmlns:a="http://schemas.openxmlformats.org/drawingml/2006/main" xmlns:r="http://schemas.openxmlformats.org/officeDocument/2006/relationships" xmlns:p="http://schemas.openxmlformats.org/presentationml/2006/main">
   <p:cSld name="Slide 15">
     <p:bg>
@@ -8709,7 +8727,7 @@
                 <a:ea typeface="Consolas" pitchFamily="34" charset="-122"/>
                 <a:cs typeface="Consolas" pitchFamily="34" charset="-120"/>
               </a:rPr>
-              <a:t>FileAgentSkillsProvider</a:t>
+              <a:t>AgentSkillsProvider</a:t>
             </a:r>
             <a:endParaRPr lang="en-US" sz="950" dirty="0"/>
           </a:p>
@@ -9605,7 +9623,7 @@
 </p:sld>
 </file>
 
-<file path=ppt\slides\slide16.xml><?xml version="1.0" encoding="utf-8"?>
+<file path=ppt/slides/slide16.xml><?xml version="1.0" encoding="utf-8"?>
 <p:sld xmlns:a="http://schemas.openxmlformats.org/drawingml/2006/main" xmlns:r="http://schemas.openxmlformats.org/officeDocument/2006/relationships" xmlns:p="http://schemas.openxmlformats.org/presentationml/2006/main">
   <p:cSld name="Slide 16">
     <p:bg>
@@ -10007,7 +10025,7 @@
 </p:sld>
 </file>
 
-<file path=ppt\slides\slide2.xml><?xml version="1.0" encoding="utf-8"?>
+<file path=ppt/slides/slide2.xml><?xml version="1.0" encoding="utf-8"?>
 <p:sld xmlns:a="http://schemas.openxmlformats.org/drawingml/2006/main" xmlns:r="http://schemas.openxmlformats.org/officeDocument/2006/relationships" xmlns:p="http://schemas.openxmlformats.org/presentationml/2006/main">
   <p:cSld name="Slide 2">
     <p:bg>
@@ -10207,7 +10225,7 @@
                 <a:ea typeface="Calibri" pitchFamily="34" charset="-122"/>
                 <a:cs typeface="Calibri" pitchFamily="34" charset="-120"/>
               </a:rPr>
-              <a:t>This is not a chatbot walkthrough — it is a MAF architecture story shown through a real Azure support application.</a:t>
+              <a:t>This is not a chatbot walkthrough – it is a MAF architecture story shown through a real Azure support application.</a:t>
             </a:r>
             <a:endParaRPr lang="en-US" sz="1350" dirty="0"/>
           </a:p>
@@ -10629,7 +10647,7 @@
                 <a:ea typeface="Calibri" pitchFamily="34" charset="-122"/>
                 <a:cs typeface="Calibri" pitchFamily="34" charset="-120"/>
               </a:rPr>
-              <a:t>Then we'll pull back the curtain and explain the MAF, MCP, AG-UI, and observability pieces that made it possible.</a:t>
+              <a:t>Then we'll pull back the curtain and show how the demo now runs on the official .NET MAF v1 core package line.</a:t>
             </a:r>
             <a:endParaRPr lang="en-US" sz="1400" dirty="0"/>
           </a:p>
@@ -10643,7 +10661,7 @@
 </p:sld>
 </file>
 
-<file path=ppt\slides\slide3.xml><?xml version="1.0" encoding="utf-8"?>
+<file path=ppt/slides/slide3.xml><?xml version="1.0" encoding="utf-8"?>
 <p:sld xmlns:a="http://schemas.openxmlformats.org/drawingml/2006/main" xmlns:r="http://schemas.openxmlformats.org/officeDocument/2006/relationships" xmlns:p="http://schemas.openxmlformats.org/presentationml/2006/main">
   <p:cSld name="Slide 3">
     <p:bg>
@@ -11166,7 +11184,7 @@
                 <a:ea typeface="Calibri" pitchFamily="34" charset="-122"/>
                 <a:cs typeface="Calibri" pitchFamily="34" charset="-120"/>
               </a:rPr>
-              <a:t>Prescribes how agents, routing, memory, and telemetry wire together. Convention over configuration â€“ most things work without ceremony.</a:t>
+              <a:t>Prescribes how agents, routing, memory, and telemetry wire together. Convention over configuration – most things work without ceremony.</a:t>
             </a:r>
             <a:endParaRPr lang="en-US" sz="1200" dirty="0"/>
           </a:p>
@@ -11315,7 +11333,7 @@
                 <a:ea typeface="Calibri" pitchFamily="34" charset="-122"/>
                 <a:cs typeface="Calibri" pitchFamily="34" charset="-120"/>
               </a:rPr>
-              <a:t>Azure OpenAI, Document Intelligence, Cosmos, Redis, AI Search, and App Insights are the default backing services â€” all configurable and replaceable.</a:t>
+              <a:t>Azure OpenAI, Document Intelligence, Cosmos, Redis, AI Search, and App Insights are the default backing services – all configurable and replaceable.</a:t>
             </a:r>
             <a:endParaRPr lang="en-US" sz="1200" dirty="0"/>
           </a:p>
@@ -11478,7 +11496,7 @@
 </p:sld>
 </file>
 
-<file path=ppt\slides\slide4.xml><?xml version="1.0" encoding="utf-8"?>
+<file path=ppt/slides/slide4.xml><?xml version="1.0" encoding="utf-8"?>
 <p:sld xmlns:a="http://schemas.openxmlformats.org/drawingml/2006/main" xmlns:r="http://schemas.openxmlformats.org/officeDocument/2006/relationships" xmlns:p="http://schemas.openxmlformats.org/presentationml/2006/main">
   <p:cSld name="Slide 4">
     <p:bg>
@@ -12363,7 +12381,7 @@
 </p:sld>
 </file>
 
-<file path=ppt\slides\slide5.xml><?xml version="1.0" encoding="utf-8"?>
+<file path=ppt/slides/slide5.xml><?xml version="1.0" encoding="utf-8"?>
 <p:sld xmlns:a="http://schemas.openxmlformats.org/drawingml/2006/main" xmlns:r="http://schemas.openxmlformats.org/officeDocument/2006/relationships" xmlns:p="http://schemas.openxmlformats.org/presentationml/2006/main">
   <p:cSld name="Slide 5">
     <p:bg>
@@ -14148,7 +14166,7 @@
 </p:sld>
 </file>
 
-<file path=ppt\slides\slide6.xml><?xml version="1.0" encoding="utf-8"?>
+<file path=ppt/slides/slide6.xml><?xml version="1.0" encoding="utf-8"?>
 <p:sld xmlns:a="http://schemas.openxmlformats.org/drawingml/2006/main" xmlns:r="http://schemas.openxmlformats.org/officeDocument/2006/relationships" xmlns:p="http://schemas.openxmlformats.org/presentationml/2006/main">
   <p:cSld name="Slide 6">
     <p:bg>
@@ -15880,7 +15898,7 @@
 </p:sld>
 </file>
 
-<file path=ppt\slides\slide7.xml><?xml version="1.0" encoding="utf-8"?>
+<file path=ppt/slides/slide7.xml><?xml version="1.0" encoding="utf-8"?>
 <p:sld xmlns:a="http://schemas.openxmlformats.org/drawingml/2006/main" xmlns:r="http://schemas.openxmlformats.org/officeDocument/2006/relationships" xmlns:p="http://schemas.openxmlformats.org/presentationml/2006/main">
   <p:cSld name="Slide 7">
     <p:bg>
@@ -16617,7 +16635,7 @@
                 <a:ea typeface="Calibri" pitchFamily="34" charset="-122"/>
                 <a:cs typeface="Calibri" pitchFamily="34" charset="-120"/>
               </a:rPr>
-              <a:t>MAF gets much more powerful when identity and per-thread scoping are first-class. HelpdeskAI uses one middleware seam so every downstream component sees the same user and thread context.</a:t>
+              <a:t>MAF gets much more powerful when identity and per-thread scoping are first-class. HelpdeskAI uses one middleware seam, so every downstream component sees the same user and thread context.</a:t>
             </a:r>
             <a:endParaRPr lang="en-US" sz="1200" dirty="0"/>
           </a:p>
@@ -16741,7 +16759,7 @@
 </p:sld>
 </file>
 
-<file path=ppt\slides\slide8.xml><?xml version="1.0" encoding="utf-8"?>
+<file path=ppt/slides/slide8.xml><?xml version="1.0" encoding="utf-8"?>
 <p:sld xmlns:a="http://schemas.openxmlformats.org/drawingml/2006/main" xmlns:r="http://schemas.openxmlformats.org/officeDocument/2006/relationships" xmlns:p="http://schemas.openxmlformats.org/presentationml/2006/main">
   <p:cSld name="Slide 8">
     <p:bg>
@@ -17717,7 +17735,7 @@
 </p:sld>
 </file>
 
-<file path=ppt\slides\slide9.xml><?xml version="1.0" encoding="utf-8"?>
+<file path=ppt/slides/slide9.xml><?xml version="1.0" encoding="utf-8"?>
 <p:sld xmlns:a="http://schemas.openxmlformats.org/drawingml/2006/main" xmlns:r="http://schemas.openxmlformats.org/officeDocument/2006/relationships" xmlns:p="http://schemas.openxmlformats.org/presentationml/2006/main">
   <p:cSld name="Slide 9">
     <p:bg>
@@ -18389,11 +18407,7 @@
 </p:sld>
 </file>
 
-<file path=ppt\tableStyles.xml><?xml version="1.0" encoding="utf-8"?>
-<a:tblStyleLst xmlns:a="http://schemas.openxmlformats.org/drawingml/2006/main" def="{5C22544A-7EE6-4342-B048-85BDC9FD1C3A}"/>
-</file>
-
-<file path=ppt\theme\theme1.xml><?xml version="1.0" encoding="utf-8"?>
+<file path=ppt/theme/theme1.xml><?xml version="1.0" encoding="utf-8"?>
 <a:theme xmlns:a="http://schemas.openxmlformats.org/drawingml/2006/main" name="Office Theme">
   <a:themeElements>
     <a:clrScheme name="Office">
@@ -18688,7 +18702,7 @@
 </a:theme>
 </file>
 
-<file path=ppt\theme\theme2.xml><?xml version="1.0" encoding="utf-8"?>
+<file path=ppt/theme/theme2.xml><?xml version="1.0" encoding="utf-8"?>
 <a:theme xmlns:a="http://schemas.openxmlformats.org/drawingml/2006/main" name="Office Theme">
   <a:themeElements>
     <a:clrScheme name="Office">
@@ -19001,35 +19015,4 @@
     </a:ext>
   </a:extLst>
 </a:theme>
-</file>
-
-<file path=ppt\viewProps.xml><?xml version="1.0" encoding="utf-8"?>
-<p:viewPr xmlns:a="http://schemas.openxmlformats.org/drawingml/2006/main" xmlns:r="http://schemas.openxmlformats.org/officeDocument/2006/relationships" xmlns:p="http://schemas.openxmlformats.org/presentationml/2006/main">
-  <p:normalViewPr horzBarState="maximized">
-    <p:restoredLeft sz="15611"/>
-    <p:restoredTop sz="94610"/>
-  </p:normalViewPr>
-  <p:slideViewPr>
-    <p:cSldViewPr snapToGrid="0" snapToObjects="1">
-      <p:cViewPr varScale="1">
-        <p:scale>
-          <a:sx n="130" d="100"/>
-          <a:sy n="130" d="100"/>
-        </p:scale>
-        <p:origin x="1074" y="336"/>
-      </p:cViewPr>
-      <p:guideLst/>
-    </p:cSldViewPr>
-  </p:slideViewPr>
-  <p:notesTextViewPr>
-    <p:cViewPr>
-      <p:scale>
-        <a:sx n="1" d="1"/>
-        <a:sy n="1" d="1"/>
-      </p:scale>
-      <p:origin x="0" y="0"/>
-    </p:cViewPr>
-  </p:notesTextViewPr>
-  <p:gridSpacing cx="76200" cy="76200"/>
-</p:viewPr>
 </file>
</xml_diff>

<commit_message>
feat: content safety guard with graceful UX for v1 and v2 routes
- ContentSafetyGuardChatClient: catches Azure content_filter (HTTP 400)
  in both streaming and non-streaming paths; clears Redis history to
  prevent poisoned thread re-triggering; throws ContentSafetyException
  so MAF emits RUN_ERROR with user-facing message
- HelpdeskChat.tsx: onError calls useCopilotChat().reset() + sets
  chatInitial to warning text so bubble appears in correct position
  with clean frontend state; no jailbreak re-sent on next turn
- UsageCapturingChatClient: defensive try/catch around post-stream Redis
  write so transient failures never block RUN_FINISHED dispatch
- Program.cs: ContentSafetyGuardChatClient wired into both v1 and v2
  IChatClient pipelines after UseFunctionInvocation()
- CHANGELOG, AgentHost README, demo-script updated to reflect changes
- PPTX slide 14 colours and content fixed
</commit_message>
<xml_diff>
--- a/conference/HelpdeskAI-Kolkata-2026.pptx
+++ b/conference/HelpdeskAI-Kolkata-2026.pptx
@@ -5,7 +5,7 @@
     <p:sldMasterId id="2147483648" r:id="rId1"/>
   </p:sldMasterIdLst>
   <p:notesMasterIdLst>
-    <p:notesMasterId r:id="rId18"/>
+    <p:notesMasterId r:id="rId19"/>
   </p:notesMasterIdLst>
   <p:sldIdLst>
     <p:sldId id="256" r:id="rId2"/>
@@ -21,9 +21,10 @@
     <p:sldId id="266" r:id="rId12"/>
     <p:sldId id="267" r:id="rId13"/>
     <p:sldId id="268" r:id="rId14"/>
-    <p:sldId id="269" r:id="rId15"/>
-    <p:sldId id="270" r:id="rId16"/>
-    <p:sldId id="271" r:id="rId17"/>
+    <p:sldId id="272" r:id="rId15"/>
+    <p:sldId id="269" r:id="rId16"/>
+    <p:sldId id="270" r:id="rId17"/>
+    <p:sldId id="271" r:id="rId18"/>
   </p:sldIdLst>
   <p:sldSz cx="9144000" cy="5143500" type="screen16x9"/>
   <p:notesSz cx="5143500" cy="9144000"/>
@@ -724,73 +725,7 @@
           <a:chExt cx="0" cy="0"/>
         </a:xfrm>
       </p:grpSpPr>
-      <p:sp>
-        <p:nvSpPr>
-          <p:cNvPr id="2" name="Slide Image Placeholder 1"/>
-          <p:cNvSpPr>
-            <a:spLocks noGrp="1" noRot="1" noChangeAspect="1"/>
-          </p:cNvSpPr>
-          <p:nvPr>
-            <p:ph type="sldImg"/>
-          </p:nvPr>
-        </p:nvSpPr>
-        <p:spPr/>
-        <p:txBody>
-          <a:bodyPr/>
-          <a:lstStyle/>
-          <a:p>
-            <a:endParaRPr lang="en-US"/>
-          </a:p>
-        </p:txBody>
-      </p:sp>
-      <p:sp>
-        <p:nvSpPr>
-          <p:cNvPr id="3" name="Notes Placeholder 2"/>
-          <p:cNvSpPr>
-            <a:spLocks noGrp="1"/>
-          </p:cNvSpPr>
-          <p:nvPr>
-            <p:ph type="body" idx="1"/>
-          </p:nvPr>
-        </p:nvSpPr>
-        <p:spPr/>
-        <p:txBody>
-          <a:bodyPr/>
-          <a:lstStyle/>
-          <a:p>
-            <a:endParaRPr lang="en-US" dirty="0"/>
-          </a:p>
-        </p:txBody>
-      </p:sp>
-      <p:sp>
-        <p:nvSpPr>
-          <p:cNvPr id="4" name="Slide Number Placeholder 3"/>
-          <p:cNvSpPr>
-            <a:spLocks noGrp="1"/>
-          </p:cNvSpPr>
-          <p:nvPr>
-            <p:ph type="sldNum" sz="quarter" idx="10"/>
-          </p:nvPr>
-        </p:nvSpPr>
-        <p:spPr/>
-        <p:txBody>
-          <a:bodyPr/>
-          <a:lstStyle/>
-          <a:p>
-            <a:fld id="{F7021451-1387-4CA6-816F-3879F97B5CBC}" type="slidenum">
-              <a:rPr lang="en-US"/>
-              <a:t>14</a:t>
-            </a:fld>
-            <a:endParaRPr lang="en-US"/>
-          </a:p>
-        </p:txBody>
-      </p:sp>
     </p:spTree>
-    <p:extLst>
-      <p:ext uri="{BB962C8B-B14F-4D97-AF65-F5344CB8AC3E}">
-        <p14:creationId xmlns:p14="http://schemas.microsoft.com/office/powerpoint/2010/main" val="1024086991"/>
-      </p:ext>
-    </p:extLst>
   </p:cSld>
   <p:clrMapOvr>
     <a:masterClrMapping/>
@@ -962,6 +897,97 @@
             <a:fld id="{F7021451-1387-4CA6-816F-3879F97B5CBC}" type="slidenum">
               <a:rPr lang="en-US"/>
               <a:t>16</a:t>
+            </a:fld>
+            <a:endParaRPr lang="en-US"/>
+          </a:p>
+        </p:txBody>
+      </p:sp>
+    </p:spTree>
+    <p:extLst>
+      <p:ext uri="{BB962C8B-B14F-4D97-AF65-F5344CB8AC3E}">
+        <p14:creationId xmlns:p14="http://schemas.microsoft.com/office/powerpoint/2010/main" val="1024086991"/>
+      </p:ext>
+    </p:extLst>
+  </p:cSld>
+  <p:clrMapOvr>
+    <a:masterClrMapping/>
+  </p:clrMapOvr>
+</p:notes>
+</file>
+
+<file path=ppt/notesSlides/notesSlide17.xml><?xml version="1.0" encoding="utf-8"?>
+<p:notes xmlns:a="http://schemas.openxmlformats.org/drawingml/2006/main" xmlns:r="http://schemas.openxmlformats.org/officeDocument/2006/relationships" xmlns:p="http://schemas.openxmlformats.org/presentationml/2006/main">
+  <p:cSld>
+    <p:spTree>
+      <p:nvGrpSpPr>
+        <p:cNvPr id="1" name=""/>
+        <p:cNvGrpSpPr/>
+        <p:nvPr/>
+      </p:nvGrpSpPr>
+      <p:grpSpPr>
+        <a:xfrm>
+          <a:off x="0" y="0"/>
+          <a:ext cx="0" cy="0"/>
+          <a:chOff x="0" y="0"/>
+          <a:chExt cx="0" cy="0"/>
+        </a:xfrm>
+      </p:grpSpPr>
+      <p:sp>
+        <p:nvSpPr>
+          <p:cNvPr id="2" name="Slide Image Placeholder 1"/>
+          <p:cNvSpPr>
+            <a:spLocks noGrp="1" noRot="1" noChangeAspect="1"/>
+          </p:cNvSpPr>
+          <p:nvPr>
+            <p:ph type="sldImg"/>
+          </p:nvPr>
+        </p:nvSpPr>
+        <p:spPr/>
+        <p:txBody>
+          <a:bodyPr/>
+          <a:lstStyle/>
+          <a:p>
+            <a:endParaRPr lang="en-US"/>
+          </a:p>
+        </p:txBody>
+      </p:sp>
+      <p:sp>
+        <p:nvSpPr>
+          <p:cNvPr id="3" name="Notes Placeholder 2"/>
+          <p:cNvSpPr>
+            <a:spLocks noGrp="1"/>
+          </p:cNvSpPr>
+          <p:nvPr>
+            <p:ph type="body" idx="1"/>
+          </p:nvPr>
+        </p:nvSpPr>
+        <p:spPr/>
+        <p:txBody>
+          <a:bodyPr/>
+          <a:lstStyle/>
+          <a:p>
+            <a:endParaRPr lang="en-US" dirty="0"/>
+          </a:p>
+        </p:txBody>
+      </p:sp>
+      <p:sp>
+        <p:nvSpPr>
+          <p:cNvPr id="4" name="Slide Number Placeholder 3"/>
+          <p:cNvSpPr>
+            <a:spLocks noGrp="1"/>
+          </p:cNvSpPr>
+          <p:nvPr>
+            <p:ph type="sldNum" sz="quarter" idx="10"/>
+          </p:nvPr>
+        </p:nvSpPr>
+        <p:spPr/>
+        <p:txBody>
+          <a:bodyPr/>
+          <a:lstStyle/>
+          <a:p>
+            <a:fld id="{F7021451-1387-4CA6-816F-3879F97B5CBC}" type="slidenum">
+              <a:rPr lang="en-US"/>
+              <a:t>17</a:t>
             </a:fld>
             <a:endParaRPr lang="en-US"/>
           </a:p>
@@ -6926,6 +6952,854 @@
 
 <file path=ppt/slides/slide14.xml><?xml version="1.0" encoding="utf-8"?>
 <p:sld xmlns:a="http://schemas.openxmlformats.org/drawingml/2006/main" xmlns:r="http://schemas.openxmlformats.org/officeDocument/2006/relationships" xmlns:p="http://schemas.openxmlformats.org/presentationml/2006/main">
+  <p:cSld>
+    <p:spTree>
+      <p:nvGrpSpPr>
+        <p:cNvPr id="1" name=""/>
+        <p:cNvGrpSpPr/>
+        <p:nvPr/>
+      </p:nvGrpSpPr>
+      <p:grpSpPr>
+        <a:xfrm>
+          <a:off x="0" y="0"/>
+          <a:ext cx="0" cy="0"/>
+          <a:chOff x="0" y="0"/>
+          <a:chExt cx="0" cy="0"/>
+        </a:xfrm>
+      </p:grpSpPr>
+      <p:sp>
+        <p:nvSpPr>
+          <p:cNvPr id="2" name="Shape 0"/>
+          <p:cNvSpPr/>
+          <p:nvPr/>
+        </p:nvSpPr>
+        <p:spPr>
+          <a:xfrm>
+            <a:off x="0" y="0"/>
+            <a:ext cx="3566160" cy="5143500"/>
+          </a:xfrm>
+          <a:prstGeom prst="rect">
+            <a:avLst/>
+          </a:prstGeom>
+          <a:solidFill>
+            <a:srgbClr val="C00000"/>
+          </a:solidFill>
+          <a:ln w="9525">
+            <a:solidFill>
+              <a:srgbClr val="312E81"/>
+            </a:solidFill>
+            <a:prstDash val="solid"/>
+          </a:ln>
+        </p:spPr>
+        <p:txBody>
+          <a:bodyPr/>
+          <a:lstStyle/>
+          <a:p>
+            <a:endParaRPr lang="en-US"/>
+          </a:p>
+        </p:txBody>
+      </p:sp>
+      <p:sp>
+        <p:nvSpPr>
+          <p:cNvPr id="3" name="Text 1"/>
+          <p:cNvSpPr/>
+          <p:nvPr/>
+        </p:nvSpPr>
+        <p:spPr>
+          <a:xfrm>
+            <a:off x="201168" y="164592"/>
+            <a:ext cx="3200400" cy="274320"/>
+          </a:xfrm>
+          <a:prstGeom prst="rect">
+            <a:avLst/>
+          </a:prstGeom>
+          <a:noFill/>
+          <a:ln/>
+        </p:spPr>
+        <p:txBody>
+          <a:bodyPr wrap="square" lIns="0" tIns="0" rIns="0" bIns="0" rtlCol="0" anchor="ctr"/>
+          <a:lstStyle/>
+          <a:p>
+            <a:pPr marL="0" indent="0">
+              <a:buNone/>
+            </a:pPr>
+            <a:r>
+              <a:rPr lang="en-US" sz="900" b="1" kern="0" spc="300" dirty="0">
+                <a:solidFill>
+                  <a:srgbClr val="FFFFFF"/>
+                </a:solidFill>
+                <a:latin typeface="Calibri" pitchFamily="34" charset="0"/>
+                <a:ea typeface="Calibri" pitchFamily="34" charset="-122"/>
+                <a:cs typeface="Calibri" pitchFamily="34" charset="-120"/>
+              </a:rPr>
+              <a:t>C10 - SAFETY LAYER</a:t>
+            </a:r>
+            <a:endParaRPr lang="en-US" sz="900" dirty="0"/>
+          </a:p>
+        </p:txBody>
+      </p:sp>
+      <p:sp>
+        <p:nvSpPr>
+          <p:cNvPr id="4" name="Text 2"/>
+          <p:cNvSpPr/>
+          <p:nvPr/>
+        </p:nvSpPr>
+        <p:spPr>
+          <a:xfrm>
+            <a:off x="201168" y="457200"/>
+            <a:ext cx="3218688" cy="960120"/>
+          </a:xfrm>
+          <a:prstGeom prst="rect">
+            <a:avLst/>
+          </a:prstGeom>
+          <a:noFill/>
+          <a:ln/>
+        </p:spPr>
+        <p:txBody>
+          <a:bodyPr wrap="square" lIns="0" tIns="0" rIns="0" bIns="0" rtlCol="0" anchor="ctr"/>
+          <a:lstStyle/>
+          <a:p>
+            <a:pPr marL="0" indent="0">
+              <a:buNone/>
+            </a:pPr>
+            <a:r>
+              <a:rPr lang="en-US" sz="2600" b="1" dirty="0">
+                <a:solidFill>
+                  <a:srgbClr val="FFFFFF"/>
+                </a:solidFill>
+                <a:latin typeface="Calibri" pitchFamily="34" charset="0"/>
+                <a:ea typeface="Calibri" pitchFamily="34" charset="-122"/>
+                <a:cs typeface="Calibri" pitchFamily="34" charset="-120"/>
+              </a:rPr>
+              <a:t>Content</a:t>
+            </a:r>
+            <a:endParaRPr lang="en-US" sz="2600" dirty="0"/>
+          </a:p>
+          <a:p>
+            <a:pPr marL="0" indent="0">
+              <a:buNone/>
+            </a:pPr>
+            <a:r>
+              <a:rPr lang="en-US" sz="2600" b="1" dirty="0">
+                <a:solidFill>
+                  <a:srgbClr val="FFFFFF"/>
+                </a:solidFill>
+                <a:latin typeface="Calibri" pitchFamily="34" charset="0"/>
+                <a:ea typeface="Calibri" pitchFamily="34" charset="-122"/>
+                <a:cs typeface="Calibri" pitchFamily="34" charset="-120"/>
+              </a:rPr>
+              <a:t>Safety &amp; Guardrails</a:t>
+            </a:r>
+            <a:endParaRPr lang="en-US" sz="2600" dirty="0"/>
+          </a:p>
+        </p:txBody>
+      </p:sp>
+      <p:sp>
+        <p:nvSpPr>
+          <p:cNvPr id="5" name="Shape 3"/>
+          <p:cNvSpPr/>
+          <p:nvPr/>
+        </p:nvSpPr>
+        <p:spPr>
+          <a:xfrm>
+            <a:off x="201168" y="1481328"/>
+            <a:ext cx="3163824" cy="36576"/>
+          </a:xfrm>
+          <a:prstGeom prst="rect">
+            <a:avLst/>
+          </a:prstGeom>
+          <a:solidFill>
+            <a:srgbClr val="FFFFFF"/>
+          </a:solidFill>
+          <a:ln w="9525">
+            <a:solidFill>
+              <a:srgbClr val="FFFFFF"/>
+            </a:solidFill>
+            <a:prstDash val="solid"/>
+          </a:ln>
+        </p:spPr>
+        <p:txBody>
+          <a:bodyPr/>
+          <a:lstStyle/>
+          <a:p>
+            <a:endParaRPr lang="en-US"/>
+          </a:p>
+        </p:txBody>
+      </p:sp>
+      <p:sp>
+        <p:nvSpPr>
+          <p:cNvPr id="6" name="Text 4"/>
+          <p:cNvSpPr/>
+          <p:nvPr/>
+        </p:nvSpPr>
+        <p:spPr>
+          <a:xfrm>
+            <a:off x="201168" y="1664208"/>
+            <a:ext cx="3218688" cy="658368"/>
+          </a:xfrm>
+          <a:prstGeom prst="rect">
+            <a:avLst/>
+          </a:prstGeom>
+          <a:noFill/>
+          <a:ln/>
+        </p:spPr>
+        <p:txBody>
+          <a:bodyPr wrap="square" lIns="0" tIns="0" rIns="0" bIns="0" rtlCol="0" anchor="ctr"/>
+          <a:lstStyle/>
+          <a:p>
+            <a:pPr marL="0" indent="0">
+              <a:buNone/>
+            </a:pPr>
+            <a:r>
+              <a:rPr lang="en-US" sz="1600" b="1" dirty="0">
+                <a:solidFill>
+                  <a:srgbClr val="FFFFFF"/>
+                </a:solidFill>
+                <a:latin typeface="Calibri" pitchFamily="34" charset="0"/>
+                <a:ea typeface="Calibri" pitchFamily="34" charset="-122"/>
+                <a:cs typeface="Calibri" pitchFamily="34" charset="-120"/>
+              </a:rPr>
+              <a:t>› </a:t>
+            </a:r>
+            <a:r>
+              <a:rPr lang="en-US" sz="1250" dirty="0">
+                <a:solidFill>
+                  <a:srgbClr val="FFFFFF"/>
+                </a:solidFill>
+                <a:latin typeface="Calibri" pitchFamily="34" charset="0"/>
+                <a:ea typeface="Calibri" pitchFamily="34" charset="-122"/>
+                <a:cs typeface="Calibri" pitchFamily="34" charset="-120"/>
+              </a:rPr>
+              <a:t>Azure content filters active on all model deployments</a:t>
+            </a:r>
+            <a:endParaRPr lang="en-US" sz="1250" dirty="0"/>
+          </a:p>
+        </p:txBody>
+      </p:sp>
+      <p:sp>
+        <p:nvSpPr>
+          <p:cNvPr id="7" name="Text 5"/>
+          <p:cNvSpPr/>
+          <p:nvPr/>
+        </p:nvSpPr>
+        <p:spPr>
+          <a:xfrm>
+            <a:off x="201168" y="2391616"/>
+            <a:ext cx="3218688" cy="658368"/>
+          </a:xfrm>
+          <a:prstGeom prst="rect">
+            <a:avLst/>
+          </a:prstGeom>
+          <a:noFill/>
+          <a:ln/>
+        </p:spPr>
+        <p:txBody>
+          <a:bodyPr wrap="square" lIns="0" tIns="0" rIns="0" bIns="0" rtlCol="0" anchor="ctr"/>
+          <a:lstStyle/>
+          <a:p>
+            <a:pPr marL="0" indent="0">
+              <a:buNone/>
+            </a:pPr>
+            <a:r>
+              <a:rPr lang="en-US" sz="1600" b="1" dirty="0">
+                <a:solidFill>
+                  <a:srgbClr val="FFFFFF"/>
+                </a:solidFill>
+                <a:latin typeface="Calibri" pitchFamily="34" charset="0"/>
+                <a:ea typeface="Calibri" pitchFamily="34" charset="-122"/>
+                <a:cs typeface="Calibri" pitchFamily="34" charset="-120"/>
+              </a:rPr>
+              <a:t>› </a:t>
+            </a:r>
+            <a:r>
+              <a:rPr lang="en-US" sz="1250" dirty="0">
+                <a:solidFill>
+                  <a:srgbClr val="FFFFFF"/>
+                </a:solidFill>
+                <a:latin typeface="Calibri" pitchFamily="34" charset="0"/>
+                <a:ea typeface="Calibri" pitchFamily="34" charset="-122"/>
+                <a:cs typeface="Calibri" pitchFamily="34" charset="-120"/>
+              </a:rPr>
+              <a:t>Unhandled content_filter (HTTP 400) → SSE stream terminates — no RUN_FINISHED sent</a:t>
+            </a:r>
+            <a:endParaRPr lang="en-US" sz="1250" dirty="0"/>
+          </a:p>
+        </p:txBody>
+      </p:sp>
+      <p:sp>
+        <p:nvSpPr>
+          <p:cNvPr id="8" name="Text 6"/>
+          <p:cNvSpPr/>
+          <p:nvPr/>
+        </p:nvSpPr>
+        <p:spPr>
+          <a:xfrm>
+            <a:off x="201168" y="3246611"/>
+            <a:ext cx="3218688" cy="658368"/>
+          </a:xfrm>
+          <a:prstGeom prst="rect">
+            <a:avLst/>
+          </a:prstGeom>
+          <a:noFill/>
+          <a:ln/>
+        </p:spPr>
+        <p:txBody>
+          <a:bodyPr wrap="square" lIns="0" tIns="0" rIns="0" bIns="0" rtlCol="0" anchor="ctr"/>
+          <a:lstStyle/>
+          <a:p>
+            <a:pPr marL="0" indent="0">
+              <a:buNone/>
+            </a:pPr>
+            <a:r>
+              <a:rPr lang="en-US" sz="1600" b="1" dirty="0">
+                <a:solidFill>
+                  <a:srgbClr val="FFFFFF"/>
+                </a:solidFill>
+                <a:latin typeface="Calibri" pitchFamily="34" charset="0"/>
+                <a:ea typeface="Calibri" pitchFamily="34" charset="-122"/>
+                <a:cs typeface="Calibri" pitchFamily="34" charset="-120"/>
+              </a:rPr>
+              <a:t>› </a:t>
+            </a:r>
+            <a:r>
+              <a:rPr lang="en-US" sz="1250" dirty="0">
+                <a:solidFill>
+                  <a:srgbClr val="FFFFFF"/>
+                </a:solidFill>
+                <a:latin typeface="Calibri" pitchFamily="34" charset="0"/>
+                <a:ea typeface="Calibri" pitchFamily="34" charset="-122"/>
+                <a:cs typeface="Calibri" pitchFamily="34" charset="-120"/>
+              </a:rPr>
+              <a:t>ContentSafetyGuardChatClient — inserted after UseFunctionInvocation() in both v1 + v2</a:t>
+            </a:r>
+            <a:endParaRPr lang="en-US" sz="1250" dirty="0"/>
+          </a:p>
+        </p:txBody>
+      </p:sp>
+      <p:sp>
+        <p:nvSpPr>
+          <p:cNvPr id="9" name="Text 7"/>
+          <p:cNvSpPr/>
+          <p:nvPr/>
+        </p:nvSpPr>
+        <p:spPr>
+          <a:xfrm>
+            <a:off x="201168" y="4087435"/>
+            <a:ext cx="3218688" cy="658368"/>
+          </a:xfrm>
+          <a:prstGeom prst="rect">
+            <a:avLst/>
+          </a:prstGeom>
+          <a:noFill/>
+          <a:ln/>
+        </p:spPr>
+        <p:txBody>
+          <a:bodyPr wrap="square" lIns="0" tIns="0" rIns="0" bIns="0" rtlCol="0" anchor="ctr"/>
+          <a:lstStyle/>
+          <a:p>
+            <a:pPr marL="0" indent="0">
+              <a:buNone/>
+            </a:pPr>
+            <a:r>
+              <a:rPr lang="en-US" sz="1600" b="1" dirty="0">
+                <a:solidFill>
+                  <a:srgbClr val="FFFFFF"/>
+                </a:solidFill>
+                <a:latin typeface="Calibri" pitchFamily="34" charset="0"/>
+                <a:ea typeface="Calibri" pitchFamily="34" charset="-122"/>
+                <a:cs typeface="Calibri" pitchFamily="34" charset="-120"/>
+              </a:rPr>
+              <a:t>› </a:t>
+            </a:r>
+            <a:r>
+              <a:rPr lang="en-US" sz="1250" dirty="0">
+                <a:solidFill>
+                  <a:srgbClr val="FFFFFF"/>
+                </a:solidFill>
+                <a:latin typeface="Calibri" pitchFamily="34" charset="0"/>
+                <a:ea typeface="Calibri" pitchFamily="34" charset="-122"/>
+                <a:cs typeface="Calibri" pitchFamily="34" charset="-120"/>
+              </a:rPr>
+              <a:t>On filter hit: Redis history cleared, ⚠️ message returned, thread.id logged → App Insights</a:t>
+            </a:r>
+            <a:endParaRPr lang="en-US" sz="1250" dirty="0"/>
+          </a:p>
+        </p:txBody>
+      </p:sp>
+      <p:sp>
+        <p:nvSpPr>
+          <p:cNvPr id="10" name="Shape 8"/>
+          <p:cNvSpPr/>
+          <p:nvPr/>
+        </p:nvSpPr>
+        <p:spPr>
+          <a:xfrm>
+            <a:off x="3566160" y="0"/>
+            <a:ext cx="5577840" cy="54864"/>
+          </a:xfrm>
+          <a:prstGeom prst="rect">
+            <a:avLst/>
+          </a:prstGeom>
+          <a:solidFill>
+            <a:srgbClr val="C00000"/>
+          </a:solidFill>
+          <a:ln w="9525">
+            <a:solidFill>
+              <a:srgbClr val="312E81"/>
+            </a:solidFill>
+            <a:prstDash val="solid"/>
+          </a:ln>
+        </p:spPr>
+        <p:txBody>
+          <a:bodyPr/>
+          <a:lstStyle/>
+          <a:p>
+            <a:endParaRPr lang="en-US"/>
+          </a:p>
+        </p:txBody>
+      </p:sp>
+      <p:sp>
+        <p:nvSpPr>
+          <p:cNvPr id="11" name="Text 9"/>
+          <p:cNvSpPr/>
+          <p:nvPr/>
+        </p:nvSpPr>
+        <p:spPr>
+          <a:xfrm>
+            <a:off x="3749040" y="137160"/>
+            <a:ext cx="5212080" cy="384048"/>
+          </a:xfrm>
+          <a:prstGeom prst="rect">
+            <a:avLst/>
+          </a:prstGeom>
+          <a:noFill/>
+          <a:ln/>
+        </p:spPr>
+        <p:txBody>
+          <a:bodyPr wrap="square" lIns="0" tIns="0" rIns="0" bIns="0" rtlCol="0" anchor="ctr"/>
+          <a:lstStyle/>
+          <a:p>
+            <a:pPr marL="0" indent="0">
+              <a:buNone/>
+            </a:pPr>
+            <a:r>
+              <a:rPr lang="en-US" sz="1400" b="1" dirty="0">
+                <a:solidFill>
+                  <a:srgbClr val="312E81"/>
+                </a:solidFill>
+                <a:latin typeface="Calibri" pitchFamily="34" charset="0"/>
+                <a:ea typeface="Calibri" pitchFamily="34" charset="-122"/>
+                <a:cs typeface="Calibri" pitchFamily="34" charset="-120"/>
+              </a:rPr>
+              <a:t>Handle guardrails explicitly in the pipeline — not as an afterthought</a:t>
+            </a:r>
+            <a:endParaRPr lang="en-US" sz="1400" dirty="0"/>
+          </a:p>
+        </p:txBody>
+      </p:sp>
+      <p:sp>
+        <p:nvSpPr>
+          <p:cNvPr id="12" name="Shape 10"/>
+          <p:cNvSpPr/>
+          <p:nvPr/>
+        </p:nvSpPr>
+        <p:spPr>
+          <a:xfrm>
+            <a:off x="3749040" y="548640"/>
+            <a:ext cx="5212080" cy="22860"/>
+          </a:xfrm>
+          <a:prstGeom prst="rect">
+            <a:avLst/>
+          </a:prstGeom>
+          <a:solidFill>
+            <a:srgbClr val="E2E8F0"/>
+          </a:solidFill>
+          <a:ln w="9525">
+            <a:solidFill>
+              <a:srgbClr val="E2E8F0"/>
+            </a:solidFill>
+            <a:prstDash val="solid"/>
+          </a:ln>
+        </p:spPr>
+        <p:txBody>
+          <a:bodyPr/>
+          <a:lstStyle/>
+          <a:p>
+            <a:endParaRPr lang="en-US"/>
+          </a:p>
+        </p:txBody>
+      </p:sp>
+      <p:sp>
+        <p:nvSpPr>
+          <p:cNvPr id="13" name="Shape 11"/>
+          <p:cNvSpPr/>
+          <p:nvPr/>
+        </p:nvSpPr>
+        <p:spPr>
+          <a:xfrm>
+            <a:off x="3749040" y="658368"/>
+            <a:ext cx="5212080" cy="1371600"/>
+          </a:xfrm>
+          <a:prstGeom prst="rect">
+            <a:avLst/>
+          </a:prstGeom>
+          <a:solidFill>
+            <a:srgbClr val="1E1E2E"/>
+          </a:solidFill>
+          <a:ln w="9525">
+            <a:solidFill>
+              <a:srgbClr val="374151"/>
+            </a:solidFill>
+            <a:prstDash val="solid"/>
+          </a:ln>
+          <a:effectLst>
+            <a:outerShdw blurRad="63500" dist="25400" dir="8100000" algn="bl" rotWithShape="0">
+              <a:srgbClr val="000000">
+                <a:alpha val="9000"/>
+              </a:srgbClr>
+            </a:outerShdw>
+          </a:effectLst>
+        </p:spPr>
+        <p:txBody>
+          <a:bodyPr/>
+          <a:lstStyle/>
+          <a:p>
+            <a:endParaRPr lang="en-US"/>
+          </a:p>
+        </p:txBody>
+      </p:sp>
+      <p:sp>
+        <p:nvSpPr>
+          <p:cNvPr id="14" name="Text 12"/>
+          <p:cNvSpPr/>
+          <p:nvPr/>
+        </p:nvSpPr>
+        <p:spPr>
+          <a:xfrm>
+            <a:off x="3931920" y="804672"/>
+            <a:ext cx="4892040" cy="1115568"/>
+          </a:xfrm>
+          <a:prstGeom prst="rect">
+            <a:avLst/>
+          </a:prstGeom>
+          <a:noFill/>
+          <a:ln/>
+        </p:spPr>
+        <p:txBody>
+          <a:bodyPr wrap="square" lIns="0" tIns="0" rIns="0" bIns="0" rtlCol="0" anchor="ctr"/>
+          <a:lstStyle/>
+          <a:p>
+            <a:pPr marL="0" indent="0">
+              <a:buNone/>
+            </a:pPr>
+            <a:r>
+              <a:rPr lang="en-US" sz="1050" dirty="0">
+                <a:solidFill>
+                  <a:srgbClr val="569CD6"/>
+                </a:solidFill>
+                <a:latin typeface="Consolas" pitchFamily="34" charset="0"/>
+                <a:ea typeface="Consolas" pitchFamily="34" charset="-122"/>
+                <a:cs typeface="Consolas" pitchFamily="34" charset="-120"/>
+              </a:rPr>
+              <a:t>catch (Exception ex)
+  when (IsContentFilterException(ex))
+{
+  await HandleContentFilterAsync(ex, ct);
+  filterHit = true;
+}</a:t>
+            </a:r>
+            <a:endParaRPr lang="en-US" sz="1050" dirty="0"/>
+          </a:p>
+        </p:txBody>
+      </p:sp>
+      <p:sp>
+        <p:nvSpPr>
+          <p:cNvPr id="15" name="Text 13"/>
+          <p:cNvSpPr/>
+          <p:nvPr/>
+        </p:nvSpPr>
+        <p:spPr>
+          <a:xfrm>
+            <a:off x="3749040" y="2194560"/>
+            <a:ext cx="5212080" cy="256032"/>
+          </a:xfrm>
+          <a:prstGeom prst="rect">
+            <a:avLst/>
+          </a:prstGeom>
+          <a:noFill/>
+          <a:ln/>
+        </p:spPr>
+        <p:txBody>
+          <a:bodyPr wrap="square" lIns="0" tIns="0" rIns="0" bIns="0" rtlCol="0" anchor="ctr"/>
+          <a:lstStyle/>
+          <a:p>
+            <a:pPr marL="0" indent="0">
+              <a:buNone/>
+            </a:pPr>
+            <a:r>
+              <a:rPr lang="en-US" sz="1200" b="1" dirty="0">
+                <a:solidFill>
+                  <a:srgbClr val="312E81"/>
+                </a:solidFill>
+                <a:latin typeface="Calibri" pitchFamily="34" charset="0"/>
+                <a:ea typeface="Calibri" pitchFamily="34" charset="-122"/>
+                <a:cs typeface="Calibri" pitchFamily="34" charset="-120"/>
+              </a:rPr>
+              <a:t>On filter hit</a:t>
+            </a:r>
+            <a:endParaRPr lang="en-US" sz="1200" dirty="0"/>
+          </a:p>
+        </p:txBody>
+      </p:sp>
+      <p:sp>
+        <p:nvSpPr>
+          <p:cNvPr id="16" name="Text 14"/>
+          <p:cNvSpPr/>
+          <p:nvPr/>
+        </p:nvSpPr>
+        <p:spPr>
+          <a:xfrm>
+            <a:off x="3749040" y="2487168"/>
+            <a:ext cx="5212080" cy="228600"/>
+          </a:xfrm>
+          <a:prstGeom prst="rect">
+            <a:avLst/>
+          </a:prstGeom>
+          <a:noFill/>
+          <a:ln/>
+        </p:spPr>
+        <p:txBody>
+          <a:bodyPr wrap="square" lIns="0" tIns="0" rIns="0" bIns="0" rtlCol="0" anchor="ctr"/>
+          <a:lstStyle/>
+          <a:p>
+            <a:pPr marL="0" indent="0">
+              <a:buNone/>
+            </a:pPr>
+            <a:r>
+              <a:rPr lang="en-US" sz="1150" b="1" dirty="0">
+                <a:solidFill>
+                  <a:srgbClr val="312E81"/>
+                </a:solidFill>
+                <a:latin typeface="Calibri" pitchFamily="34" charset="0"/>
+                <a:ea typeface="Calibri" pitchFamily="34" charset="-122"/>
+                <a:cs typeface="Calibri" pitchFamily="34" charset="-120"/>
+              </a:rPr>
+              <a:t>- Redis history cleared (messages:{threadId})</a:t>
+            </a:r>
+            <a:endParaRPr lang="en-US" sz="1150" dirty="0"/>
+          </a:p>
+        </p:txBody>
+      </p:sp>
+      <p:sp>
+        <p:nvSpPr>
+          <p:cNvPr id="17" name="Text 15"/>
+          <p:cNvSpPr/>
+          <p:nvPr/>
+        </p:nvSpPr>
+        <p:spPr>
+          <a:xfrm>
+            <a:off x="3749040" y="2734056"/>
+            <a:ext cx="5212080" cy="228600"/>
+          </a:xfrm>
+          <a:prstGeom prst="rect">
+            <a:avLst/>
+          </a:prstGeom>
+          <a:noFill/>
+          <a:ln/>
+        </p:spPr>
+        <p:txBody>
+          <a:bodyPr wrap="square" lIns="0" tIns="0" rIns="0" bIns="0" rtlCol="0" anchor="ctr"/>
+          <a:lstStyle/>
+          <a:p>
+            <a:pPr marL="0" indent="0">
+              <a:buNone/>
+            </a:pPr>
+            <a:r>
+              <a:rPr lang="en-US" sz="1150" b="1" dirty="0">
+                <a:solidFill>
+                  <a:srgbClr val="312E81"/>
+                </a:solidFill>
+                <a:latin typeface="Calibri" pitchFamily="34" charset="0"/>
+                <a:ea typeface="Calibri" pitchFamily="34" charset="-122"/>
+                <a:cs typeface="Calibri" pitchFamily="34" charset="-120"/>
+              </a:rPr>
+              <a:t>- ⚠️  User-facing message returned</a:t>
+            </a:r>
+            <a:endParaRPr lang="en-US" sz="1150" dirty="0"/>
+          </a:p>
+        </p:txBody>
+      </p:sp>
+      <p:sp>
+        <p:nvSpPr>
+          <p:cNvPr id="18" name="Text 16"/>
+          <p:cNvSpPr/>
+          <p:nvPr/>
+        </p:nvSpPr>
+        <p:spPr>
+          <a:xfrm>
+            <a:off x="3749040" y="2980944"/>
+            <a:ext cx="5212080" cy="228600"/>
+          </a:xfrm>
+          <a:prstGeom prst="rect">
+            <a:avLst/>
+          </a:prstGeom>
+          <a:noFill/>
+          <a:ln/>
+        </p:spPr>
+        <p:txBody>
+          <a:bodyPr wrap="square" lIns="0" tIns="0" rIns="0" bIns="0" rtlCol="0" anchor="ctr"/>
+          <a:lstStyle/>
+          <a:p>
+            <a:pPr marL="0" indent="0">
+              <a:buNone/>
+            </a:pPr>
+            <a:r>
+              <a:rPr lang="en-US" sz="1150" b="1" dirty="0">
+                <a:solidFill>
+                  <a:srgbClr val="312E81"/>
+                </a:solidFill>
+                <a:latin typeface="Calibri" pitchFamily="34" charset="0"/>
+                <a:ea typeface="Calibri" pitchFamily="34" charset="-122"/>
+                <a:cs typeface="Calibri" pitchFamily="34" charset="-120"/>
+              </a:rPr>
+              <a:t>- Stream closes cleanly (RUN_FINISHED sent)</a:t>
+            </a:r>
+            <a:endParaRPr lang="en-US" sz="1150" dirty="0"/>
+          </a:p>
+        </p:txBody>
+      </p:sp>
+      <p:sp>
+        <p:nvSpPr>
+          <p:cNvPr id="19" name="Text 17"/>
+          <p:cNvSpPr/>
+          <p:nvPr/>
+        </p:nvSpPr>
+        <p:spPr>
+          <a:xfrm>
+            <a:off x="3749040" y="3227832"/>
+            <a:ext cx="5212080" cy="228600"/>
+          </a:xfrm>
+          <a:prstGeom prst="rect">
+            <a:avLst/>
+          </a:prstGeom>
+          <a:noFill/>
+          <a:ln/>
+        </p:spPr>
+        <p:txBody>
+          <a:bodyPr wrap="square" lIns="0" tIns="0" rIns="0" bIns="0" rtlCol="0" anchor="ctr"/>
+          <a:lstStyle/>
+          <a:p>
+            <a:pPr marL="0" indent="0">
+              <a:buNone/>
+            </a:pPr>
+            <a:r>
+              <a:rPr lang="en-US" sz="1150" b="1" dirty="0">
+                <a:solidFill>
+                  <a:srgbClr val="312E81"/>
+                </a:solidFill>
+                <a:latin typeface="Calibri" pitchFamily="34" charset="0"/>
+                <a:ea typeface="Calibri" pitchFamily="34" charset="-122"/>
+                <a:cs typeface="Calibri" pitchFamily="34" charset="-120"/>
+              </a:rPr>
+              <a:t>- Warning logged with thread.id for App Insights</a:t>
+            </a:r>
+            <a:endParaRPr lang="en-US" sz="1150" dirty="0"/>
+          </a:p>
+        </p:txBody>
+      </p:sp>
+      <p:sp>
+        <p:nvSpPr>
+          <p:cNvPr id="20" name="Shape 18"/>
+          <p:cNvSpPr/>
+          <p:nvPr/>
+        </p:nvSpPr>
+        <p:spPr>
+          <a:xfrm>
+            <a:off x="3749040" y="3474720"/>
+            <a:ext cx="5212080" cy="1120140"/>
+          </a:xfrm>
+          <a:prstGeom prst="rect">
+            <a:avLst/>
+          </a:prstGeom>
+          <a:solidFill>
+            <a:srgbClr val="1E1E2E"/>
+          </a:solidFill>
+          <a:ln w="9525">
+            <a:solidFill>
+              <a:srgbClr val="374151"/>
+            </a:solidFill>
+            <a:prstDash val="solid"/>
+          </a:ln>
+          <a:effectLst>
+            <a:outerShdw blurRad="63500" dist="25400" dir="8100000" algn="bl" rotWithShape="0">
+              <a:srgbClr val="000000">
+                <a:alpha val="9000"/>
+              </a:srgbClr>
+            </a:outerShdw>
+          </a:effectLst>
+        </p:spPr>
+        <p:txBody>
+          <a:bodyPr/>
+          <a:lstStyle/>
+          <a:p>
+            <a:endParaRPr lang="en-US"/>
+          </a:p>
+        </p:txBody>
+      </p:sp>
+      <p:sp>
+        <p:nvSpPr>
+          <p:cNvPr id="21" name="Text 19"/>
+          <p:cNvSpPr/>
+          <p:nvPr/>
+        </p:nvSpPr>
+        <p:spPr>
+          <a:xfrm>
+            <a:off x="3931920" y="3694176"/>
+            <a:ext cx="4892040" cy="612648"/>
+          </a:xfrm>
+          <a:prstGeom prst="rect">
+            <a:avLst/>
+          </a:prstGeom>
+          <a:noFill/>
+          <a:ln/>
+        </p:spPr>
+        <p:txBody>
+          <a:bodyPr wrap="square" lIns="0" tIns="0" rIns="0" bIns="0" rtlCol="0" anchor="ctr"/>
+          <a:lstStyle/>
+          <a:p>
+            <a:pPr marL="0" indent="0">
+              <a:buNone/>
+            </a:pPr>
+            <a:r>
+              <a:rPr lang="en-US" sz="1050" dirty="0">
+                <a:solidFill>
+                  <a:srgbClr val="9CDCFE"/>
+                </a:solidFill>
+                <a:latin typeface="Consolas" pitchFamily="34" charset="0"/>
+                <a:ea typeface="Consolas" pitchFamily="34" charset="-122"/>
+                <a:cs typeface="Consolas" pitchFamily="34" charset="-120"/>
+              </a:rPr>
+              <a:t>.UseFunctionInvocation()
+.Use((inner, svc) =&gt;
+  new ContentSafetyGuardChatClient(
+    inner, redis, logger))
+.Use((inner, svc) =&gt;
+  new UsageCapturingChatClient(...))</a:t>
+            </a:r>
+            <a:endParaRPr lang="en-US" sz="1050" dirty="0"/>
+          </a:p>
+        </p:txBody>
+      </p:sp>
+    </p:spTree>
+  </p:cSld>
+  <p:clrMapOvr>
+    <a:masterClrMapping/>
+  </p:clrMapOvr>
+</p:sld>
+</file>
+
+<file path=ppt/slides/slide15.xml><?xml version="1.0" encoding="utf-8"?>
+<p:sld xmlns:a="http://schemas.openxmlformats.org/drawingml/2006/main" xmlns:r="http://schemas.openxmlformats.org/officeDocument/2006/relationships" xmlns:p="http://schemas.openxmlformats.org/presentationml/2006/main">
   <p:cSld name="Slide 14">
     <p:bg>
       <p:bgPr>
@@ -7234,7 +8108,7 @@
                 <a:ea typeface="Calibri" pitchFamily="34" charset="-122"/>
                 <a:cs typeface="Calibri" pitchFamily="34" charset="-120"/>
               </a:rPr>
-              <a:t>An LLM API call is not a system. Routing, memory, auth, skills, streaming, and evaluation need to be built consistently - MAF does that.</a:t>
+              <a:t>An LLM API call is not a system. Routing, memory, auth, skills, streaming, evaluation, and production guardrails need to be built consistently — MAF does that.</a:t>
             </a:r>
             <a:endParaRPr lang="en-US" sz="1250" dirty="0"/>
           </a:p>
@@ -7571,7 +8445,7 @@
                 <a:ea typeface="Calibri" pitchFamily="34" charset="-122"/>
                 <a:cs typeface="Calibri" pitchFamily="34" charset="-120"/>
               </a:rPr>
-              <a:t>Observability is architecture</a:t>
+              <a:t>Observability &amp; Guardrails are architecture</a:t>
             </a:r>
             <a:endParaRPr lang="en-US" sz="1400" dirty="0"/>
           </a:p>
@@ -7610,7 +8484,7 @@
                 <a:ea typeface="Calibri" pitchFamily="34" charset="-122"/>
                 <a:cs typeface="Calibri" pitchFamily="34" charset="-120"/>
               </a:rPr>
-              <a:t>If you cannot trace agent routing, tool use, and thread flow, you are not ready for production. OTel plus App Insights make MAF systems operable.</a:t>
+              <a:t>If you cannot trace agent routing, tool use, and thread flow — and handle content safety failures without breaking the stream — you are not ready for production.</a:t>
             </a:r>
             <a:endParaRPr lang="en-US" sz="1250" dirty="0"/>
           </a:p>
@@ -7812,7 +8686,7 @@
 </p:sld>
 </file>
 
-<file path=ppt/slides/slide15.xml><?xml version="1.0" encoding="utf-8"?>
+<file path=ppt/slides/slide16.xml><?xml version="1.0" encoding="utf-8"?>
 <p:sld xmlns:a="http://schemas.openxmlformats.org/drawingml/2006/main" xmlns:r="http://schemas.openxmlformats.org/officeDocument/2006/relationships" xmlns:p="http://schemas.openxmlformats.org/presentationml/2006/main">
   <p:cSld name="Slide 15">
     <p:bg>
@@ -9623,7 +10497,7 @@
 </p:sld>
 </file>
 
-<file path=ppt/slides/slide16.xml><?xml version="1.0" encoding="utf-8"?>
+<file path=ppt/slides/slide17.xml><?xml version="1.0" encoding="utf-8"?>
 <p:sld xmlns:a="http://schemas.openxmlformats.org/drawingml/2006/main" xmlns:r="http://schemas.openxmlformats.org/officeDocument/2006/relationships" xmlns:p="http://schemas.openxmlformats.org/presentationml/2006/main">
   <p:cSld name="Slide 16">
     <p:bg>

</xml_diff>

<commit_message>
chore: trivial ppt updates
</commit_message>
<xml_diff>
--- a/conference/HelpdeskAI-Kolkata-2026.pptx
+++ b/conference/HelpdeskAI-Kolkata-2026.pptx
@@ -2795,7 +2795,7 @@
         <p:spPr>
           <a:xfrm>
             <a:off x="201168" y="3090672"/>
-            <a:ext cx="3218688" cy="658368"/>
+            <a:ext cx="3294200" cy="658368"/>
           </a:xfrm>
           <a:prstGeom prst="rect">
             <a:avLst/>
@@ -2822,6 +2822,17 @@
               <a:t>› </a:t>
             </a:r>
             <a:r>
+              <a:rPr lang="en-US" sz="1250" dirty="0" err="1">
+                <a:solidFill>
+                  <a:srgbClr val="FFFFFF"/>
+                </a:solidFill>
+                <a:latin typeface="Calibri" pitchFamily="34" charset="0"/>
+                <a:ea typeface="Calibri" pitchFamily="34" charset="-122"/>
+                <a:cs typeface="Calibri" pitchFamily="34" charset="-120"/>
+              </a:rPr>
+              <a:t>AgentWo</a:t>
+            </a:r>
+            <a:r>
               <a:rPr lang="en-US" sz="1250" dirty="0">
                 <a:solidFill>
                   <a:srgbClr val="FFFFFF"/>
@@ -2830,7 +2841,51 @@
                 <a:ea typeface="Calibri" pitchFamily="34" charset="-122"/>
                 <a:cs typeface="Calibri" pitchFamily="34" charset="-120"/>
               </a:rPr>
-              <a:t>AgentWorkflowBuilder.CreateHandoffBuilderWith()</a:t>
+              <a:t>…</a:t>
+            </a:r>
+            <a:r>
+              <a:rPr lang="en-US" sz="1250" dirty="0" err="1">
+                <a:solidFill>
+                  <a:srgbClr val="FFFFFF"/>
+                </a:solidFill>
+                <a:latin typeface="Calibri" pitchFamily="34" charset="0"/>
+                <a:ea typeface="Calibri" pitchFamily="34" charset="-122"/>
+                <a:cs typeface="Calibri" pitchFamily="34" charset="-120"/>
+              </a:rPr>
+              <a:t>Builder.CreateHan</a:t>
+            </a:r>
+            <a:r>
+              <a:rPr lang="en-US" sz="1250" dirty="0">
+                <a:solidFill>
+                  <a:srgbClr val="FFFFFF"/>
+                </a:solidFill>
+                <a:latin typeface="Calibri" pitchFamily="34" charset="0"/>
+                <a:ea typeface="Calibri" pitchFamily="34" charset="-122"/>
+                <a:cs typeface="Calibri" pitchFamily="34" charset="-120"/>
+              </a:rPr>
+              <a:t>…</a:t>
+            </a:r>
+            <a:r>
+              <a:rPr lang="en-US" sz="1250" dirty="0" err="1">
+                <a:solidFill>
+                  <a:srgbClr val="FFFFFF"/>
+                </a:solidFill>
+                <a:latin typeface="Calibri" pitchFamily="34" charset="0"/>
+                <a:ea typeface="Calibri" pitchFamily="34" charset="-122"/>
+                <a:cs typeface="Calibri" pitchFamily="34" charset="-120"/>
+              </a:rPr>
+              <a:t>BuilderWith</a:t>
+            </a:r>
+            <a:r>
+              <a:rPr lang="en-US" sz="1250" dirty="0">
+                <a:solidFill>
+                  <a:srgbClr val="FFFFFF"/>
+                </a:solidFill>
+                <a:latin typeface="Calibri" pitchFamily="34" charset="0"/>
+                <a:ea typeface="Calibri" pitchFamily="34" charset="-122"/>
+                <a:cs typeface="Calibri" pitchFamily="34" charset="-120"/>
+              </a:rPr>
+              <a:t>()</a:t>
             </a:r>
             <a:endParaRPr lang="en-US" sz="1600" dirty="0"/>
           </a:p>
@@ -2844,7 +2899,7 @@
         </p:nvSpPr>
         <p:spPr>
           <a:xfrm>
-            <a:off x="201168" y="3803904"/>
+            <a:off x="201168" y="3789156"/>
             <a:ext cx="3218688" cy="658368"/>
           </a:xfrm>
           <a:prstGeom prst="rect">
@@ -6985,9 +7040,7 @@
             <a:srgbClr val="C00000"/>
           </a:solidFill>
           <a:ln w="9525">
-            <a:solidFill>
-              <a:srgbClr val="312E81"/>
-            </a:solidFill>
+            <a:noFill/>
             <a:prstDash val="solid"/>
           </a:ln>
         </p:spPr>
@@ -7344,9 +7397,7 @@
             <a:srgbClr val="C00000"/>
           </a:solidFill>
           <a:ln w="9525">
-            <a:solidFill>
-              <a:srgbClr val="312E81"/>
-            </a:solidFill>
+            <a:noFill/>
             <a:prstDash val="solid"/>
           </a:ln>
         </p:spPr>
@@ -7576,10 +7627,7 @@
               <a:buNone/>
             </a:pPr>
             <a:r>
-              <a:rPr lang="en-US" sz="1150" b="1" dirty="0">
-                <a:solidFill>
-                  <a:srgbClr val="312E81"/>
-                </a:solidFill>
+              <a:rPr lang="en-US" sz="1150" dirty="0">
                 <a:latin typeface="Calibri" pitchFamily="34" charset="0"/>
                 <a:ea typeface="Calibri" pitchFamily="34" charset="-122"/>
                 <a:cs typeface="Calibri" pitchFamily="34" charset="-120"/>
@@ -7615,10 +7663,7 @@
               <a:buNone/>
             </a:pPr>
             <a:r>
-              <a:rPr lang="en-US" sz="1150" b="1" dirty="0">
-                <a:solidFill>
-                  <a:srgbClr val="312E81"/>
-                </a:solidFill>
+              <a:rPr lang="en-US" sz="1150" dirty="0">
                 <a:latin typeface="Calibri" pitchFamily="34" charset="0"/>
                 <a:ea typeface="Calibri" pitchFamily="34" charset="-122"/>
                 <a:cs typeface="Calibri" pitchFamily="34" charset="-120"/>
@@ -7654,15 +7699,12 @@
               <a:buNone/>
             </a:pPr>
             <a:r>
-              <a:rPr lang="en-US" sz="1150" b="1" dirty="0">
-                <a:solidFill>
-                  <a:srgbClr val="312E81"/>
-                </a:solidFill>
-                <a:latin typeface="Calibri" pitchFamily="34" charset="0"/>
-                <a:ea typeface="Calibri" pitchFamily="34" charset="-122"/>
-                <a:cs typeface="Calibri" pitchFamily="34" charset="-120"/>
-              </a:rPr>
-              <a:t>- Stream closes cleanly (RUN_FINISHED sent)</a:t>
+              <a:rPr lang="en-US" sz="1150" dirty="0">
+                <a:latin typeface="Calibri" pitchFamily="34" charset="0"/>
+                <a:ea typeface="Calibri" pitchFamily="34" charset="-122"/>
+                <a:cs typeface="Calibri" pitchFamily="34" charset="-120"/>
+              </a:rPr>
+              <a:t>- Stream closes cleanly (RUN_ERROR sent)</a:t>
             </a:r>
             <a:endParaRPr lang="en-US" sz="1150" dirty="0"/>
           </a:p>
@@ -7693,10 +7735,7 @@
               <a:buNone/>
             </a:pPr>
             <a:r>
-              <a:rPr lang="en-US" sz="1150" b="1" dirty="0">
-                <a:solidFill>
-                  <a:srgbClr val="312E81"/>
-                </a:solidFill>
+              <a:rPr lang="en-US" sz="1150" dirty="0">
                 <a:latin typeface="Calibri" pitchFamily="34" charset="0"/>
                 <a:ea typeface="Calibri" pitchFamily="34" charset="-122"/>
                 <a:cs typeface="Calibri" pitchFamily="34" charset="-120"/>
@@ -11521,7 +11560,7 @@
                 <a:ea typeface="Calibri" pitchFamily="34" charset="-122"/>
                 <a:cs typeface="Calibri" pitchFamily="34" charset="-120"/>
               </a:rPr>
-              <a:t>Then we'll pull back the curtain and show how the demo now runs on the official .NET MAF v1 core package line.</a:t>
+              <a:t>Then we'll pull back the curtain; show how the demo now runs on the official .NET MAF 1.0.0 core package line.</a:t>
             </a:r>
             <a:endParaRPr lang="en-US" sz="1400" dirty="0"/>
           </a:p>

</xml_diff>